<commit_message>
docs(pitch): remplacer les GIF par des diapositives fixes successives
</commit_message>
<xml_diff>
--- a/docs/pitch/Club-des-Affaires-pitch.pptx
+++ b/docs/pitch/Club-des-Affaires-pitch.pptx
@@ -20,6 +20,17 @@
     <p:sldId id="268" r:id="rId20"/>
     <p:sldId id="269" r:id="rId21"/>
     <p:sldId id="270" r:id="rId22"/>
+    <p:sldId id="271" r:id="rId23"/>
+    <p:sldId id="272" r:id="rId24"/>
+    <p:sldId id="273" r:id="rId25"/>
+    <p:sldId id="274" r:id="rId26"/>
+    <p:sldId id="275" r:id="rId27"/>
+    <p:sldId id="276" r:id="rId28"/>
+    <p:sldId id="277" r:id="rId29"/>
+    <p:sldId id="278" r:id="rId30"/>
+    <p:sldId id="279" r:id="rId31"/>
+    <p:sldId id="280" r:id="rId32"/>
+    <p:sldId id="281" r:id="rId33"/>
   </p:sldIdLst>
   <p:sldSz cx="12192000" cy="6858000" type="screen4x3"/>
   <p:notesSz cx="6858000" cy="9144000"/>
@@ -586,7 +597,7 @@
           <a:lstStyle/>
           <a:p>
             <a:r>
-              <a:t>Annexe A2 : la faisabilité. L’application tourne aujourd’hui, en trois langues, avec une matrice d’accès testée et une administration guidée pour l’équipe.</a:t>
+              <a:t>(0:57–1:01) Ses coordonnées se débloquent.</a:t>
             </a:r>
           </a:p>
         </p:txBody>
@@ -656,7 +667,7 @@
           <a:lstStyle/>
           <a:p>
             <a:r>
-              <a:t>Annexe pour les questions : l'architecture.</a:t>
+              <a:t>(1:01–1:14) Son bingo coche une case : le jeu pousse à parler à de nouvelles personnes. Chaque rencontre fait aussi avancer le Club vers un palier collectif, avec une récompense valaisanne.</a:t>
             </a:r>
           </a:p>
         </p:txBody>
@@ -726,7 +737,7 @@
           <a:lstStyle/>
           <a:p>
             <a:r>
-              <a:t>Annexe : les algorithmes.</a:t>
+              <a:t>(1:14–1:19) Entre les soirées : annonces, relances et récapitulatif des nouveaux membres.</a:t>
             </a:r>
           </a:p>
         </p:txBody>
@@ -796,7 +807,7 @@
           <a:lstStyle/>
           <a:p>
             <a:r>
-              <a:t>Annexe : sécurité et protection des données.</a:t>
+              <a:t>(1:19–1:23) Le parrainage permet d’inviter une personne de confiance.</a:t>
             </a:r>
           </a:p>
         </p:txBody>
@@ -866,7 +877,7 @@
           <a:lstStyle/>
           <a:p>
             <a:r>
-              <a:t>Annexe : recruter en douceur, seulement les bonnes personnes.</a:t>
+              <a:t>(1:23–1:26) L’invité demande à rejoindre le Club.</a:t>
             </a:r>
           </a:p>
         </p:txBody>
@@ -936,7 +947,287 @@
           <a:lstStyle/>
           <a:p>
             <a:r>
-              <a:t>Annexe : coûts et feuille de route.</a:t>
+              <a:t>(1:26–1:32) L’équipe voit les membres, les rencontres et les personnes isolées.</a:t>
+            </a:r>
+          </a:p>
+        </p:txBody>
+      </p:sp>
+      <p:sp>
+        <p:nvSpPr>
+          <p:cNvPr id="4" name="Slide Number Placeholder 3"/>
+          <p:cNvSpPr>
+            <a:spLocks noGrp="1"/>
+          </p:cNvSpPr>
+          <p:nvPr>
+            <p:ph type="sldNum" idx="5" sz="quarter"/>
+          </p:nvPr>
+        </p:nvSpPr>
+        <p:spPr/>
+      </p:sp>
+    </p:spTree>
+  </p:cSld>
+  <p:clrMapOvr>
+    <a:masterClrMapping/>
+  </p:clrMapOvr>
+</p:notes>
+</file>
+
+<file path=ppt/notesSlides/notesSlide16.xml><?xml version="1.0" encoding="utf-8"?>
+<p:notes xmlns:a="http://schemas.openxmlformats.org/drawingml/2006/main" xmlns:p="http://schemas.openxmlformats.org/presentationml/2006/main" xmlns:r="http://schemas.openxmlformats.org/officeDocument/2006/relationships">
+  <p:cSld>
+    <p:spTree>
+      <p:nvGrpSpPr>
+        <p:cNvPr id="1" name=""/>
+        <p:cNvGrpSpPr/>
+        <p:nvPr/>
+      </p:nvGrpSpPr>
+      <p:grpSpPr>
+        <a:xfrm>
+          <a:off x="0" y="0"/>
+          <a:ext cx="0" cy="0"/>
+          <a:chOff x="0" y="0"/>
+          <a:chExt cx="0" cy="0"/>
+        </a:xfrm>
+      </p:grpSpPr>
+      <p:sp>
+        <p:nvSpPr>
+          <p:cNvPr id="2" name="Slide Image Placeholder 1"/>
+          <p:cNvSpPr>
+            <a:spLocks noGrp="1"/>
+          </p:cNvSpPr>
+          <p:nvPr>
+            <p:ph type="sldImg" idx="2"/>
+          </p:nvPr>
+        </p:nvSpPr>
+        <p:spPr/>
+      </p:sp>
+      <p:sp>
+        <p:nvSpPr>
+          <p:cNvPr id="3" name="Notes Placeholder 2"/>
+          <p:cNvSpPr>
+            <a:spLocks noGrp="1"/>
+          </p:cNvSpPr>
+          <p:nvPr>
+            <p:ph type="body" idx="3" sz="quarter"/>
+          </p:nvPr>
+        </p:nvSpPr>
+        <p:spPr/>
+        <p:txBody>
+          <a:bodyPr/>
+          <a:lstStyle/>
+          <a:p>
+            <a:r>
+              <a:t>(1:32–1:37) Elle prépare les soirées, génère les badges et les tables tournantes.</a:t>
+            </a:r>
+          </a:p>
+        </p:txBody>
+      </p:sp>
+      <p:sp>
+        <p:nvSpPr>
+          <p:cNvPr id="4" name="Slide Number Placeholder 3"/>
+          <p:cNvSpPr>
+            <a:spLocks noGrp="1"/>
+          </p:cNvSpPr>
+          <p:nvPr>
+            <p:ph type="sldNum" idx="5" sz="quarter"/>
+          </p:nvPr>
+        </p:nvSpPr>
+        <p:spPr/>
+      </p:sp>
+    </p:spTree>
+  </p:cSld>
+  <p:clrMapOvr>
+    <a:masterClrMapping/>
+  </p:clrMapOvr>
+</p:notes>
+</file>
+
+<file path=ppt/notesSlides/notesSlide17.xml><?xml version="1.0" encoding="utf-8"?>
+<p:notes xmlns:a="http://schemas.openxmlformats.org/drawingml/2006/main" xmlns:p="http://schemas.openxmlformats.org/presentationml/2006/main" xmlns:r="http://schemas.openxmlformats.org/officeDocument/2006/relationships">
+  <p:cSld>
+    <p:spTree>
+      <p:nvGrpSpPr>
+        <p:cNvPr id="1" name=""/>
+        <p:cNvGrpSpPr/>
+        <p:nvPr/>
+      </p:nvGrpSpPr>
+      <p:grpSpPr>
+        <a:xfrm>
+          <a:off x="0" y="0"/>
+          <a:ext cx="0" cy="0"/>
+          <a:chOff x="0" y="0"/>
+          <a:chExt cx="0" cy="0"/>
+        </a:xfrm>
+      </p:grpSpPr>
+      <p:sp>
+        <p:nvSpPr>
+          <p:cNvPr id="2" name="Slide Image Placeholder 1"/>
+          <p:cNvSpPr>
+            <a:spLocks noGrp="1"/>
+          </p:cNvSpPr>
+          <p:nvPr>
+            <p:ph type="sldImg" idx="2"/>
+          </p:nvPr>
+        </p:nvSpPr>
+        <p:spPr/>
+      </p:sp>
+      <p:sp>
+        <p:nvSpPr>
+          <p:cNvPr id="3" name="Notes Placeholder 2"/>
+          <p:cNvSpPr>
+            <a:spLocks noGrp="1"/>
+          </p:cNvSpPr>
+          <p:nvPr>
+            <p:ph type="body" idx="3" sz="quarter"/>
+          </p:nvPr>
+        </p:nvSpPr>
+        <p:spPr/>
+        <p:txBody>
+          <a:bodyPr/>
+          <a:lstStyle/>
+          <a:p>
+            <a:r>
+              <a:t>(1:37–1:44) Ici, trente-huit invités sont mélangés sur trois services.</a:t>
+            </a:r>
+          </a:p>
+        </p:txBody>
+      </p:sp>
+      <p:sp>
+        <p:nvSpPr>
+          <p:cNvPr id="4" name="Slide Number Placeholder 3"/>
+          <p:cNvSpPr>
+            <a:spLocks noGrp="1"/>
+          </p:cNvSpPr>
+          <p:nvPr>
+            <p:ph type="sldNum" idx="5" sz="quarter"/>
+          </p:nvPr>
+        </p:nvSpPr>
+        <p:spPr/>
+      </p:sp>
+    </p:spTree>
+  </p:cSld>
+  <p:clrMapOvr>
+    <a:masterClrMapping/>
+  </p:clrMapOvr>
+</p:notes>
+</file>
+
+<file path=ppt/notesSlides/notesSlide18.xml><?xml version="1.0" encoding="utf-8"?>
+<p:notes xmlns:a="http://schemas.openxmlformats.org/drawingml/2006/main" xmlns:p="http://schemas.openxmlformats.org/presentationml/2006/main" xmlns:r="http://schemas.openxmlformats.org/officeDocument/2006/relationships">
+  <p:cSld>
+    <p:spTree>
+      <p:nvGrpSpPr>
+        <p:cNvPr id="1" name=""/>
+        <p:cNvGrpSpPr/>
+        <p:nvPr/>
+      </p:nvGrpSpPr>
+      <p:grpSpPr>
+        <a:xfrm>
+          <a:off x="0" y="0"/>
+          <a:ext cx="0" cy="0"/>
+          <a:chOff x="0" y="0"/>
+          <a:chExt cx="0" cy="0"/>
+        </a:xfrm>
+      </p:grpSpPr>
+      <p:sp>
+        <p:nvSpPr>
+          <p:cNvPr id="2" name="Slide Image Placeholder 1"/>
+          <p:cNvSpPr>
+            <a:spLocks noGrp="1"/>
+          </p:cNvSpPr>
+          <p:nvPr>
+            <p:ph type="sldImg" idx="2"/>
+          </p:nvPr>
+        </p:nvSpPr>
+        <p:spPr/>
+      </p:sp>
+      <p:sp>
+        <p:nvSpPr>
+          <p:cNvPr id="3" name="Notes Placeholder 2"/>
+          <p:cNvSpPr>
+            <a:spLocks noGrp="1"/>
+          </p:cNvSpPr>
+          <p:nvPr>
+            <p:ph type="body" idx="3" sz="quarter"/>
+          </p:nvPr>
+        </p:nvSpPr>
+        <p:spPr/>
+        <p:txBody>
+          <a:bodyPr/>
+          <a:lstStyle/>
+          <a:p>
+            <a:r>
+              <a:t>(1:44–1:58) Pour lancer : hébergement suisse, import des membres, activation des emails. Environ trente francs par mois, hors développement. Un club qui se connaît se retrouve. Merci.</a:t>
+            </a:r>
+          </a:p>
+        </p:txBody>
+      </p:sp>
+      <p:sp>
+        <p:nvSpPr>
+          <p:cNvPr id="4" name="Slide Number Placeholder 3"/>
+          <p:cNvSpPr>
+            <a:spLocks noGrp="1"/>
+          </p:cNvSpPr>
+          <p:nvPr>
+            <p:ph type="sldNum" idx="5" sz="quarter"/>
+          </p:nvPr>
+        </p:nvSpPr>
+        <p:spPr/>
+      </p:sp>
+    </p:spTree>
+  </p:cSld>
+  <p:clrMapOvr>
+    <a:masterClrMapping/>
+  </p:clrMapOvr>
+</p:notes>
+</file>
+
+<file path=ppt/notesSlides/notesSlide19.xml><?xml version="1.0" encoding="utf-8"?>
+<p:notes xmlns:a="http://schemas.openxmlformats.org/drawingml/2006/main" xmlns:p="http://schemas.openxmlformats.org/presentationml/2006/main" xmlns:r="http://schemas.openxmlformats.org/officeDocument/2006/relationships">
+  <p:cSld>
+    <p:spTree>
+      <p:nvGrpSpPr>
+        <p:cNvPr id="1" name=""/>
+        <p:cNvGrpSpPr/>
+        <p:nvPr/>
+      </p:nvGrpSpPr>
+      <p:grpSpPr>
+        <a:xfrm>
+          <a:off x="0" y="0"/>
+          <a:ext cx="0" cy="0"/>
+          <a:chOff x="0" y="0"/>
+          <a:chExt cx="0" cy="0"/>
+        </a:xfrm>
+      </p:grpSpPr>
+      <p:sp>
+        <p:nvSpPr>
+          <p:cNvPr id="2" name="Slide Image Placeholder 1"/>
+          <p:cNvSpPr>
+            <a:spLocks noGrp="1"/>
+          </p:cNvSpPr>
+          <p:nvPr>
+            <p:ph type="sldImg" idx="2"/>
+          </p:nvPr>
+        </p:nvSpPr>
+        <p:spPr/>
+      </p:sp>
+      <p:sp>
+        <p:nvSpPr>
+          <p:cNvPr id="3" name="Notes Placeholder 2"/>
+          <p:cNvSpPr>
+            <a:spLocks noGrp="1"/>
+          </p:cNvSpPr>
+          <p:nvPr>
+            <p:ph type="body" idx="3" sz="quarter"/>
+          </p:nvPr>
+        </p:nvSpPr>
+        <p:spPr/>
+        <p:txBody>
+          <a:bodyPr/>
+          <a:lstStyle/>
+          <a:p>
+            <a:r>
+              <a:t>Fin du pitch. Les sept annexes suivantes servent seulement aux questions, et ne font pas partie des deux minutes.</a:t>
             </a:r>
           </a:p>
         </p:txBody>
@@ -1031,6 +1322,496 @@
 </p:notes>
 </file>
 
+<file path=ppt/notesSlides/notesSlide20.xml><?xml version="1.0" encoding="utf-8"?>
+<p:notes xmlns:a="http://schemas.openxmlformats.org/drawingml/2006/main" xmlns:p="http://schemas.openxmlformats.org/presentationml/2006/main" xmlns:r="http://schemas.openxmlformats.org/officeDocument/2006/relationships">
+  <p:cSld>
+    <p:spTree>
+      <p:nvGrpSpPr>
+        <p:cNvPr id="1" name=""/>
+        <p:cNvGrpSpPr/>
+        <p:nvPr/>
+      </p:nvGrpSpPr>
+      <p:grpSpPr>
+        <a:xfrm>
+          <a:off x="0" y="0"/>
+          <a:ext cx="0" cy="0"/>
+          <a:chOff x="0" y="0"/>
+          <a:chExt cx="0" cy="0"/>
+        </a:xfrm>
+      </p:grpSpPr>
+      <p:sp>
+        <p:nvSpPr>
+          <p:cNvPr id="2" name="Slide Image Placeholder 1"/>
+          <p:cNvSpPr>
+            <a:spLocks noGrp="1"/>
+          </p:cNvSpPr>
+          <p:nvPr>
+            <p:ph type="sldImg" idx="2"/>
+          </p:nvPr>
+        </p:nvSpPr>
+        <p:spPr/>
+      </p:sp>
+      <p:sp>
+        <p:nvSpPr>
+          <p:cNvPr id="3" name="Notes Placeholder 2"/>
+          <p:cNvSpPr>
+            <a:spLocks noGrp="1"/>
+          </p:cNvSpPr>
+          <p:nvPr>
+            <p:ph type="body" idx="3" sz="quarter"/>
+          </p:nvPr>
+        </p:nvSpPr>
+        <p:spPr/>
+        <p:txBody>
+          <a:bodyPr/>
+          <a:lstStyle/>
+          <a:p>
+            <a:r>
+              <a:t>Annexe A1 : Ce qui est nouveau : chaque vraie rencontre compte, et se compte. Le Club est connecté à 15 % aujourd'hui ; au prochain palier, une tournée de Petite Arvine pour tous. Mesurable pour le comité, motivant pour les membres.</a:t>
+            </a:r>
+          </a:p>
+        </p:txBody>
+      </p:sp>
+      <p:sp>
+        <p:nvSpPr>
+          <p:cNvPr id="4" name="Slide Number Placeholder 3"/>
+          <p:cNvSpPr>
+            <a:spLocks noGrp="1"/>
+          </p:cNvSpPr>
+          <p:nvPr>
+            <p:ph type="sldNum" idx="5" sz="quarter"/>
+          </p:nvPr>
+        </p:nvSpPr>
+        <p:spPr/>
+      </p:sp>
+    </p:spTree>
+  </p:cSld>
+  <p:clrMapOvr>
+    <a:masterClrMapping/>
+  </p:clrMapOvr>
+</p:notes>
+</file>
+
+<file path=ppt/notesSlides/notesSlide21.xml><?xml version="1.0" encoding="utf-8"?>
+<p:notes xmlns:a="http://schemas.openxmlformats.org/drawingml/2006/main" xmlns:p="http://schemas.openxmlformats.org/presentationml/2006/main" xmlns:r="http://schemas.openxmlformats.org/officeDocument/2006/relationships">
+  <p:cSld>
+    <p:spTree>
+      <p:nvGrpSpPr>
+        <p:cNvPr id="1" name=""/>
+        <p:cNvGrpSpPr/>
+        <p:nvPr/>
+      </p:nvGrpSpPr>
+      <p:grpSpPr>
+        <a:xfrm>
+          <a:off x="0" y="0"/>
+          <a:ext cx="0" cy="0"/>
+          <a:chOff x="0" y="0"/>
+          <a:chExt cx="0" cy="0"/>
+        </a:xfrm>
+      </p:grpSpPr>
+      <p:sp>
+        <p:nvSpPr>
+          <p:cNvPr id="2" name="Slide Image Placeholder 1"/>
+          <p:cNvSpPr>
+            <a:spLocks noGrp="1"/>
+          </p:cNvSpPr>
+          <p:nvPr>
+            <p:ph type="sldImg" idx="2"/>
+          </p:nvPr>
+        </p:nvSpPr>
+        <p:spPr/>
+      </p:sp>
+      <p:sp>
+        <p:nvSpPr>
+          <p:cNvPr id="3" name="Notes Placeholder 2"/>
+          <p:cNvSpPr>
+            <a:spLocks noGrp="1"/>
+          </p:cNvSpPr>
+          <p:nvPr>
+            <p:ph type="body" idx="3" sz="quarter"/>
+          </p:nvPr>
+        </p:nvSpPr>
+        <p:spPr/>
+        <p:txBody>
+          <a:bodyPr/>
+          <a:lstStyle/>
+          <a:p>
+            <a:r>
+              <a:t>Annexe A2 : la faisabilité. L’application tourne aujourd’hui, en trois langues, avec une matrice d’accès testée et une administration guidée pour l’équipe.</a:t>
+            </a:r>
+          </a:p>
+        </p:txBody>
+      </p:sp>
+      <p:sp>
+        <p:nvSpPr>
+          <p:cNvPr id="4" name="Slide Number Placeholder 3"/>
+          <p:cNvSpPr>
+            <a:spLocks noGrp="1"/>
+          </p:cNvSpPr>
+          <p:nvPr>
+            <p:ph type="sldNum" idx="5" sz="quarter"/>
+          </p:nvPr>
+        </p:nvSpPr>
+        <p:spPr/>
+      </p:sp>
+    </p:spTree>
+  </p:cSld>
+  <p:clrMapOvr>
+    <a:masterClrMapping/>
+  </p:clrMapOvr>
+</p:notes>
+</file>
+
+<file path=ppt/notesSlides/notesSlide22.xml><?xml version="1.0" encoding="utf-8"?>
+<p:notes xmlns:a="http://schemas.openxmlformats.org/drawingml/2006/main" xmlns:p="http://schemas.openxmlformats.org/presentationml/2006/main" xmlns:r="http://schemas.openxmlformats.org/officeDocument/2006/relationships">
+  <p:cSld>
+    <p:spTree>
+      <p:nvGrpSpPr>
+        <p:cNvPr id="1" name=""/>
+        <p:cNvGrpSpPr/>
+        <p:nvPr/>
+      </p:nvGrpSpPr>
+      <p:grpSpPr>
+        <a:xfrm>
+          <a:off x="0" y="0"/>
+          <a:ext cx="0" cy="0"/>
+          <a:chOff x="0" y="0"/>
+          <a:chExt cx="0" cy="0"/>
+        </a:xfrm>
+      </p:grpSpPr>
+      <p:sp>
+        <p:nvSpPr>
+          <p:cNvPr id="2" name="Slide Image Placeholder 1"/>
+          <p:cNvSpPr>
+            <a:spLocks noGrp="1"/>
+          </p:cNvSpPr>
+          <p:nvPr>
+            <p:ph type="sldImg" idx="2"/>
+          </p:nvPr>
+        </p:nvSpPr>
+        <p:spPr/>
+      </p:sp>
+      <p:sp>
+        <p:nvSpPr>
+          <p:cNvPr id="3" name="Notes Placeholder 2"/>
+          <p:cNvSpPr>
+            <a:spLocks noGrp="1"/>
+          </p:cNvSpPr>
+          <p:nvPr>
+            <p:ph type="body" idx="3" sz="quarter"/>
+          </p:nvPr>
+        </p:nvSpPr>
+        <p:spPr/>
+        <p:txBody>
+          <a:bodyPr/>
+          <a:lstStyle/>
+          <a:p>
+            <a:r>
+              <a:t>Annexe pour les questions : l'architecture.</a:t>
+            </a:r>
+          </a:p>
+        </p:txBody>
+      </p:sp>
+      <p:sp>
+        <p:nvSpPr>
+          <p:cNvPr id="4" name="Slide Number Placeholder 3"/>
+          <p:cNvSpPr>
+            <a:spLocks noGrp="1"/>
+          </p:cNvSpPr>
+          <p:nvPr>
+            <p:ph type="sldNum" idx="5" sz="quarter"/>
+          </p:nvPr>
+        </p:nvSpPr>
+        <p:spPr/>
+      </p:sp>
+    </p:spTree>
+  </p:cSld>
+  <p:clrMapOvr>
+    <a:masterClrMapping/>
+  </p:clrMapOvr>
+</p:notes>
+</file>
+
+<file path=ppt/notesSlides/notesSlide23.xml><?xml version="1.0" encoding="utf-8"?>
+<p:notes xmlns:a="http://schemas.openxmlformats.org/drawingml/2006/main" xmlns:p="http://schemas.openxmlformats.org/presentationml/2006/main" xmlns:r="http://schemas.openxmlformats.org/officeDocument/2006/relationships">
+  <p:cSld>
+    <p:spTree>
+      <p:nvGrpSpPr>
+        <p:cNvPr id="1" name=""/>
+        <p:cNvGrpSpPr/>
+        <p:nvPr/>
+      </p:nvGrpSpPr>
+      <p:grpSpPr>
+        <a:xfrm>
+          <a:off x="0" y="0"/>
+          <a:ext cx="0" cy="0"/>
+          <a:chOff x="0" y="0"/>
+          <a:chExt cx="0" cy="0"/>
+        </a:xfrm>
+      </p:grpSpPr>
+      <p:sp>
+        <p:nvSpPr>
+          <p:cNvPr id="2" name="Slide Image Placeholder 1"/>
+          <p:cNvSpPr>
+            <a:spLocks noGrp="1"/>
+          </p:cNvSpPr>
+          <p:nvPr>
+            <p:ph type="sldImg" idx="2"/>
+          </p:nvPr>
+        </p:nvSpPr>
+        <p:spPr/>
+      </p:sp>
+      <p:sp>
+        <p:nvSpPr>
+          <p:cNvPr id="3" name="Notes Placeholder 2"/>
+          <p:cNvSpPr>
+            <a:spLocks noGrp="1"/>
+          </p:cNvSpPr>
+          <p:nvPr>
+            <p:ph type="body" idx="3" sz="quarter"/>
+          </p:nvPr>
+        </p:nvSpPr>
+        <p:spPr/>
+        <p:txBody>
+          <a:bodyPr/>
+          <a:lstStyle/>
+          <a:p>
+            <a:r>
+              <a:t>Annexe : les algorithmes.</a:t>
+            </a:r>
+          </a:p>
+        </p:txBody>
+      </p:sp>
+      <p:sp>
+        <p:nvSpPr>
+          <p:cNvPr id="4" name="Slide Number Placeholder 3"/>
+          <p:cNvSpPr>
+            <a:spLocks noGrp="1"/>
+          </p:cNvSpPr>
+          <p:nvPr>
+            <p:ph type="sldNum" idx="5" sz="quarter"/>
+          </p:nvPr>
+        </p:nvSpPr>
+        <p:spPr/>
+      </p:sp>
+    </p:spTree>
+  </p:cSld>
+  <p:clrMapOvr>
+    <a:masterClrMapping/>
+  </p:clrMapOvr>
+</p:notes>
+</file>
+
+<file path=ppt/notesSlides/notesSlide24.xml><?xml version="1.0" encoding="utf-8"?>
+<p:notes xmlns:a="http://schemas.openxmlformats.org/drawingml/2006/main" xmlns:p="http://schemas.openxmlformats.org/presentationml/2006/main" xmlns:r="http://schemas.openxmlformats.org/officeDocument/2006/relationships">
+  <p:cSld>
+    <p:spTree>
+      <p:nvGrpSpPr>
+        <p:cNvPr id="1" name=""/>
+        <p:cNvGrpSpPr/>
+        <p:nvPr/>
+      </p:nvGrpSpPr>
+      <p:grpSpPr>
+        <a:xfrm>
+          <a:off x="0" y="0"/>
+          <a:ext cx="0" cy="0"/>
+          <a:chOff x="0" y="0"/>
+          <a:chExt cx="0" cy="0"/>
+        </a:xfrm>
+      </p:grpSpPr>
+      <p:sp>
+        <p:nvSpPr>
+          <p:cNvPr id="2" name="Slide Image Placeholder 1"/>
+          <p:cNvSpPr>
+            <a:spLocks noGrp="1"/>
+          </p:cNvSpPr>
+          <p:nvPr>
+            <p:ph type="sldImg" idx="2"/>
+          </p:nvPr>
+        </p:nvSpPr>
+        <p:spPr/>
+      </p:sp>
+      <p:sp>
+        <p:nvSpPr>
+          <p:cNvPr id="3" name="Notes Placeholder 2"/>
+          <p:cNvSpPr>
+            <a:spLocks noGrp="1"/>
+          </p:cNvSpPr>
+          <p:nvPr>
+            <p:ph type="body" idx="3" sz="quarter"/>
+          </p:nvPr>
+        </p:nvSpPr>
+        <p:spPr/>
+        <p:txBody>
+          <a:bodyPr/>
+          <a:lstStyle/>
+          <a:p>
+            <a:r>
+              <a:t>Annexe : sécurité et protection des données.</a:t>
+            </a:r>
+          </a:p>
+        </p:txBody>
+      </p:sp>
+      <p:sp>
+        <p:nvSpPr>
+          <p:cNvPr id="4" name="Slide Number Placeholder 3"/>
+          <p:cNvSpPr>
+            <a:spLocks noGrp="1"/>
+          </p:cNvSpPr>
+          <p:nvPr>
+            <p:ph type="sldNum" idx="5" sz="quarter"/>
+          </p:nvPr>
+        </p:nvSpPr>
+        <p:spPr/>
+      </p:sp>
+    </p:spTree>
+  </p:cSld>
+  <p:clrMapOvr>
+    <a:masterClrMapping/>
+  </p:clrMapOvr>
+</p:notes>
+</file>
+
+<file path=ppt/notesSlides/notesSlide25.xml><?xml version="1.0" encoding="utf-8"?>
+<p:notes xmlns:a="http://schemas.openxmlformats.org/drawingml/2006/main" xmlns:p="http://schemas.openxmlformats.org/presentationml/2006/main" xmlns:r="http://schemas.openxmlformats.org/officeDocument/2006/relationships">
+  <p:cSld>
+    <p:spTree>
+      <p:nvGrpSpPr>
+        <p:cNvPr id="1" name=""/>
+        <p:cNvGrpSpPr/>
+        <p:nvPr/>
+      </p:nvGrpSpPr>
+      <p:grpSpPr>
+        <a:xfrm>
+          <a:off x="0" y="0"/>
+          <a:ext cx="0" cy="0"/>
+          <a:chOff x="0" y="0"/>
+          <a:chExt cx="0" cy="0"/>
+        </a:xfrm>
+      </p:grpSpPr>
+      <p:sp>
+        <p:nvSpPr>
+          <p:cNvPr id="2" name="Slide Image Placeholder 1"/>
+          <p:cNvSpPr>
+            <a:spLocks noGrp="1"/>
+          </p:cNvSpPr>
+          <p:nvPr>
+            <p:ph type="sldImg" idx="2"/>
+          </p:nvPr>
+        </p:nvSpPr>
+        <p:spPr/>
+      </p:sp>
+      <p:sp>
+        <p:nvSpPr>
+          <p:cNvPr id="3" name="Notes Placeholder 2"/>
+          <p:cNvSpPr>
+            <a:spLocks noGrp="1"/>
+          </p:cNvSpPr>
+          <p:nvPr>
+            <p:ph type="body" idx="3" sz="quarter"/>
+          </p:nvPr>
+        </p:nvSpPr>
+        <p:spPr/>
+        <p:txBody>
+          <a:bodyPr/>
+          <a:lstStyle/>
+          <a:p>
+            <a:r>
+              <a:t>Annexe : recruter en douceur, seulement les bonnes personnes.</a:t>
+            </a:r>
+          </a:p>
+        </p:txBody>
+      </p:sp>
+      <p:sp>
+        <p:nvSpPr>
+          <p:cNvPr id="4" name="Slide Number Placeholder 3"/>
+          <p:cNvSpPr>
+            <a:spLocks noGrp="1"/>
+          </p:cNvSpPr>
+          <p:nvPr>
+            <p:ph type="sldNum" idx="5" sz="quarter"/>
+          </p:nvPr>
+        </p:nvSpPr>
+        <p:spPr/>
+      </p:sp>
+    </p:spTree>
+  </p:cSld>
+  <p:clrMapOvr>
+    <a:masterClrMapping/>
+  </p:clrMapOvr>
+</p:notes>
+</file>
+
+<file path=ppt/notesSlides/notesSlide26.xml><?xml version="1.0" encoding="utf-8"?>
+<p:notes xmlns:a="http://schemas.openxmlformats.org/drawingml/2006/main" xmlns:p="http://schemas.openxmlformats.org/presentationml/2006/main" xmlns:r="http://schemas.openxmlformats.org/officeDocument/2006/relationships">
+  <p:cSld>
+    <p:spTree>
+      <p:nvGrpSpPr>
+        <p:cNvPr id="1" name=""/>
+        <p:cNvGrpSpPr/>
+        <p:nvPr/>
+      </p:nvGrpSpPr>
+      <p:grpSpPr>
+        <a:xfrm>
+          <a:off x="0" y="0"/>
+          <a:ext cx="0" cy="0"/>
+          <a:chOff x="0" y="0"/>
+          <a:chExt cx="0" cy="0"/>
+        </a:xfrm>
+      </p:grpSpPr>
+      <p:sp>
+        <p:nvSpPr>
+          <p:cNvPr id="2" name="Slide Image Placeholder 1"/>
+          <p:cNvSpPr>
+            <a:spLocks noGrp="1"/>
+          </p:cNvSpPr>
+          <p:nvPr>
+            <p:ph type="sldImg" idx="2"/>
+          </p:nvPr>
+        </p:nvSpPr>
+        <p:spPr/>
+      </p:sp>
+      <p:sp>
+        <p:nvSpPr>
+          <p:cNvPr id="3" name="Notes Placeholder 2"/>
+          <p:cNvSpPr>
+            <a:spLocks noGrp="1"/>
+          </p:cNvSpPr>
+          <p:nvPr>
+            <p:ph type="body" idx="3" sz="quarter"/>
+          </p:nvPr>
+        </p:nvSpPr>
+        <p:spPr/>
+        <p:txBody>
+          <a:bodyPr/>
+          <a:lstStyle/>
+          <a:p>
+            <a:r>
+              <a:t>Annexe : coûts et feuille de route.</a:t>
+            </a:r>
+          </a:p>
+        </p:txBody>
+      </p:sp>
+      <p:sp>
+        <p:nvSpPr>
+          <p:cNvPr id="4" name="Slide Number Placeholder 3"/>
+          <p:cNvSpPr>
+            <a:spLocks noGrp="1"/>
+          </p:cNvSpPr>
+          <p:nvPr>
+            <p:ph type="sldNum" idx="5" sz="quarter"/>
+          </p:nvPr>
+        </p:nvSpPr>
+        <p:spPr/>
+      </p:sp>
+    </p:spTree>
+  </p:cSld>
+  <p:clrMapOvr>
+    <a:masterClrMapping/>
+  </p:clrMapOvr>
+</p:notes>
+</file>
+
 <file path=ppt/notesSlides/notesSlide3.xml><?xml version="1.0" encoding="utf-8"?>
 <p:notes xmlns:a="http://schemas.openxmlformats.org/drawingml/2006/main" xmlns:p="http://schemas.openxmlformats.org/presentationml/2006/main" xmlns:r="http://schemas.openxmlformats.org/officeDocument/2006/relationships">
   <p:cSld>
@@ -1076,7 +1857,7 @@
           <a:lstStyle/>
           <a:p>
             <a:r>
-              <a:t>(0:24–0:46) Voici Camille. Rien à installer : elle se connecte et découvre l’album des membres. Avant le dîner, trois rencontres lui sont proposées, avec une raison. Lukas cherche du digital, son métier à elle ; il peut l’aider à découvrir le marché alémanique. Leurs passions donnent un premier sujet de conversation.</a:t>
+              <a:t>(0:24–0:28) Voici Camille. Elle se connecte, sans rien installer.</a:t>
             </a:r>
           </a:p>
         </p:txBody>
@@ -1146,7 +1927,7 @@
           <a:lstStyle/>
           <a:p>
             <a:r>
-              <a:t>(0:46–1:14) Le soir même, Lukas lui montre son QR code. Camille confirme leur rencontre : sa carte rejoint son album et ses coordonnées se débloquent. Son bingo coche une case : le jeu pousse à parler à de nouvelles personnes. Chaque rencontre fait aussi avancer le Club vers un palier collectif, avec une récompense valaisanne.</a:t>
+              <a:t>(0:28–0:32) Son accueil montre l’album et les paliers du Club.</a:t>
             </a:r>
           </a:p>
         </p:txBody>
@@ -1216,7 +1997,7 @@
           <a:lstStyle/>
           <a:p>
             <a:r>
-              <a:t>(1:14–1:26) Entre les soirées : annonces et relances ciblées, puis un récapitulatif mensuel des nouveaux membres. Le parrainage permet d’inviter une personne de confiance.</a:t>
+              <a:t>(0:32–0:35) Dans l’album, elle découvre les membres.</a:t>
             </a:r>
           </a:p>
         </p:txBody>
@@ -1286,7 +2067,7 @@
           <a:lstStyle/>
           <a:p>
             <a:r>
-              <a:t>(1:26–1:44) Pour l’équipe, ce tableau de bord montre les membres et les rencontres. Elle prépare les soirées, génère les badges et les tables tournantes. Ici, trente-huit invités sont mélangés sur trois services. Elle peut aussi repérer les membres isolés.</a:t>
+              <a:t>(0:35–0:46) Trois rencontres sont proposées, avec une raison : Lukas cherche du digital et peut l’aider sur le marché alémanique. Leurs passions lancent la conversation.</a:t>
             </a:r>
           </a:p>
         </p:txBody>
@@ -1356,7 +2137,7 @@
           <a:lstStyle/>
           <a:p>
             <a:r>
-              <a:t>(1:44–1:58) Pour lancer : hébergement suisse, import des membres, activation des emails. Environ trente francs par mois, hors développement. Un club qui se connaît se retrouve. Merci.</a:t>
+              <a:t>(0:46–0:50) Le soir même, Lukas lui montre son QR code.</a:t>
             </a:r>
           </a:p>
         </p:txBody>
@@ -1426,7 +2207,7 @@
           <a:lstStyle/>
           <a:p>
             <a:r>
-              <a:t>Fin du pitch. Les sept annexes suivantes servent seulement aux questions, et ne font pas partie des deux minutes.</a:t>
+              <a:t>(0:50–0:54) Camille confirme leur rencontre.</a:t>
             </a:r>
           </a:p>
         </p:txBody>
@@ -1496,7 +2277,7 @@
           <a:lstStyle/>
           <a:p>
             <a:r>
-              <a:t>Annexe A1 : Ce qui est nouveau : chaque vraie rencontre compte, et se compte. Le Club est connecté à 15 % aujourd'hui ; au prochain palier, une tournée de Petite Arvine pour tous. Mesurable pour le comité, motivant pour les membres.</a:t>
+              <a:t>(0:54–0:57) Sa carte rejoint son album.</a:t>
             </a:r>
           </a:p>
         </p:txBody>
@@ -4793,6 +5574,178 @@
 </p:sld>
 </file>
 
+<file path=ppt/slides/slide16.xml><?xml version="1.0" encoding="utf-8"?>
+<p:sld xmlns:a="http://schemas.openxmlformats.org/drawingml/2006/main" xmlns:p="http://schemas.openxmlformats.org/presentationml/2006/main" xmlns:r="http://schemas.openxmlformats.org/officeDocument/2006/relationships">
+  <p:cSld>
+    <p:spTree>
+      <p:nvGrpSpPr>
+        <p:cNvPr id="1" name=""/>
+        <p:cNvGrpSpPr/>
+        <p:nvPr/>
+      </p:nvGrpSpPr>
+      <p:grpSpPr/>
+      <p:pic>
+        <p:nvPicPr>
+          <p:cNvPr id="2" name="Picture 1" descr="slide-16.png"/>
+          <p:cNvPicPr>
+            <a:picLocks noChangeAspect="1"/>
+          </p:cNvPicPr>
+          <p:nvPr/>
+        </p:nvPicPr>
+        <p:blipFill>
+          <a:blip r:embed="rId2"/>
+          <a:stretch>
+            <a:fillRect/>
+          </a:stretch>
+        </p:blipFill>
+        <p:spPr>
+          <a:xfrm>
+            <a:off x="0" y="0"/>
+            <a:ext cx="12192000" cy="6858000"/>
+          </a:xfrm>
+          <a:prstGeom prst="rect">
+            <a:avLst/>
+          </a:prstGeom>
+        </p:spPr>
+      </p:pic>
+    </p:spTree>
+  </p:cSld>
+  <p:clrMapOvr>
+    <a:masterClrMapping/>
+  </p:clrMapOvr>
+  <p:transition advClick="1"/>
+</p:sld>
+</file>
+
+<file path=ppt/slides/slide17.xml><?xml version="1.0" encoding="utf-8"?>
+<p:sld xmlns:a="http://schemas.openxmlformats.org/drawingml/2006/main" xmlns:p="http://schemas.openxmlformats.org/presentationml/2006/main" xmlns:r="http://schemas.openxmlformats.org/officeDocument/2006/relationships">
+  <p:cSld>
+    <p:spTree>
+      <p:nvGrpSpPr>
+        <p:cNvPr id="1" name=""/>
+        <p:cNvGrpSpPr/>
+        <p:nvPr/>
+      </p:nvGrpSpPr>
+      <p:grpSpPr/>
+      <p:pic>
+        <p:nvPicPr>
+          <p:cNvPr id="2" name="Picture 1" descr="slide-17.png"/>
+          <p:cNvPicPr>
+            <a:picLocks noChangeAspect="1"/>
+          </p:cNvPicPr>
+          <p:nvPr/>
+        </p:nvPicPr>
+        <p:blipFill>
+          <a:blip r:embed="rId2"/>
+          <a:stretch>
+            <a:fillRect/>
+          </a:stretch>
+        </p:blipFill>
+        <p:spPr>
+          <a:xfrm>
+            <a:off x="0" y="0"/>
+            <a:ext cx="12192000" cy="6858000"/>
+          </a:xfrm>
+          <a:prstGeom prst="rect">
+            <a:avLst/>
+          </a:prstGeom>
+        </p:spPr>
+      </p:pic>
+    </p:spTree>
+  </p:cSld>
+  <p:clrMapOvr>
+    <a:masterClrMapping/>
+  </p:clrMapOvr>
+  <p:transition advClick="1"/>
+</p:sld>
+</file>
+
+<file path=ppt/slides/slide18.xml><?xml version="1.0" encoding="utf-8"?>
+<p:sld xmlns:a="http://schemas.openxmlformats.org/drawingml/2006/main" xmlns:p="http://schemas.openxmlformats.org/presentationml/2006/main" xmlns:r="http://schemas.openxmlformats.org/officeDocument/2006/relationships">
+  <p:cSld>
+    <p:spTree>
+      <p:nvGrpSpPr>
+        <p:cNvPr id="1" name=""/>
+        <p:cNvGrpSpPr/>
+        <p:nvPr/>
+      </p:nvGrpSpPr>
+      <p:grpSpPr/>
+      <p:pic>
+        <p:nvPicPr>
+          <p:cNvPr id="2" name="Picture 1" descr="slide-18.png"/>
+          <p:cNvPicPr>
+            <a:picLocks noChangeAspect="1"/>
+          </p:cNvPicPr>
+          <p:nvPr/>
+        </p:nvPicPr>
+        <p:blipFill>
+          <a:blip r:embed="rId2"/>
+          <a:stretch>
+            <a:fillRect/>
+          </a:stretch>
+        </p:blipFill>
+        <p:spPr>
+          <a:xfrm>
+            <a:off x="0" y="0"/>
+            <a:ext cx="12192000" cy="6858000"/>
+          </a:xfrm>
+          <a:prstGeom prst="rect">
+            <a:avLst/>
+          </a:prstGeom>
+        </p:spPr>
+      </p:pic>
+    </p:spTree>
+  </p:cSld>
+  <p:clrMapOvr>
+    <a:masterClrMapping/>
+  </p:clrMapOvr>
+  <p:transition advClick="1"/>
+</p:sld>
+</file>
+
+<file path=ppt/slides/slide19.xml><?xml version="1.0" encoding="utf-8"?>
+<p:sld xmlns:a="http://schemas.openxmlformats.org/drawingml/2006/main" xmlns:p="http://schemas.openxmlformats.org/presentationml/2006/main" xmlns:r="http://schemas.openxmlformats.org/officeDocument/2006/relationships">
+  <p:cSld>
+    <p:spTree>
+      <p:nvGrpSpPr>
+        <p:cNvPr id="1" name=""/>
+        <p:cNvGrpSpPr/>
+        <p:nvPr/>
+      </p:nvGrpSpPr>
+      <p:grpSpPr/>
+      <p:pic>
+        <p:nvPicPr>
+          <p:cNvPr id="2" name="Picture 1" descr="slide-19.png"/>
+          <p:cNvPicPr>
+            <a:picLocks noChangeAspect="1"/>
+          </p:cNvPicPr>
+          <p:nvPr/>
+        </p:nvPicPr>
+        <p:blipFill>
+          <a:blip r:embed="rId2"/>
+          <a:stretch>
+            <a:fillRect/>
+          </a:stretch>
+        </p:blipFill>
+        <p:spPr>
+          <a:xfrm>
+            <a:off x="0" y="0"/>
+            <a:ext cx="12192000" cy="6858000"/>
+          </a:xfrm>
+          <a:prstGeom prst="rect">
+            <a:avLst/>
+          </a:prstGeom>
+        </p:spPr>
+      </p:pic>
+    </p:spTree>
+  </p:cSld>
+  <p:clrMapOvr>
+    <a:masterClrMapping/>
+  </p:clrMapOvr>
+  <p:transition advClick="1"/>
+</p:sld>
+</file>
+
 <file path=ppt/slides/slide2.xml><?xml version="1.0" encoding="utf-8"?>
 <p:sld xmlns:a="http://schemas.openxmlformats.org/drawingml/2006/main" xmlns:p="http://schemas.openxmlformats.org/presentationml/2006/main" xmlns:r="http://schemas.openxmlformats.org/officeDocument/2006/relationships">
   <p:cSld>
@@ -4806,6 +5759,307 @@
       <p:pic>
         <p:nvPicPr>
           <p:cNvPr id="2" name="Picture 1" descr="slide-02.png"/>
+          <p:cNvPicPr>
+            <a:picLocks noChangeAspect="1"/>
+          </p:cNvPicPr>
+          <p:nvPr/>
+        </p:nvPicPr>
+        <p:blipFill>
+          <a:blip r:embed="rId2"/>
+          <a:stretch>
+            <a:fillRect/>
+          </a:stretch>
+        </p:blipFill>
+        <p:spPr>
+          <a:xfrm>
+            <a:off x="0" y="0"/>
+            <a:ext cx="12192000" cy="6858000"/>
+          </a:xfrm>
+          <a:prstGeom prst="rect">
+            <a:avLst/>
+          </a:prstGeom>
+        </p:spPr>
+      </p:pic>
+    </p:spTree>
+  </p:cSld>
+  <p:clrMapOvr>
+    <a:masterClrMapping/>
+  </p:clrMapOvr>
+  <p:transition advClick="1"/>
+</p:sld>
+</file>
+
+<file path=ppt/slides/slide20.xml><?xml version="1.0" encoding="utf-8"?>
+<p:sld xmlns:a="http://schemas.openxmlformats.org/drawingml/2006/main" xmlns:p="http://schemas.openxmlformats.org/presentationml/2006/main" xmlns:r="http://schemas.openxmlformats.org/officeDocument/2006/relationships">
+  <p:cSld>
+    <p:spTree>
+      <p:nvGrpSpPr>
+        <p:cNvPr id="1" name=""/>
+        <p:cNvGrpSpPr/>
+        <p:nvPr/>
+      </p:nvGrpSpPr>
+      <p:grpSpPr/>
+      <p:pic>
+        <p:nvPicPr>
+          <p:cNvPr id="2" name="Picture 1" descr="slide-20.png"/>
+          <p:cNvPicPr>
+            <a:picLocks noChangeAspect="1"/>
+          </p:cNvPicPr>
+          <p:nvPr/>
+        </p:nvPicPr>
+        <p:blipFill>
+          <a:blip r:embed="rId2"/>
+          <a:stretch>
+            <a:fillRect/>
+          </a:stretch>
+        </p:blipFill>
+        <p:spPr>
+          <a:xfrm>
+            <a:off x="0" y="0"/>
+            <a:ext cx="12192000" cy="6858000"/>
+          </a:xfrm>
+          <a:prstGeom prst="rect">
+            <a:avLst/>
+          </a:prstGeom>
+        </p:spPr>
+      </p:pic>
+    </p:spTree>
+  </p:cSld>
+  <p:clrMapOvr>
+    <a:masterClrMapping/>
+  </p:clrMapOvr>
+  <p:transition advClick="1"/>
+</p:sld>
+</file>
+
+<file path=ppt/slides/slide21.xml><?xml version="1.0" encoding="utf-8"?>
+<p:sld xmlns:a="http://schemas.openxmlformats.org/drawingml/2006/main" xmlns:p="http://schemas.openxmlformats.org/presentationml/2006/main" xmlns:r="http://schemas.openxmlformats.org/officeDocument/2006/relationships">
+  <p:cSld>
+    <p:spTree>
+      <p:nvGrpSpPr>
+        <p:cNvPr id="1" name=""/>
+        <p:cNvGrpSpPr/>
+        <p:nvPr/>
+      </p:nvGrpSpPr>
+      <p:grpSpPr/>
+      <p:pic>
+        <p:nvPicPr>
+          <p:cNvPr id="2" name="Picture 1" descr="slide-21.png"/>
+          <p:cNvPicPr>
+            <a:picLocks noChangeAspect="1"/>
+          </p:cNvPicPr>
+          <p:nvPr/>
+        </p:nvPicPr>
+        <p:blipFill>
+          <a:blip r:embed="rId2"/>
+          <a:stretch>
+            <a:fillRect/>
+          </a:stretch>
+        </p:blipFill>
+        <p:spPr>
+          <a:xfrm>
+            <a:off x="0" y="0"/>
+            <a:ext cx="12192000" cy="6858000"/>
+          </a:xfrm>
+          <a:prstGeom prst="rect">
+            <a:avLst/>
+          </a:prstGeom>
+        </p:spPr>
+      </p:pic>
+    </p:spTree>
+  </p:cSld>
+  <p:clrMapOvr>
+    <a:masterClrMapping/>
+  </p:clrMapOvr>
+  <p:transition advClick="1"/>
+</p:sld>
+</file>
+
+<file path=ppt/slides/slide22.xml><?xml version="1.0" encoding="utf-8"?>
+<p:sld xmlns:a="http://schemas.openxmlformats.org/drawingml/2006/main" xmlns:p="http://schemas.openxmlformats.org/presentationml/2006/main" xmlns:r="http://schemas.openxmlformats.org/officeDocument/2006/relationships">
+  <p:cSld>
+    <p:spTree>
+      <p:nvGrpSpPr>
+        <p:cNvPr id="1" name=""/>
+        <p:cNvGrpSpPr/>
+        <p:nvPr/>
+      </p:nvGrpSpPr>
+      <p:grpSpPr/>
+      <p:pic>
+        <p:nvPicPr>
+          <p:cNvPr id="2" name="Picture 1" descr="slide-22.png"/>
+          <p:cNvPicPr>
+            <a:picLocks noChangeAspect="1"/>
+          </p:cNvPicPr>
+          <p:nvPr/>
+        </p:nvPicPr>
+        <p:blipFill>
+          <a:blip r:embed="rId2"/>
+          <a:stretch>
+            <a:fillRect/>
+          </a:stretch>
+        </p:blipFill>
+        <p:spPr>
+          <a:xfrm>
+            <a:off x="0" y="0"/>
+            <a:ext cx="12192000" cy="6858000"/>
+          </a:xfrm>
+          <a:prstGeom prst="rect">
+            <a:avLst/>
+          </a:prstGeom>
+        </p:spPr>
+      </p:pic>
+    </p:spTree>
+  </p:cSld>
+  <p:clrMapOvr>
+    <a:masterClrMapping/>
+  </p:clrMapOvr>
+  <p:transition advClick="1"/>
+</p:sld>
+</file>
+
+<file path=ppt/slides/slide23.xml><?xml version="1.0" encoding="utf-8"?>
+<p:sld xmlns:a="http://schemas.openxmlformats.org/drawingml/2006/main" xmlns:p="http://schemas.openxmlformats.org/presentationml/2006/main" xmlns:r="http://schemas.openxmlformats.org/officeDocument/2006/relationships">
+  <p:cSld>
+    <p:spTree>
+      <p:nvGrpSpPr>
+        <p:cNvPr id="1" name=""/>
+        <p:cNvGrpSpPr/>
+        <p:nvPr/>
+      </p:nvGrpSpPr>
+      <p:grpSpPr/>
+      <p:pic>
+        <p:nvPicPr>
+          <p:cNvPr id="2" name="Picture 1" descr="slide-23.png"/>
+          <p:cNvPicPr>
+            <a:picLocks noChangeAspect="1"/>
+          </p:cNvPicPr>
+          <p:nvPr/>
+        </p:nvPicPr>
+        <p:blipFill>
+          <a:blip r:embed="rId2"/>
+          <a:stretch>
+            <a:fillRect/>
+          </a:stretch>
+        </p:blipFill>
+        <p:spPr>
+          <a:xfrm>
+            <a:off x="0" y="0"/>
+            <a:ext cx="12192000" cy="6858000"/>
+          </a:xfrm>
+          <a:prstGeom prst="rect">
+            <a:avLst/>
+          </a:prstGeom>
+        </p:spPr>
+      </p:pic>
+    </p:spTree>
+  </p:cSld>
+  <p:clrMapOvr>
+    <a:masterClrMapping/>
+  </p:clrMapOvr>
+  <p:transition advClick="1"/>
+</p:sld>
+</file>
+
+<file path=ppt/slides/slide24.xml><?xml version="1.0" encoding="utf-8"?>
+<p:sld xmlns:a="http://schemas.openxmlformats.org/drawingml/2006/main" xmlns:p="http://schemas.openxmlformats.org/presentationml/2006/main" xmlns:r="http://schemas.openxmlformats.org/officeDocument/2006/relationships">
+  <p:cSld>
+    <p:spTree>
+      <p:nvGrpSpPr>
+        <p:cNvPr id="1" name=""/>
+        <p:cNvGrpSpPr/>
+        <p:nvPr/>
+      </p:nvGrpSpPr>
+      <p:grpSpPr/>
+      <p:pic>
+        <p:nvPicPr>
+          <p:cNvPr id="2" name="Picture 1" descr="slide-24.png"/>
+          <p:cNvPicPr>
+            <a:picLocks noChangeAspect="1"/>
+          </p:cNvPicPr>
+          <p:nvPr/>
+        </p:nvPicPr>
+        <p:blipFill>
+          <a:blip r:embed="rId2"/>
+          <a:stretch>
+            <a:fillRect/>
+          </a:stretch>
+        </p:blipFill>
+        <p:spPr>
+          <a:xfrm>
+            <a:off x="0" y="0"/>
+            <a:ext cx="12192000" cy="6858000"/>
+          </a:xfrm>
+          <a:prstGeom prst="rect">
+            <a:avLst/>
+          </a:prstGeom>
+        </p:spPr>
+      </p:pic>
+    </p:spTree>
+  </p:cSld>
+  <p:clrMapOvr>
+    <a:masterClrMapping/>
+  </p:clrMapOvr>
+  <p:transition advClick="1"/>
+</p:sld>
+</file>
+
+<file path=ppt/slides/slide25.xml><?xml version="1.0" encoding="utf-8"?>
+<p:sld xmlns:a="http://schemas.openxmlformats.org/drawingml/2006/main" xmlns:p="http://schemas.openxmlformats.org/presentationml/2006/main" xmlns:r="http://schemas.openxmlformats.org/officeDocument/2006/relationships">
+  <p:cSld>
+    <p:spTree>
+      <p:nvGrpSpPr>
+        <p:cNvPr id="1" name=""/>
+        <p:cNvGrpSpPr/>
+        <p:nvPr/>
+      </p:nvGrpSpPr>
+      <p:grpSpPr/>
+      <p:pic>
+        <p:nvPicPr>
+          <p:cNvPr id="2" name="Picture 1" descr="slide-25.png"/>
+          <p:cNvPicPr>
+            <a:picLocks noChangeAspect="1"/>
+          </p:cNvPicPr>
+          <p:nvPr/>
+        </p:nvPicPr>
+        <p:blipFill>
+          <a:blip r:embed="rId2"/>
+          <a:stretch>
+            <a:fillRect/>
+          </a:stretch>
+        </p:blipFill>
+        <p:spPr>
+          <a:xfrm>
+            <a:off x="0" y="0"/>
+            <a:ext cx="12192000" cy="6858000"/>
+          </a:xfrm>
+          <a:prstGeom prst="rect">
+            <a:avLst/>
+          </a:prstGeom>
+        </p:spPr>
+      </p:pic>
+    </p:spTree>
+  </p:cSld>
+  <p:clrMapOvr>
+    <a:masterClrMapping/>
+  </p:clrMapOvr>
+  <p:transition advClick="1"/>
+</p:sld>
+</file>
+
+<file path=ppt/slides/slide26.xml><?xml version="1.0" encoding="utf-8"?>
+<p:sld xmlns:a="http://schemas.openxmlformats.org/drawingml/2006/main" xmlns:p="http://schemas.openxmlformats.org/presentationml/2006/main" xmlns:r="http://schemas.openxmlformats.org/officeDocument/2006/relationships">
+  <p:cSld>
+    <p:spTree>
+      <p:nvGrpSpPr>
+        <p:cNvPr id="1" name=""/>
+        <p:cNvGrpSpPr/>
+        <p:nvPr/>
+      </p:nvGrpSpPr>
+      <p:grpSpPr/>
+      <p:pic>
+        <p:nvPicPr>
+          <p:cNvPr id="2" name="Picture 1" descr="slide-26.png"/>
           <p:cNvPicPr>
             <a:picLocks noChangeAspect="1"/>
           </p:cNvPicPr>
@@ -4870,32 +6124,6 @@
           </a:prstGeom>
         </p:spPr>
       </p:pic>
-      <p:pic>
-        <p:nvPicPr>
-          <p:cNvPr id="3" name="Animated demo: gifs/web.gif" descr="web.gif"/>
-          <p:cNvPicPr>
-            <a:picLocks noChangeAspect="1"/>
-          </p:cNvPicPr>
-          <p:nvPr/>
-        </p:nvPicPr>
-        <p:blipFill>
-          <a:blip r:embed="rId3"/>
-          <a:stretch>
-            <a:fillRect/>
-          </a:stretch>
-        </p:blipFill>
-        <p:spPr>
-          <a:xfrm>
-            <a:off x="8509000" y="596900"/>
-            <a:ext cx="2641600" cy="5715000"/>
-          </a:xfrm>
-          <a:prstGeom prst="roundRect">
-            <a:avLst>
-              <a:gd name="adj" fmla="val 9135"/>
-            </a:avLst>
-          </a:prstGeom>
-        </p:spPr>
-      </p:pic>
     </p:spTree>
   </p:cSld>
   <p:clrMapOvr>
@@ -4936,32 +6164,6 @@
           </a:xfrm>
           <a:prstGeom prst="rect">
             <a:avLst/>
-          </a:prstGeom>
-        </p:spPr>
-      </p:pic>
-      <p:pic>
-        <p:nvPicPr>
-          <p:cNvPr id="3" name="Animated demo: gifs/event.gif" descr="event.gif"/>
-          <p:cNvPicPr>
-            <a:picLocks noChangeAspect="1"/>
-          </p:cNvPicPr>
-          <p:nvPr/>
-        </p:nvPicPr>
-        <p:blipFill>
-          <a:blip r:embed="rId3"/>
-          <a:stretch>
-            <a:fillRect/>
-          </a:stretch>
-        </p:blipFill>
-        <p:spPr>
-          <a:xfrm>
-            <a:off x="8509000" y="596900"/>
-            <a:ext cx="2641600" cy="5715000"/>
-          </a:xfrm>
-          <a:prstGeom prst="roundRect">
-            <a:avLst>
-              <a:gd name="adj" fmla="val 9135"/>
-            </a:avLst>
           </a:prstGeom>
         </p:spPr>
       </p:pic>
@@ -5008,32 +6210,6 @@
           </a:prstGeom>
         </p:spPr>
       </p:pic>
-      <p:pic>
-        <p:nvPicPr>
-          <p:cNvPr id="3" name="Animated demo: gifs/referral.gif" descr="referral.gif"/>
-          <p:cNvPicPr>
-            <a:picLocks noChangeAspect="1"/>
-          </p:cNvPicPr>
-          <p:nvPr/>
-        </p:nvPicPr>
-        <p:blipFill>
-          <a:blip r:embed="rId3"/>
-          <a:stretch>
-            <a:fillRect/>
-          </a:stretch>
-        </p:blipFill>
-        <p:spPr>
-          <a:xfrm>
-            <a:off x="8509000" y="596900"/>
-            <a:ext cx="2641600" cy="5715000"/>
-          </a:xfrm>
-          <a:prstGeom prst="roundRect">
-            <a:avLst>
-              <a:gd name="adj" fmla="val 9135"/>
-            </a:avLst>
-          </a:prstGeom>
-        </p:spPr>
-      </p:pic>
     </p:spTree>
   </p:cSld>
   <p:clrMapOvr>
@@ -5074,32 +6250,6 @@
           </a:xfrm>
           <a:prstGeom prst="rect">
             <a:avLst/>
-          </a:prstGeom>
-        </p:spPr>
-      </p:pic>
-      <p:pic>
-        <p:nvPicPr>
-          <p:cNvPr id="3" name="Animated demo: gifs/admin.gif" descr="admin.gif"/>
-          <p:cNvPicPr>
-            <a:picLocks noChangeAspect="1"/>
-          </p:cNvPicPr>
-          <p:nvPr/>
-        </p:nvPicPr>
-        <p:blipFill>
-          <a:blip r:embed="rId3"/>
-          <a:stretch>
-            <a:fillRect/>
-          </a:stretch>
-        </p:blipFill>
-        <p:spPr>
-          <a:xfrm>
-            <a:off x="838200" y="1905000"/>
-            <a:ext cx="7112000" cy="4445000"/>
-          </a:xfrm>
-          <a:prstGeom prst="roundRect">
-            <a:avLst>
-              <a:gd name="adj" fmla="val 2000"/>
-            </a:avLst>
           </a:prstGeom>
         </p:spPr>
       </p:pic>

</xml_diff>

<commit_message>
fix(pitch): corriger le portrait de Lukas dans la capture
</commit_message>
<xml_diff>
--- a/docs/pitch/Club-des-Affaires-pitch.pptx
+++ b/docs/pitch/Club-des-Affaires-pitch.pptx
@@ -4,35 +4,38 @@
   <p:sldMasterIdLst>
     <p:sldMasterId id="2147483648" r:id="rId1"/>
   </p:sldMasterIdLst>
+  <p:notesMasterIdLst>
+    <p:notesMasterId r:id="rId28"/>
+  </p:notesMasterIdLst>
   <p:sldIdLst>
-    <p:sldId id="256" r:id="rId7"/>
-    <p:sldId id="257" r:id="rId9"/>
-    <p:sldId id="258" r:id="rId10"/>
-    <p:sldId id="259" r:id="rId11"/>
-    <p:sldId id="260" r:id="rId12"/>
-    <p:sldId id="261" r:id="rId13"/>
-    <p:sldId id="262" r:id="rId14"/>
-    <p:sldId id="263" r:id="rId15"/>
-    <p:sldId id="264" r:id="rId16"/>
-    <p:sldId id="265" r:id="rId17"/>
-    <p:sldId id="266" r:id="rId18"/>
-    <p:sldId id="267" r:id="rId19"/>
-    <p:sldId id="268" r:id="rId20"/>
-    <p:sldId id="269" r:id="rId21"/>
-    <p:sldId id="270" r:id="rId22"/>
-    <p:sldId id="271" r:id="rId23"/>
-    <p:sldId id="272" r:id="rId24"/>
-    <p:sldId id="273" r:id="rId25"/>
-    <p:sldId id="274" r:id="rId26"/>
-    <p:sldId id="275" r:id="rId27"/>
-    <p:sldId id="276" r:id="rId28"/>
-    <p:sldId id="277" r:id="rId29"/>
-    <p:sldId id="278" r:id="rId30"/>
-    <p:sldId id="279" r:id="rId31"/>
-    <p:sldId id="280" r:id="rId32"/>
-    <p:sldId id="281" r:id="rId33"/>
+    <p:sldId id="256" r:id="rId2"/>
+    <p:sldId id="257" r:id="rId3"/>
+    <p:sldId id="258" r:id="rId4"/>
+    <p:sldId id="259" r:id="rId5"/>
+    <p:sldId id="260" r:id="rId6"/>
+    <p:sldId id="261" r:id="rId7"/>
+    <p:sldId id="262" r:id="rId8"/>
+    <p:sldId id="263" r:id="rId9"/>
+    <p:sldId id="264" r:id="rId10"/>
+    <p:sldId id="265" r:id="rId11"/>
+    <p:sldId id="266" r:id="rId12"/>
+    <p:sldId id="267" r:id="rId13"/>
+    <p:sldId id="268" r:id="rId14"/>
+    <p:sldId id="269" r:id="rId15"/>
+    <p:sldId id="270" r:id="rId16"/>
+    <p:sldId id="271" r:id="rId17"/>
+    <p:sldId id="272" r:id="rId18"/>
+    <p:sldId id="273" r:id="rId19"/>
+    <p:sldId id="274" r:id="rId20"/>
+    <p:sldId id="275" r:id="rId21"/>
+    <p:sldId id="276" r:id="rId22"/>
+    <p:sldId id="277" r:id="rId23"/>
+    <p:sldId id="278" r:id="rId24"/>
+    <p:sldId id="279" r:id="rId25"/>
+    <p:sldId id="280" r:id="rId26"/>
+    <p:sldId id="281" r:id="rId27"/>
   </p:sldIdLst>
-  <p:sldSz cx="12192000" cy="6858000" type="screen4x3"/>
+  <p:sldSz cx="12192000" cy="6858000"/>
   <p:notesSz cx="6858000" cy="9144000"/>
   <p:defaultTextStyle>
     <a:defPPr>
@@ -129,11 +132,27 @@
       </a:defRPr>
     </a:lvl9pPr>
   </p:defaultTextStyle>
+  <p:extLst>
+    <p:ext uri="{EFAFB233-063F-42B5-8137-9DF3F51BA10A}">
+      <p15:sldGuideLst xmlns:p15="http://schemas.microsoft.com/office/powerpoint/2012/main">
+        <p15:guide id="1" orient="horz" pos="2160">
+          <p15:clr>
+            <a:srgbClr val="A4A3A4"/>
+          </p15:clr>
+        </p15:guide>
+        <p15:guide id="2" pos="2880">
+          <p15:clr>
+            <a:srgbClr val="A4A3A4"/>
+          </p15:clr>
+        </p15:guide>
+      </p15:sldGuideLst>
+    </p:ext>
+  </p:extLst>
 </p:presentation>
 </file>
 
 <file path=ppt/notesMasters/notesMaster1.xml><?xml version="1.0" encoding="utf-8"?>
-<p:notesMaster xmlns:a="http://schemas.openxmlformats.org/drawingml/2006/main" xmlns:p="http://schemas.openxmlformats.org/presentationml/2006/main" xmlns:r="http://schemas.openxmlformats.org/officeDocument/2006/relationships">
+<p:notesMaster xmlns:a="http://schemas.openxmlformats.org/drawingml/2006/main" xmlns:r="http://schemas.openxmlformats.org/officeDocument/2006/relationships" xmlns:p="http://schemas.openxmlformats.org/presentationml/2006/main">
   <p:cSld>
     <p:bg>
       <p:bgRef idx="1001">
@@ -154,241 +173,16 @@
           <a:chExt cx="0" cy="0"/>
         </a:xfrm>
       </p:grpSpPr>
-      <p:sp>
-        <p:nvSpPr>
-          <p:cNvPr id="2" name="Header Placeholder 1"/>
-          <p:cNvSpPr>
-            <a:spLocks noGrp="1"/>
-          </p:cNvSpPr>
-          <p:nvPr>
-            <p:ph type="hdr" sz="quarter"/>
-          </p:nvPr>
-        </p:nvSpPr>
-        <p:spPr>
-          <a:xfrm>
-            <a:off x="0" y="0"/>
-            <a:ext cx="2971800" cy="457200"/>
-          </a:xfrm>
-          <a:prstGeom prst="rect">
-            <a:avLst/>
-          </a:prstGeom>
-        </p:spPr>
-        <p:txBody>
-          <a:bodyPr vert="horz" lIns="91440" tIns="45720" rIns="91440" bIns="45720" rtlCol="0"/>
-          <a:lstStyle>
-            <a:lvl1pPr algn="l">
-              <a:defRPr sz="1200"/>
-            </a:lvl1pPr>
-          </a:lstStyle>
-          <a:p>
-            <a:endParaRPr lang="en-US"/>
-          </a:p>
-        </p:txBody>
-      </p:sp>
-      <p:sp>
-        <p:nvSpPr>
-          <p:cNvPr id="3" name="Date Placeholder 2"/>
-          <p:cNvSpPr>
-            <a:spLocks noGrp="1"/>
-          </p:cNvSpPr>
-          <p:nvPr>
-            <p:ph type="dt" idx="1"/>
-          </p:nvPr>
-        </p:nvSpPr>
-        <p:spPr>
-          <a:xfrm>
-            <a:off x="3884613" y="0"/>
-            <a:ext cx="2971800" cy="457200"/>
-          </a:xfrm>
-          <a:prstGeom prst="rect">
-            <a:avLst/>
-          </a:prstGeom>
-        </p:spPr>
-        <p:txBody>
-          <a:bodyPr vert="horz" lIns="91440" tIns="45720" rIns="91440" bIns="45720" rtlCol="0"/>
-          <a:lstStyle>
-            <a:lvl1pPr algn="r">
-              <a:defRPr sz="1200"/>
-            </a:lvl1pPr>
-          </a:lstStyle>
-          <a:p>
-            <a:fld id="{0F89C1C7-3DCD-1040-A9CF-14679D8B5DDD}" type="datetimeFigureOut">
-              <a:rPr lang="en-US" smtClean="0"/>
-              <a:t>10/17/16</a:t>
-            </a:fld>
-            <a:endParaRPr lang="en-US"/>
-          </a:p>
-        </p:txBody>
-      </p:sp>
-      <p:sp>
-        <p:nvSpPr>
-          <p:cNvPr id="4" name="Slide Image Placeholder 3"/>
-          <p:cNvSpPr>
-            <a:spLocks noGrp="1" noRot="1" noChangeAspect="1"/>
-          </p:cNvSpPr>
-          <p:nvPr>
-            <p:ph type="sldImg" idx="2"/>
-          </p:nvPr>
-        </p:nvSpPr>
-        <p:spPr>
-          <a:xfrm>
-            <a:off x="1143000" y="685800"/>
-            <a:ext cx="4572000" cy="3429000"/>
-          </a:xfrm>
-          <a:prstGeom prst="rect">
-            <a:avLst/>
-          </a:prstGeom>
-          <a:noFill/>
-          <a:ln w="12700">
-            <a:solidFill>
-              <a:prstClr val="black"/>
-            </a:solidFill>
-          </a:ln>
-        </p:spPr>
-        <p:txBody>
-          <a:bodyPr vert="horz" lIns="91440" tIns="45720" rIns="91440" bIns="45720" rtlCol="0" anchor="ctr"/>
-          <a:lstStyle/>
-          <a:p>
-            <a:endParaRPr lang="en-US"/>
-          </a:p>
-        </p:txBody>
-      </p:sp>
-      <p:sp>
-        <p:nvSpPr>
-          <p:cNvPr id="5" name="Notes Placeholder 4"/>
-          <p:cNvSpPr>
-            <a:spLocks noGrp="1"/>
-          </p:cNvSpPr>
-          <p:nvPr>
-            <p:ph type="body" sz="quarter" idx="3"/>
-          </p:nvPr>
-        </p:nvSpPr>
-        <p:spPr>
-          <a:xfrm>
-            <a:off x="685800" y="4343400"/>
-            <a:ext cx="5486400" cy="4114800"/>
-          </a:xfrm>
-          <a:prstGeom prst="rect">
-            <a:avLst/>
-          </a:prstGeom>
-        </p:spPr>
-        <p:txBody>
-          <a:bodyPr vert="horz" lIns="91440" tIns="45720" rIns="91440" bIns="45720" rtlCol="0"/>
-          <a:lstStyle/>
-          <a:p>
-            <a:pPr lvl="0"/>
-            <a:r>
-              <a:rPr lang="en-US" smtClean="0"/>
-              <a:t>Click to edit Master text styles</a:t>
-            </a:r>
-          </a:p>
-          <a:p>
-            <a:pPr lvl="1"/>
-            <a:r>
-              <a:rPr lang="en-US" smtClean="0"/>
-              <a:t>Second level</a:t>
-            </a:r>
-          </a:p>
-          <a:p>
-            <a:pPr lvl="2"/>
-            <a:r>
-              <a:rPr lang="en-US" smtClean="0"/>
-              <a:t>Third level</a:t>
-            </a:r>
-          </a:p>
-          <a:p>
-            <a:pPr lvl="3"/>
-            <a:r>
-              <a:rPr lang="en-US" smtClean="0"/>
-              <a:t>Fourth level</a:t>
-            </a:r>
-          </a:p>
-          <a:p>
-            <a:pPr lvl="4"/>
-            <a:r>
-              <a:rPr lang="en-US" smtClean="0"/>
-              <a:t>Fifth level</a:t>
-            </a:r>
-            <a:endParaRPr lang="en-US"/>
-          </a:p>
-        </p:txBody>
-      </p:sp>
-      <p:sp>
-        <p:nvSpPr>
-          <p:cNvPr id="6" name="Footer Placeholder 5"/>
-          <p:cNvSpPr>
-            <a:spLocks noGrp="1"/>
-          </p:cNvSpPr>
-          <p:nvPr>
-            <p:ph type="ftr" sz="quarter" idx="4"/>
-          </p:nvPr>
-        </p:nvSpPr>
-        <p:spPr>
-          <a:xfrm>
-            <a:off x="0" y="8685213"/>
-            <a:ext cx="2971800" cy="457200"/>
-          </a:xfrm>
-          <a:prstGeom prst="rect">
-            <a:avLst/>
-          </a:prstGeom>
-        </p:spPr>
-        <p:txBody>
-          <a:bodyPr vert="horz" lIns="91440" tIns="45720" rIns="91440" bIns="45720" rtlCol="0" anchor="b"/>
-          <a:lstStyle>
-            <a:lvl1pPr algn="l">
-              <a:defRPr sz="1200"/>
-            </a:lvl1pPr>
-          </a:lstStyle>
-          <a:p>
-            <a:endParaRPr lang="en-US"/>
-          </a:p>
-        </p:txBody>
-      </p:sp>
-      <p:sp>
-        <p:nvSpPr>
-          <p:cNvPr id="7" name="Slide Number Placeholder 6"/>
-          <p:cNvSpPr>
-            <a:spLocks noGrp="1"/>
-          </p:cNvSpPr>
-          <p:nvPr>
-            <p:ph type="sldNum" sz="quarter" idx="5"/>
-          </p:nvPr>
-        </p:nvSpPr>
-        <p:spPr>
-          <a:xfrm>
-            <a:off x="3884613" y="8685213"/>
-            <a:ext cx="2971800" cy="457200"/>
-          </a:xfrm>
-          <a:prstGeom prst="rect">
-            <a:avLst/>
-          </a:prstGeom>
-        </p:spPr>
-        <p:txBody>
-          <a:bodyPr vert="horz" lIns="91440" tIns="45720" rIns="91440" bIns="45720" rtlCol="0" anchor="b"/>
-          <a:lstStyle>
-            <a:lvl1pPr algn="r">
-              <a:defRPr sz="1200"/>
-            </a:lvl1pPr>
-          </a:lstStyle>
-          <a:p>
-            <a:fld id="{BB5E49A5-4136-284D-997B-48E1D791AD67}" type="slidenum">
-              <a:rPr lang="en-US" smtClean="0"/>
-              <a:t>‹#›</a:t>
-            </a:fld>
-            <a:endParaRPr lang="en-US"/>
-          </a:p>
-        </p:txBody>
-      </p:sp>
     </p:spTree>
     <p:extLst>
       <p:ext uri="{BB962C8B-B14F-4D97-AF65-F5344CB8AC3E}">
-        <p14:creationId xmlns:p14="http://schemas.microsoft.com/office/powerpoint/2010/main" val="2623252185"/>
+        <p14:creationId xmlns:p14="http://schemas.microsoft.com/office/powerpoint/2010/main" val="1374365343"/>
       </p:ext>
     </p:extLst>
   </p:cSld>
   <p:clrMap bg1="lt1" tx1="dk1" bg2="lt2" tx2="dk2" accent1="accent1" accent2="accent2" accent3="accent3" accent4="accent4" accent5="accent5" accent6="accent6" hlink="hlink" folHlink="folHlink"/>
   <p:notesStyle>
-    <a:lvl1pPr marL="0" algn="l" defTabSz="457200" rtl="0" eaLnBrk="1" latinLnBrk="0" hangingPunct="1">
+    <a:lvl1pPr marL="0" algn="l" defTabSz="914400" rtl="0" eaLnBrk="1" latinLnBrk="0" hangingPunct="1">
       <a:defRPr sz="1200" kern="1200">
         <a:solidFill>
           <a:schemeClr val="tx1"/>
@@ -398,7 +192,7 @@
         <a:cs typeface="+mn-cs"/>
       </a:defRPr>
     </a:lvl1pPr>
-    <a:lvl2pPr marL="457200" algn="l" defTabSz="457200" rtl="0" eaLnBrk="1" latinLnBrk="0" hangingPunct="1">
+    <a:lvl2pPr marL="457200" algn="l" defTabSz="914400" rtl="0" eaLnBrk="1" latinLnBrk="0" hangingPunct="1">
       <a:defRPr sz="1200" kern="1200">
         <a:solidFill>
           <a:schemeClr val="tx1"/>
@@ -408,7 +202,7 @@
         <a:cs typeface="+mn-cs"/>
       </a:defRPr>
     </a:lvl2pPr>
-    <a:lvl3pPr marL="914400" algn="l" defTabSz="457200" rtl="0" eaLnBrk="1" latinLnBrk="0" hangingPunct="1">
+    <a:lvl3pPr marL="914400" algn="l" defTabSz="914400" rtl="0" eaLnBrk="1" latinLnBrk="0" hangingPunct="1">
       <a:defRPr sz="1200" kern="1200">
         <a:solidFill>
           <a:schemeClr val="tx1"/>
@@ -418,7 +212,7 @@
         <a:cs typeface="+mn-cs"/>
       </a:defRPr>
     </a:lvl3pPr>
-    <a:lvl4pPr marL="1371600" algn="l" defTabSz="457200" rtl="0" eaLnBrk="1" latinLnBrk="0" hangingPunct="1">
+    <a:lvl4pPr marL="1371600" algn="l" defTabSz="914400" rtl="0" eaLnBrk="1" latinLnBrk="0" hangingPunct="1">
       <a:defRPr sz="1200" kern="1200">
         <a:solidFill>
           <a:schemeClr val="tx1"/>
@@ -428,7 +222,7 @@
         <a:cs typeface="+mn-cs"/>
       </a:defRPr>
     </a:lvl4pPr>
-    <a:lvl5pPr marL="1828800" algn="l" defTabSz="457200" rtl="0" eaLnBrk="1" latinLnBrk="0" hangingPunct="1">
+    <a:lvl5pPr marL="1828800" algn="l" defTabSz="914400" rtl="0" eaLnBrk="1" latinLnBrk="0" hangingPunct="1">
       <a:defRPr sz="1200" kern="1200">
         <a:solidFill>
           <a:schemeClr val="tx1"/>
@@ -438,7 +232,7 @@
         <a:cs typeface="+mn-cs"/>
       </a:defRPr>
     </a:lvl5pPr>
-    <a:lvl6pPr marL="2286000" algn="l" defTabSz="457200" rtl="0" eaLnBrk="1" latinLnBrk="0" hangingPunct="1">
+    <a:lvl6pPr marL="2286000" algn="l" defTabSz="914400" rtl="0" eaLnBrk="1" latinLnBrk="0" hangingPunct="1">
       <a:defRPr sz="1200" kern="1200">
         <a:solidFill>
           <a:schemeClr val="tx1"/>
@@ -448,7 +242,7 @@
         <a:cs typeface="+mn-cs"/>
       </a:defRPr>
     </a:lvl6pPr>
-    <a:lvl7pPr marL="2743200" algn="l" defTabSz="457200" rtl="0" eaLnBrk="1" latinLnBrk="0" hangingPunct="1">
+    <a:lvl7pPr marL="2743200" algn="l" defTabSz="914400" rtl="0" eaLnBrk="1" latinLnBrk="0" hangingPunct="1">
       <a:defRPr sz="1200" kern="1200">
         <a:solidFill>
           <a:schemeClr val="tx1"/>
@@ -458,7 +252,7 @@
         <a:cs typeface="+mn-cs"/>
       </a:defRPr>
     </a:lvl7pPr>
-    <a:lvl8pPr marL="3200400" algn="l" defTabSz="457200" rtl="0" eaLnBrk="1" latinLnBrk="0" hangingPunct="1">
+    <a:lvl8pPr marL="3200400" algn="l" defTabSz="914400" rtl="0" eaLnBrk="1" latinLnBrk="0" hangingPunct="1">
       <a:defRPr sz="1200" kern="1200">
         <a:solidFill>
           <a:schemeClr val="tx1"/>
@@ -468,7 +262,7 @@
         <a:cs typeface="+mn-cs"/>
       </a:defRPr>
     </a:lvl8pPr>
-    <a:lvl9pPr marL="3657600" algn="l" defTabSz="457200" rtl="0" eaLnBrk="1" latinLnBrk="0" hangingPunct="1">
+    <a:lvl9pPr marL="3657600" algn="l" defTabSz="914400" rtl="0" eaLnBrk="1" latinLnBrk="0" hangingPunct="1">
       <a:defRPr sz="1200" kern="1200">
         <a:solidFill>
           <a:schemeClr val="tx1"/>
@@ -483,7 +277,7 @@
 </file>
 
 <file path=ppt/notesSlides/notesSlide1.xml><?xml version="1.0" encoding="utf-8"?>
-<p:notes xmlns:a="http://schemas.openxmlformats.org/drawingml/2006/main" xmlns:p="http://schemas.openxmlformats.org/presentationml/2006/main" xmlns:r="http://schemas.openxmlformats.org/officeDocument/2006/relationships">
+<p:notes xmlns:a="http://schemas.openxmlformats.org/drawingml/2006/main" xmlns:r="http://schemas.openxmlformats.org/officeDocument/2006/relationships" xmlns:p="http://schemas.openxmlformats.org/presentationml/2006/main">
   <p:cSld>
     <p:spTree>
       <p:nvGrpSpPr>
@@ -503,7 +297,7 @@
         <p:nvSpPr>
           <p:cNvPr id="2" name="Slide Image Placeholder 1"/>
           <p:cNvSpPr>
-            <a:spLocks noGrp="1"/>
+            <a:spLocks noGrp="1" noRot="1" noChangeAspect="1"/>
           </p:cNvSpPr>
           <p:nvPr>
             <p:ph type="sldImg" idx="2"/>
@@ -518,7 +312,7 @@
             <a:spLocks noGrp="1"/>
           </p:cNvSpPr>
           <p:nvPr>
-            <p:ph type="body" idx="3" sz="quarter"/>
+            <p:ph type="body" sz="quarter" idx="3"/>
           </p:nvPr>
         </p:nvSpPr>
         <p:spPr/>
@@ -539,7 +333,7 @@
             <a:spLocks noGrp="1"/>
           </p:cNvSpPr>
           <p:nvPr>
-            <p:ph type="sldNum" idx="5" sz="quarter"/>
+            <p:ph type="sldNum" sz="quarter" idx="5"/>
           </p:nvPr>
         </p:nvSpPr>
         <p:spPr/>
@@ -553,7 +347,7 @@
 </file>
 
 <file path=ppt/notesSlides/notesSlide10.xml><?xml version="1.0" encoding="utf-8"?>
-<p:notes xmlns:a="http://schemas.openxmlformats.org/drawingml/2006/main" xmlns:p="http://schemas.openxmlformats.org/presentationml/2006/main" xmlns:r="http://schemas.openxmlformats.org/officeDocument/2006/relationships">
+<p:notes xmlns:a="http://schemas.openxmlformats.org/drawingml/2006/main" xmlns:r="http://schemas.openxmlformats.org/officeDocument/2006/relationships" xmlns:p="http://schemas.openxmlformats.org/presentationml/2006/main">
   <p:cSld>
     <p:spTree>
       <p:nvGrpSpPr>
@@ -573,7 +367,7 @@
         <p:nvSpPr>
           <p:cNvPr id="2" name="Slide Image Placeholder 1"/>
           <p:cNvSpPr>
-            <a:spLocks noGrp="1"/>
+            <a:spLocks noGrp="1" noRot="1" noChangeAspect="1"/>
           </p:cNvSpPr>
           <p:nvPr>
             <p:ph type="sldImg" idx="2"/>
@@ -588,7 +382,7 @@
             <a:spLocks noGrp="1"/>
           </p:cNvSpPr>
           <p:nvPr>
-            <p:ph type="body" idx="3" sz="quarter"/>
+            <p:ph type="body" sz="quarter" idx="3"/>
           </p:nvPr>
         </p:nvSpPr>
         <p:spPr/>
@@ -609,7 +403,7 @@
             <a:spLocks noGrp="1"/>
           </p:cNvSpPr>
           <p:nvPr>
-            <p:ph type="sldNum" idx="5" sz="quarter"/>
+            <p:ph type="sldNum" sz="quarter" idx="5"/>
           </p:nvPr>
         </p:nvSpPr>
         <p:spPr/>
@@ -623,7 +417,7 @@
 </file>
 
 <file path=ppt/notesSlides/notesSlide11.xml><?xml version="1.0" encoding="utf-8"?>
-<p:notes xmlns:a="http://schemas.openxmlformats.org/drawingml/2006/main" xmlns:p="http://schemas.openxmlformats.org/presentationml/2006/main" xmlns:r="http://schemas.openxmlformats.org/officeDocument/2006/relationships">
+<p:notes xmlns:a="http://schemas.openxmlformats.org/drawingml/2006/main" xmlns:r="http://schemas.openxmlformats.org/officeDocument/2006/relationships" xmlns:p="http://schemas.openxmlformats.org/presentationml/2006/main">
   <p:cSld>
     <p:spTree>
       <p:nvGrpSpPr>
@@ -643,7 +437,7 @@
         <p:nvSpPr>
           <p:cNvPr id="2" name="Slide Image Placeholder 1"/>
           <p:cNvSpPr>
-            <a:spLocks noGrp="1"/>
+            <a:spLocks noGrp="1" noRot="1" noChangeAspect="1"/>
           </p:cNvSpPr>
           <p:nvPr>
             <p:ph type="sldImg" idx="2"/>
@@ -658,7 +452,7 @@
             <a:spLocks noGrp="1"/>
           </p:cNvSpPr>
           <p:nvPr>
-            <p:ph type="body" idx="3" sz="quarter"/>
+            <p:ph type="body" sz="quarter" idx="3"/>
           </p:nvPr>
         </p:nvSpPr>
         <p:spPr/>
@@ -679,7 +473,7 @@
             <a:spLocks noGrp="1"/>
           </p:cNvSpPr>
           <p:nvPr>
-            <p:ph type="sldNum" idx="5" sz="quarter"/>
+            <p:ph type="sldNum" sz="quarter" idx="5"/>
           </p:nvPr>
         </p:nvSpPr>
         <p:spPr/>
@@ -693,7 +487,7 @@
 </file>
 
 <file path=ppt/notesSlides/notesSlide12.xml><?xml version="1.0" encoding="utf-8"?>
-<p:notes xmlns:a="http://schemas.openxmlformats.org/drawingml/2006/main" xmlns:p="http://schemas.openxmlformats.org/presentationml/2006/main" xmlns:r="http://schemas.openxmlformats.org/officeDocument/2006/relationships">
+<p:notes xmlns:a="http://schemas.openxmlformats.org/drawingml/2006/main" xmlns:r="http://schemas.openxmlformats.org/officeDocument/2006/relationships" xmlns:p="http://schemas.openxmlformats.org/presentationml/2006/main">
   <p:cSld>
     <p:spTree>
       <p:nvGrpSpPr>
@@ -713,7 +507,7 @@
         <p:nvSpPr>
           <p:cNvPr id="2" name="Slide Image Placeholder 1"/>
           <p:cNvSpPr>
-            <a:spLocks noGrp="1"/>
+            <a:spLocks noGrp="1" noRot="1" noChangeAspect="1"/>
           </p:cNvSpPr>
           <p:nvPr>
             <p:ph type="sldImg" idx="2"/>
@@ -728,7 +522,7 @@
             <a:spLocks noGrp="1"/>
           </p:cNvSpPr>
           <p:nvPr>
-            <p:ph type="body" idx="3" sz="quarter"/>
+            <p:ph type="body" sz="quarter" idx="3"/>
           </p:nvPr>
         </p:nvSpPr>
         <p:spPr/>
@@ -749,7 +543,7 @@
             <a:spLocks noGrp="1"/>
           </p:cNvSpPr>
           <p:nvPr>
-            <p:ph type="sldNum" idx="5" sz="quarter"/>
+            <p:ph type="sldNum" sz="quarter" idx="5"/>
           </p:nvPr>
         </p:nvSpPr>
         <p:spPr/>
@@ -763,7 +557,7 @@
 </file>
 
 <file path=ppt/notesSlides/notesSlide13.xml><?xml version="1.0" encoding="utf-8"?>
-<p:notes xmlns:a="http://schemas.openxmlformats.org/drawingml/2006/main" xmlns:p="http://schemas.openxmlformats.org/presentationml/2006/main" xmlns:r="http://schemas.openxmlformats.org/officeDocument/2006/relationships">
+<p:notes xmlns:a="http://schemas.openxmlformats.org/drawingml/2006/main" xmlns:r="http://schemas.openxmlformats.org/officeDocument/2006/relationships" xmlns:p="http://schemas.openxmlformats.org/presentationml/2006/main">
   <p:cSld>
     <p:spTree>
       <p:nvGrpSpPr>
@@ -783,7 +577,7 @@
         <p:nvSpPr>
           <p:cNvPr id="2" name="Slide Image Placeholder 1"/>
           <p:cNvSpPr>
-            <a:spLocks noGrp="1"/>
+            <a:spLocks noGrp="1" noRot="1" noChangeAspect="1"/>
           </p:cNvSpPr>
           <p:nvPr>
             <p:ph type="sldImg" idx="2"/>
@@ -798,7 +592,7 @@
             <a:spLocks noGrp="1"/>
           </p:cNvSpPr>
           <p:nvPr>
-            <p:ph type="body" idx="3" sz="quarter"/>
+            <p:ph type="body" sz="quarter" idx="3"/>
           </p:nvPr>
         </p:nvSpPr>
         <p:spPr/>
@@ -807,8 +601,13 @@
           <a:lstStyle/>
           <a:p>
             <a:r>
-              <a:t>(1:19–1:23) Le parrainage permet d’inviter une personne de confiance.</a:t>
-            </a:r>
+              <a:t>(1:19–1:23) Le parrainage permet d’inviter une personne de confiance</a:t>
+            </a:r>
+            <a:r>
+              <a:rPr lang="en-US"/>
+              <a:t> avec a la clef une reduction des cotisations pour le parrain et pour le nouvel etrant</a:t>
+            </a:r>
+            <a:endParaRPr/>
           </a:p>
         </p:txBody>
       </p:sp>
@@ -819,7 +618,7 @@
             <a:spLocks noGrp="1"/>
           </p:cNvSpPr>
           <p:nvPr>
-            <p:ph type="sldNum" idx="5" sz="quarter"/>
+            <p:ph type="sldNum" sz="quarter" idx="5"/>
           </p:nvPr>
         </p:nvSpPr>
         <p:spPr/>
@@ -833,7 +632,7 @@
 </file>
 
 <file path=ppt/notesSlides/notesSlide14.xml><?xml version="1.0" encoding="utf-8"?>
-<p:notes xmlns:a="http://schemas.openxmlformats.org/drawingml/2006/main" xmlns:p="http://schemas.openxmlformats.org/presentationml/2006/main" xmlns:r="http://schemas.openxmlformats.org/officeDocument/2006/relationships">
+<p:notes xmlns:a="http://schemas.openxmlformats.org/drawingml/2006/main" xmlns:r="http://schemas.openxmlformats.org/officeDocument/2006/relationships" xmlns:p="http://schemas.openxmlformats.org/presentationml/2006/main">
   <p:cSld>
     <p:spTree>
       <p:nvGrpSpPr>
@@ -853,7 +652,7 @@
         <p:nvSpPr>
           <p:cNvPr id="2" name="Slide Image Placeholder 1"/>
           <p:cNvSpPr>
-            <a:spLocks noGrp="1"/>
+            <a:spLocks noGrp="1" noRot="1" noChangeAspect="1"/>
           </p:cNvSpPr>
           <p:nvPr>
             <p:ph type="sldImg" idx="2"/>
@@ -868,7 +667,7 @@
             <a:spLocks noGrp="1"/>
           </p:cNvSpPr>
           <p:nvPr>
-            <p:ph type="body" idx="3" sz="quarter"/>
+            <p:ph type="body" sz="quarter" idx="3"/>
           </p:nvPr>
         </p:nvSpPr>
         <p:spPr/>
@@ -889,7 +688,7 @@
             <a:spLocks noGrp="1"/>
           </p:cNvSpPr>
           <p:nvPr>
-            <p:ph type="sldNum" idx="5" sz="quarter"/>
+            <p:ph type="sldNum" sz="quarter" idx="5"/>
           </p:nvPr>
         </p:nvSpPr>
         <p:spPr/>
@@ -903,7 +702,7 @@
 </file>
 
 <file path=ppt/notesSlides/notesSlide15.xml><?xml version="1.0" encoding="utf-8"?>
-<p:notes xmlns:a="http://schemas.openxmlformats.org/drawingml/2006/main" xmlns:p="http://schemas.openxmlformats.org/presentationml/2006/main" xmlns:r="http://schemas.openxmlformats.org/officeDocument/2006/relationships">
+<p:notes xmlns:a="http://schemas.openxmlformats.org/drawingml/2006/main" xmlns:r="http://schemas.openxmlformats.org/officeDocument/2006/relationships" xmlns:p="http://schemas.openxmlformats.org/presentationml/2006/main">
   <p:cSld>
     <p:spTree>
       <p:nvGrpSpPr>
@@ -923,7 +722,7 @@
         <p:nvSpPr>
           <p:cNvPr id="2" name="Slide Image Placeholder 1"/>
           <p:cNvSpPr>
-            <a:spLocks noGrp="1"/>
+            <a:spLocks noGrp="1" noRot="1" noChangeAspect="1"/>
           </p:cNvSpPr>
           <p:nvPr>
             <p:ph type="sldImg" idx="2"/>
@@ -938,7 +737,7 @@
             <a:spLocks noGrp="1"/>
           </p:cNvSpPr>
           <p:nvPr>
-            <p:ph type="body" idx="3" sz="quarter"/>
+            <p:ph type="body" sz="quarter" idx="3"/>
           </p:nvPr>
         </p:nvSpPr>
         <p:spPr/>
@@ -959,7 +758,7 @@
             <a:spLocks noGrp="1"/>
           </p:cNvSpPr>
           <p:nvPr>
-            <p:ph type="sldNum" idx="5" sz="quarter"/>
+            <p:ph type="sldNum" sz="quarter" idx="5"/>
           </p:nvPr>
         </p:nvSpPr>
         <p:spPr/>
@@ -973,7 +772,7 @@
 </file>
 
 <file path=ppt/notesSlides/notesSlide16.xml><?xml version="1.0" encoding="utf-8"?>
-<p:notes xmlns:a="http://schemas.openxmlformats.org/drawingml/2006/main" xmlns:p="http://schemas.openxmlformats.org/presentationml/2006/main" xmlns:r="http://schemas.openxmlformats.org/officeDocument/2006/relationships">
+<p:notes xmlns:a="http://schemas.openxmlformats.org/drawingml/2006/main" xmlns:r="http://schemas.openxmlformats.org/officeDocument/2006/relationships" xmlns:p="http://schemas.openxmlformats.org/presentationml/2006/main">
   <p:cSld>
     <p:spTree>
       <p:nvGrpSpPr>
@@ -993,7 +792,7 @@
         <p:nvSpPr>
           <p:cNvPr id="2" name="Slide Image Placeholder 1"/>
           <p:cNvSpPr>
-            <a:spLocks noGrp="1"/>
+            <a:spLocks noGrp="1" noRot="1" noChangeAspect="1"/>
           </p:cNvSpPr>
           <p:nvPr>
             <p:ph type="sldImg" idx="2"/>
@@ -1008,7 +807,7 @@
             <a:spLocks noGrp="1"/>
           </p:cNvSpPr>
           <p:nvPr>
-            <p:ph type="body" idx="3" sz="quarter"/>
+            <p:ph type="body" sz="quarter" idx="3"/>
           </p:nvPr>
         </p:nvSpPr>
         <p:spPr/>
@@ -1029,7 +828,7 @@
             <a:spLocks noGrp="1"/>
           </p:cNvSpPr>
           <p:nvPr>
-            <p:ph type="sldNum" idx="5" sz="quarter"/>
+            <p:ph type="sldNum" sz="quarter" idx="5"/>
           </p:nvPr>
         </p:nvSpPr>
         <p:spPr/>
@@ -1043,7 +842,7 @@
 </file>
 
 <file path=ppt/notesSlides/notesSlide17.xml><?xml version="1.0" encoding="utf-8"?>
-<p:notes xmlns:a="http://schemas.openxmlformats.org/drawingml/2006/main" xmlns:p="http://schemas.openxmlformats.org/presentationml/2006/main" xmlns:r="http://schemas.openxmlformats.org/officeDocument/2006/relationships">
+<p:notes xmlns:a="http://schemas.openxmlformats.org/drawingml/2006/main" xmlns:r="http://schemas.openxmlformats.org/officeDocument/2006/relationships" xmlns:p="http://schemas.openxmlformats.org/presentationml/2006/main">
   <p:cSld>
     <p:spTree>
       <p:nvGrpSpPr>
@@ -1063,7 +862,7 @@
         <p:nvSpPr>
           <p:cNvPr id="2" name="Slide Image Placeholder 1"/>
           <p:cNvSpPr>
-            <a:spLocks noGrp="1"/>
+            <a:spLocks noGrp="1" noRot="1" noChangeAspect="1"/>
           </p:cNvSpPr>
           <p:nvPr>
             <p:ph type="sldImg" idx="2"/>
@@ -1078,7 +877,7 @@
             <a:spLocks noGrp="1"/>
           </p:cNvSpPr>
           <p:nvPr>
-            <p:ph type="body" idx="3" sz="quarter"/>
+            <p:ph type="body" sz="quarter" idx="3"/>
           </p:nvPr>
         </p:nvSpPr>
         <p:spPr/>
@@ -1099,7 +898,7 @@
             <a:spLocks noGrp="1"/>
           </p:cNvSpPr>
           <p:nvPr>
-            <p:ph type="sldNum" idx="5" sz="quarter"/>
+            <p:ph type="sldNum" sz="quarter" idx="5"/>
           </p:nvPr>
         </p:nvSpPr>
         <p:spPr/>
@@ -1113,7 +912,7 @@
 </file>
 
 <file path=ppt/notesSlides/notesSlide18.xml><?xml version="1.0" encoding="utf-8"?>
-<p:notes xmlns:a="http://schemas.openxmlformats.org/drawingml/2006/main" xmlns:p="http://schemas.openxmlformats.org/presentationml/2006/main" xmlns:r="http://schemas.openxmlformats.org/officeDocument/2006/relationships">
+<p:notes xmlns:a="http://schemas.openxmlformats.org/drawingml/2006/main" xmlns:r="http://schemas.openxmlformats.org/officeDocument/2006/relationships" xmlns:p="http://schemas.openxmlformats.org/presentationml/2006/main">
   <p:cSld>
     <p:spTree>
       <p:nvGrpSpPr>
@@ -1133,7 +932,7 @@
         <p:nvSpPr>
           <p:cNvPr id="2" name="Slide Image Placeholder 1"/>
           <p:cNvSpPr>
-            <a:spLocks noGrp="1"/>
+            <a:spLocks noGrp="1" noRot="1" noChangeAspect="1"/>
           </p:cNvSpPr>
           <p:nvPr>
             <p:ph type="sldImg" idx="2"/>
@@ -1148,7 +947,7 @@
             <a:spLocks noGrp="1"/>
           </p:cNvSpPr>
           <p:nvPr>
-            <p:ph type="body" idx="3" sz="quarter"/>
+            <p:ph type="body" sz="quarter" idx="3"/>
           </p:nvPr>
         </p:nvSpPr>
         <p:spPr/>
@@ -1169,7 +968,7 @@
             <a:spLocks noGrp="1"/>
           </p:cNvSpPr>
           <p:nvPr>
-            <p:ph type="sldNum" idx="5" sz="quarter"/>
+            <p:ph type="sldNum" sz="quarter" idx="5"/>
           </p:nvPr>
         </p:nvSpPr>
         <p:spPr/>
@@ -1183,7 +982,7 @@
 </file>
 
 <file path=ppt/notesSlides/notesSlide19.xml><?xml version="1.0" encoding="utf-8"?>
-<p:notes xmlns:a="http://schemas.openxmlformats.org/drawingml/2006/main" xmlns:p="http://schemas.openxmlformats.org/presentationml/2006/main" xmlns:r="http://schemas.openxmlformats.org/officeDocument/2006/relationships">
+<p:notes xmlns:a="http://schemas.openxmlformats.org/drawingml/2006/main" xmlns:r="http://schemas.openxmlformats.org/officeDocument/2006/relationships" xmlns:p="http://schemas.openxmlformats.org/presentationml/2006/main">
   <p:cSld>
     <p:spTree>
       <p:nvGrpSpPr>
@@ -1203,7 +1002,7 @@
         <p:nvSpPr>
           <p:cNvPr id="2" name="Slide Image Placeholder 1"/>
           <p:cNvSpPr>
-            <a:spLocks noGrp="1"/>
+            <a:spLocks noGrp="1" noRot="1" noChangeAspect="1"/>
           </p:cNvSpPr>
           <p:nvPr>
             <p:ph type="sldImg" idx="2"/>
@@ -1218,7 +1017,7 @@
             <a:spLocks noGrp="1"/>
           </p:cNvSpPr>
           <p:nvPr>
-            <p:ph type="body" idx="3" sz="quarter"/>
+            <p:ph type="body" sz="quarter" idx="3"/>
           </p:nvPr>
         </p:nvSpPr>
         <p:spPr/>
@@ -1239,7 +1038,7 @@
             <a:spLocks noGrp="1"/>
           </p:cNvSpPr>
           <p:nvPr>
-            <p:ph type="sldNum" idx="5" sz="quarter"/>
+            <p:ph type="sldNum" sz="quarter" idx="5"/>
           </p:nvPr>
         </p:nvSpPr>
         <p:spPr/>
@@ -1253,7 +1052,7 @@
 </file>
 
 <file path=ppt/notesSlides/notesSlide2.xml><?xml version="1.0" encoding="utf-8"?>
-<p:notes xmlns:a="http://schemas.openxmlformats.org/drawingml/2006/main" xmlns:p="http://schemas.openxmlformats.org/presentationml/2006/main" xmlns:r="http://schemas.openxmlformats.org/officeDocument/2006/relationships">
+<p:notes xmlns:a="http://schemas.openxmlformats.org/drawingml/2006/main" xmlns:r="http://schemas.openxmlformats.org/officeDocument/2006/relationships" xmlns:p="http://schemas.openxmlformats.org/presentationml/2006/main">
   <p:cSld>
     <p:spTree>
       <p:nvGrpSpPr>
@@ -1273,7 +1072,7 @@
         <p:nvSpPr>
           <p:cNvPr id="2" name="Slide Image Placeholder 1"/>
           <p:cNvSpPr>
-            <a:spLocks noGrp="1"/>
+            <a:spLocks noGrp="1" noRot="1" noChangeAspect="1"/>
           </p:cNvSpPr>
           <p:nvPr>
             <p:ph type="sldImg" idx="2"/>
@@ -1288,7 +1087,7 @@
             <a:spLocks noGrp="1"/>
           </p:cNvSpPr>
           <p:nvPr>
-            <p:ph type="body" idx="3" sz="quarter"/>
+            <p:ph type="body" sz="quarter" idx="3"/>
           </p:nvPr>
         </p:nvSpPr>
         <p:spPr/>
@@ -1309,7 +1108,7 @@
             <a:spLocks noGrp="1"/>
           </p:cNvSpPr>
           <p:nvPr>
-            <p:ph type="sldNum" idx="5" sz="quarter"/>
+            <p:ph type="sldNum" sz="quarter" idx="5"/>
           </p:nvPr>
         </p:nvSpPr>
         <p:spPr/>
@@ -1323,7 +1122,7 @@
 </file>
 
 <file path=ppt/notesSlides/notesSlide20.xml><?xml version="1.0" encoding="utf-8"?>
-<p:notes xmlns:a="http://schemas.openxmlformats.org/drawingml/2006/main" xmlns:p="http://schemas.openxmlformats.org/presentationml/2006/main" xmlns:r="http://schemas.openxmlformats.org/officeDocument/2006/relationships">
+<p:notes xmlns:a="http://schemas.openxmlformats.org/drawingml/2006/main" xmlns:r="http://schemas.openxmlformats.org/officeDocument/2006/relationships" xmlns:p="http://schemas.openxmlformats.org/presentationml/2006/main">
   <p:cSld>
     <p:spTree>
       <p:nvGrpSpPr>
@@ -1343,7 +1142,7 @@
         <p:nvSpPr>
           <p:cNvPr id="2" name="Slide Image Placeholder 1"/>
           <p:cNvSpPr>
-            <a:spLocks noGrp="1"/>
+            <a:spLocks noGrp="1" noRot="1" noChangeAspect="1"/>
           </p:cNvSpPr>
           <p:nvPr>
             <p:ph type="sldImg" idx="2"/>
@@ -1358,7 +1157,7 @@
             <a:spLocks noGrp="1"/>
           </p:cNvSpPr>
           <p:nvPr>
-            <p:ph type="body" idx="3" sz="quarter"/>
+            <p:ph type="body" sz="quarter" idx="3"/>
           </p:nvPr>
         </p:nvSpPr>
         <p:spPr/>
@@ -1379,7 +1178,7 @@
             <a:spLocks noGrp="1"/>
           </p:cNvSpPr>
           <p:nvPr>
-            <p:ph type="sldNum" idx="5" sz="quarter"/>
+            <p:ph type="sldNum" sz="quarter" idx="5"/>
           </p:nvPr>
         </p:nvSpPr>
         <p:spPr/>
@@ -1393,7 +1192,7 @@
 </file>
 
 <file path=ppt/notesSlides/notesSlide21.xml><?xml version="1.0" encoding="utf-8"?>
-<p:notes xmlns:a="http://schemas.openxmlformats.org/drawingml/2006/main" xmlns:p="http://schemas.openxmlformats.org/presentationml/2006/main" xmlns:r="http://schemas.openxmlformats.org/officeDocument/2006/relationships">
+<p:notes xmlns:a="http://schemas.openxmlformats.org/drawingml/2006/main" xmlns:r="http://schemas.openxmlformats.org/officeDocument/2006/relationships" xmlns:p="http://schemas.openxmlformats.org/presentationml/2006/main">
   <p:cSld>
     <p:spTree>
       <p:nvGrpSpPr>
@@ -1413,7 +1212,7 @@
         <p:nvSpPr>
           <p:cNvPr id="2" name="Slide Image Placeholder 1"/>
           <p:cNvSpPr>
-            <a:spLocks noGrp="1"/>
+            <a:spLocks noGrp="1" noRot="1" noChangeAspect="1"/>
           </p:cNvSpPr>
           <p:nvPr>
             <p:ph type="sldImg" idx="2"/>
@@ -1428,7 +1227,7 @@
             <a:spLocks noGrp="1"/>
           </p:cNvSpPr>
           <p:nvPr>
-            <p:ph type="body" idx="3" sz="quarter"/>
+            <p:ph type="body" sz="quarter" idx="3"/>
           </p:nvPr>
         </p:nvSpPr>
         <p:spPr/>
@@ -1449,7 +1248,7 @@
             <a:spLocks noGrp="1"/>
           </p:cNvSpPr>
           <p:nvPr>
-            <p:ph type="sldNum" idx="5" sz="quarter"/>
+            <p:ph type="sldNum" sz="quarter" idx="5"/>
           </p:nvPr>
         </p:nvSpPr>
         <p:spPr/>
@@ -1463,7 +1262,7 @@
 </file>
 
 <file path=ppt/notesSlides/notesSlide22.xml><?xml version="1.0" encoding="utf-8"?>
-<p:notes xmlns:a="http://schemas.openxmlformats.org/drawingml/2006/main" xmlns:p="http://schemas.openxmlformats.org/presentationml/2006/main" xmlns:r="http://schemas.openxmlformats.org/officeDocument/2006/relationships">
+<p:notes xmlns:a="http://schemas.openxmlformats.org/drawingml/2006/main" xmlns:r="http://schemas.openxmlformats.org/officeDocument/2006/relationships" xmlns:p="http://schemas.openxmlformats.org/presentationml/2006/main">
   <p:cSld>
     <p:spTree>
       <p:nvGrpSpPr>
@@ -1483,7 +1282,7 @@
         <p:nvSpPr>
           <p:cNvPr id="2" name="Slide Image Placeholder 1"/>
           <p:cNvSpPr>
-            <a:spLocks noGrp="1"/>
+            <a:spLocks noGrp="1" noRot="1" noChangeAspect="1"/>
           </p:cNvSpPr>
           <p:nvPr>
             <p:ph type="sldImg" idx="2"/>
@@ -1498,7 +1297,7 @@
             <a:spLocks noGrp="1"/>
           </p:cNvSpPr>
           <p:nvPr>
-            <p:ph type="body" idx="3" sz="quarter"/>
+            <p:ph type="body" sz="quarter" idx="3"/>
           </p:nvPr>
         </p:nvSpPr>
         <p:spPr/>
@@ -1519,7 +1318,7 @@
             <a:spLocks noGrp="1"/>
           </p:cNvSpPr>
           <p:nvPr>
-            <p:ph type="sldNum" idx="5" sz="quarter"/>
+            <p:ph type="sldNum" sz="quarter" idx="5"/>
           </p:nvPr>
         </p:nvSpPr>
         <p:spPr/>
@@ -1533,7 +1332,7 @@
 </file>
 
 <file path=ppt/notesSlides/notesSlide23.xml><?xml version="1.0" encoding="utf-8"?>
-<p:notes xmlns:a="http://schemas.openxmlformats.org/drawingml/2006/main" xmlns:p="http://schemas.openxmlformats.org/presentationml/2006/main" xmlns:r="http://schemas.openxmlformats.org/officeDocument/2006/relationships">
+<p:notes xmlns:a="http://schemas.openxmlformats.org/drawingml/2006/main" xmlns:r="http://schemas.openxmlformats.org/officeDocument/2006/relationships" xmlns:p="http://schemas.openxmlformats.org/presentationml/2006/main">
   <p:cSld>
     <p:spTree>
       <p:nvGrpSpPr>
@@ -1553,7 +1352,7 @@
         <p:nvSpPr>
           <p:cNvPr id="2" name="Slide Image Placeholder 1"/>
           <p:cNvSpPr>
-            <a:spLocks noGrp="1"/>
+            <a:spLocks noGrp="1" noRot="1" noChangeAspect="1"/>
           </p:cNvSpPr>
           <p:nvPr>
             <p:ph type="sldImg" idx="2"/>
@@ -1568,7 +1367,7 @@
             <a:spLocks noGrp="1"/>
           </p:cNvSpPr>
           <p:nvPr>
-            <p:ph type="body" idx="3" sz="quarter"/>
+            <p:ph type="body" sz="quarter" idx="3"/>
           </p:nvPr>
         </p:nvSpPr>
         <p:spPr/>
@@ -1589,7 +1388,7 @@
             <a:spLocks noGrp="1"/>
           </p:cNvSpPr>
           <p:nvPr>
-            <p:ph type="sldNum" idx="5" sz="quarter"/>
+            <p:ph type="sldNum" sz="quarter" idx="5"/>
           </p:nvPr>
         </p:nvSpPr>
         <p:spPr/>
@@ -1603,7 +1402,7 @@
 </file>
 
 <file path=ppt/notesSlides/notesSlide24.xml><?xml version="1.0" encoding="utf-8"?>
-<p:notes xmlns:a="http://schemas.openxmlformats.org/drawingml/2006/main" xmlns:p="http://schemas.openxmlformats.org/presentationml/2006/main" xmlns:r="http://schemas.openxmlformats.org/officeDocument/2006/relationships">
+<p:notes xmlns:a="http://schemas.openxmlformats.org/drawingml/2006/main" xmlns:r="http://schemas.openxmlformats.org/officeDocument/2006/relationships" xmlns:p="http://schemas.openxmlformats.org/presentationml/2006/main">
   <p:cSld>
     <p:spTree>
       <p:nvGrpSpPr>
@@ -1623,7 +1422,7 @@
         <p:nvSpPr>
           <p:cNvPr id="2" name="Slide Image Placeholder 1"/>
           <p:cNvSpPr>
-            <a:spLocks noGrp="1"/>
+            <a:spLocks noGrp="1" noRot="1" noChangeAspect="1"/>
           </p:cNvSpPr>
           <p:nvPr>
             <p:ph type="sldImg" idx="2"/>
@@ -1638,7 +1437,7 @@
             <a:spLocks noGrp="1"/>
           </p:cNvSpPr>
           <p:nvPr>
-            <p:ph type="body" idx="3" sz="quarter"/>
+            <p:ph type="body" sz="quarter" idx="3"/>
           </p:nvPr>
         </p:nvSpPr>
         <p:spPr/>
@@ -1659,7 +1458,7 @@
             <a:spLocks noGrp="1"/>
           </p:cNvSpPr>
           <p:nvPr>
-            <p:ph type="sldNum" idx="5" sz="quarter"/>
+            <p:ph type="sldNum" sz="quarter" idx="5"/>
           </p:nvPr>
         </p:nvSpPr>
         <p:spPr/>
@@ -1673,7 +1472,7 @@
 </file>
 
 <file path=ppt/notesSlides/notesSlide25.xml><?xml version="1.0" encoding="utf-8"?>
-<p:notes xmlns:a="http://schemas.openxmlformats.org/drawingml/2006/main" xmlns:p="http://schemas.openxmlformats.org/presentationml/2006/main" xmlns:r="http://schemas.openxmlformats.org/officeDocument/2006/relationships">
+<p:notes xmlns:a="http://schemas.openxmlformats.org/drawingml/2006/main" xmlns:r="http://schemas.openxmlformats.org/officeDocument/2006/relationships" xmlns:p="http://schemas.openxmlformats.org/presentationml/2006/main">
   <p:cSld>
     <p:spTree>
       <p:nvGrpSpPr>
@@ -1693,7 +1492,7 @@
         <p:nvSpPr>
           <p:cNvPr id="2" name="Slide Image Placeholder 1"/>
           <p:cNvSpPr>
-            <a:spLocks noGrp="1"/>
+            <a:spLocks noGrp="1" noRot="1" noChangeAspect="1"/>
           </p:cNvSpPr>
           <p:nvPr>
             <p:ph type="sldImg" idx="2"/>
@@ -1708,7 +1507,7 @@
             <a:spLocks noGrp="1"/>
           </p:cNvSpPr>
           <p:nvPr>
-            <p:ph type="body" idx="3" sz="quarter"/>
+            <p:ph type="body" sz="quarter" idx="3"/>
           </p:nvPr>
         </p:nvSpPr>
         <p:spPr/>
@@ -1729,7 +1528,7 @@
             <a:spLocks noGrp="1"/>
           </p:cNvSpPr>
           <p:nvPr>
-            <p:ph type="sldNum" idx="5" sz="quarter"/>
+            <p:ph type="sldNum" sz="quarter" idx="5"/>
           </p:nvPr>
         </p:nvSpPr>
         <p:spPr/>
@@ -1743,7 +1542,7 @@
 </file>
 
 <file path=ppt/notesSlides/notesSlide26.xml><?xml version="1.0" encoding="utf-8"?>
-<p:notes xmlns:a="http://schemas.openxmlformats.org/drawingml/2006/main" xmlns:p="http://schemas.openxmlformats.org/presentationml/2006/main" xmlns:r="http://schemas.openxmlformats.org/officeDocument/2006/relationships">
+<p:notes xmlns:a="http://schemas.openxmlformats.org/drawingml/2006/main" xmlns:r="http://schemas.openxmlformats.org/officeDocument/2006/relationships" xmlns:p="http://schemas.openxmlformats.org/presentationml/2006/main">
   <p:cSld>
     <p:spTree>
       <p:nvGrpSpPr>
@@ -1763,7 +1562,7 @@
         <p:nvSpPr>
           <p:cNvPr id="2" name="Slide Image Placeholder 1"/>
           <p:cNvSpPr>
-            <a:spLocks noGrp="1"/>
+            <a:spLocks noGrp="1" noRot="1" noChangeAspect="1"/>
           </p:cNvSpPr>
           <p:nvPr>
             <p:ph type="sldImg" idx="2"/>
@@ -1778,7 +1577,7 @@
             <a:spLocks noGrp="1"/>
           </p:cNvSpPr>
           <p:nvPr>
-            <p:ph type="body" idx="3" sz="quarter"/>
+            <p:ph type="body" sz="quarter" idx="3"/>
           </p:nvPr>
         </p:nvSpPr>
         <p:spPr/>
@@ -1799,7 +1598,7 @@
             <a:spLocks noGrp="1"/>
           </p:cNvSpPr>
           <p:nvPr>
-            <p:ph type="sldNum" idx="5" sz="quarter"/>
+            <p:ph type="sldNum" sz="quarter" idx="5"/>
           </p:nvPr>
         </p:nvSpPr>
         <p:spPr/>
@@ -1813,7 +1612,7 @@
 </file>
 
 <file path=ppt/notesSlides/notesSlide3.xml><?xml version="1.0" encoding="utf-8"?>
-<p:notes xmlns:a="http://schemas.openxmlformats.org/drawingml/2006/main" xmlns:p="http://schemas.openxmlformats.org/presentationml/2006/main" xmlns:r="http://schemas.openxmlformats.org/officeDocument/2006/relationships">
+<p:notes xmlns:a="http://schemas.openxmlformats.org/drawingml/2006/main" xmlns:r="http://schemas.openxmlformats.org/officeDocument/2006/relationships" xmlns:p="http://schemas.openxmlformats.org/presentationml/2006/main">
   <p:cSld>
     <p:spTree>
       <p:nvGrpSpPr>
@@ -1833,7 +1632,7 @@
         <p:nvSpPr>
           <p:cNvPr id="2" name="Slide Image Placeholder 1"/>
           <p:cNvSpPr>
-            <a:spLocks noGrp="1"/>
+            <a:spLocks noGrp="1" noRot="1" noChangeAspect="1"/>
           </p:cNvSpPr>
           <p:nvPr>
             <p:ph type="sldImg" idx="2"/>
@@ -1848,7 +1647,7 @@
             <a:spLocks noGrp="1"/>
           </p:cNvSpPr>
           <p:nvPr>
-            <p:ph type="body" idx="3" sz="quarter"/>
+            <p:ph type="body" sz="quarter" idx="3"/>
           </p:nvPr>
         </p:nvSpPr>
         <p:spPr/>
@@ -1869,7 +1668,7 @@
             <a:spLocks noGrp="1"/>
           </p:cNvSpPr>
           <p:nvPr>
-            <p:ph type="sldNum" idx="5" sz="quarter"/>
+            <p:ph type="sldNum" sz="quarter" idx="5"/>
           </p:nvPr>
         </p:nvSpPr>
         <p:spPr/>
@@ -1883,7 +1682,7 @@
 </file>
 
 <file path=ppt/notesSlides/notesSlide4.xml><?xml version="1.0" encoding="utf-8"?>
-<p:notes xmlns:a="http://schemas.openxmlformats.org/drawingml/2006/main" xmlns:p="http://schemas.openxmlformats.org/presentationml/2006/main" xmlns:r="http://schemas.openxmlformats.org/officeDocument/2006/relationships">
+<p:notes xmlns:a="http://schemas.openxmlformats.org/drawingml/2006/main" xmlns:r="http://schemas.openxmlformats.org/officeDocument/2006/relationships" xmlns:p="http://schemas.openxmlformats.org/presentationml/2006/main">
   <p:cSld>
     <p:spTree>
       <p:nvGrpSpPr>
@@ -1903,7 +1702,7 @@
         <p:nvSpPr>
           <p:cNvPr id="2" name="Slide Image Placeholder 1"/>
           <p:cNvSpPr>
-            <a:spLocks noGrp="1"/>
+            <a:spLocks noGrp="1" noRot="1" noChangeAspect="1"/>
           </p:cNvSpPr>
           <p:nvPr>
             <p:ph type="sldImg" idx="2"/>
@@ -1918,7 +1717,7 @@
             <a:spLocks noGrp="1"/>
           </p:cNvSpPr>
           <p:nvPr>
-            <p:ph type="body" idx="3" sz="quarter"/>
+            <p:ph type="body" sz="quarter" idx="3"/>
           </p:nvPr>
         </p:nvSpPr>
         <p:spPr/>
@@ -1927,7 +1726,21 @@
           <a:lstStyle/>
           <a:p>
             <a:r>
-              <a:t>(0:28–0:32) Son accueil montre l’album et les paliers du Club.</a:t>
+              <a:t>(0:28–0:32) Son accueil montre </a:t>
+            </a:r>
+            <a:r>
+              <a:rPr lang="en-US"/>
+              <a:t>les prochains evenements, le nombre de personnes rencontrees dans le club</a:t>
+            </a:r>
+            <a:r>
+              <a:t> et les paliers d</a:t>
+            </a:r>
+            <a:r>
+              <a:rPr lang="en-US"/>
+              <a:t>u club</a:t>
+            </a:r>
+            <a:r>
+              <a:t>.</a:t>
             </a:r>
           </a:p>
         </p:txBody>
@@ -1939,7 +1752,7 @@
             <a:spLocks noGrp="1"/>
           </p:cNvSpPr>
           <p:nvPr>
-            <p:ph type="sldNum" idx="5" sz="quarter"/>
+            <p:ph type="sldNum" sz="quarter" idx="5"/>
           </p:nvPr>
         </p:nvSpPr>
         <p:spPr/>
@@ -1953,7 +1766,7 @@
 </file>
 
 <file path=ppt/notesSlides/notesSlide5.xml><?xml version="1.0" encoding="utf-8"?>
-<p:notes xmlns:a="http://schemas.openxmlformats.org/drawingml/2006/main" xmlns:p="http://schemas.openxmlformats.org/presentationml/2006/main" xmlns:r="http://schemas.openxmlformats.org/officeDocument/2006/relationships">
+<p:notes xmlns:a="http://schemas.openxmlformats.org/drawingml/2006/main" xmlns:r="http://schemas.openxmlformats.org/officeDocument/2006/relationships" xmlns:p="http://schemas.openxmlformats.org/presentationml/2006/main">
   <p:cSld>
     <p:spTree>
       <p:nvGrpSpPr>
@@ -1973,7 +1786,7 @@
         <p:nvSpPr>
           <p:cNvPr id="2" name="Slide Image Placeholder 1"/>
           <p:cNvSpPr>
-            <a:spLocks noGrp="1"/>
+            <a:spLocks noGrp="1" noRot="1" noChangeAspect="1"/>
           </p:cNvSpPr>
           <p:nvPr>
             <p:ph type="sldImg" idx="2"/>
@@ -1988,7 +1801,7 @@
             <a:spLocks noGrp="1"/>
           </p:cNvSpPr>
           <p:nvPr>
-            <p:ph type="body" idx="3" sz="quarter"/>
+            <p:ph type="body" sz="quarter" idx="3"/>
           </p:nvPr>
         </p:nvSpPr>
         <p:spPr/>
@@ -1997,7 +1810,28 @@
           <a:lstStyle/>
           <a:p>
             <a:r>
-              <a:t>(0:32–0:35) Dans l’album, elle découvre les membres.</a:t>
+              <a:t>(0:32–0:35) </a:t>
+            </a:r>
+            <a:r>
+              <a:rPr lang="en-US"/>
+              <a:t>E</a:t>
+            </a:r>
+            <a:r>
+              <a:t>lle découvre les memb</a:t>
+            </a:r>
+            <a:r>
+              <a:rPr lang="fr-CH"/>
+              <a:t>er</a:t>
+            </a:r>
+            <a:r>
+              <a:t>s</a:t>
+            </a:r>
+            <a:r>
+              <a:rPr lang="en-US"/>
+              <a:t> dans l’album</a:t>
+            </a:r>
+            <a:r>
+              <a:t>.</a:t>
             </a:r>
           </a:p>
         </p:txBody>
@@ -2009,7 +1843,7 @@
             <a:spLocks noGrp="1"/>
           </p:cNvSpPr>
           <p:nvPr>
-            <p:ph type="sldNum" idx="5" sz="quarter"/>
+            <p:ph type="sldNum" sz="quarter" idx="5"/>
           </p:nvPr>
         </p:nvSpPr>
         <p:spPr/>
@@ -2023,7 +1857,7 @@
 </file>
 
 <file path=ppt/notesSlides/notesSlide6.xml><?xml version="1.0" encoding="utf-8"?>
-<p:notes xmlns:a="http://schemas.openxmlformats.org/drawingml/2006/main" xmlns:p="http://schemas.openxmlformats.org/presentationml/2006/main" xmlns:r="http://schemas.openxmlformats.org/officeDocument/2006/relationships">
+<p:notes xmlns:a="http://schemas.openxmlformats.org/drawingml/2006/main" xmlns:r="http://schemas.openxmlformats.org/officeDocument/2006/relationships" xmlns:p="http://schemas.openxmlformats.org/presentationml/2006/main">
   <p:cSld>
     <p:spTree>
       <p:nvGrpSpPr>
@@ -2043,7 +1877,7 @@
         <p:nvSpPr>
           <p:cNvPr id="2" name="Slide Image Placeholder 1"/>
           <p:cNvSpPr>
-            <a:spLocks noGrp="1"/>
+            <a:spLocks noGrp="1" noRot="1" noChangeAspect="1"/>
           </p:cNvSpPr>
           <p:nvPr>
             <p:ph type="sldImg" idx="2"/>
@@ -2058,7 +1892,7 @@
             <a:spLocks noGrp="1"/>
           </p:cNvSpPr>
           <p:nvPr>
-            <p:ph type="body" idx="3" sz="quarter"/>
+            <p:ph type="body" sz="quarter" idx="3"/>
           </p:nvPr>
         </p:nvSpPr>
         <p:spPr/>
@@ -2079,7 +1913,7 @@
             <a:spLocks noGrp="1"/>
           </p:cNvSpPr>
           <p:nvPr>
-            <p:ph type="sldNum" idx="5" sz="quarter"/>
+            <p:ph type="sldNum" sz="quarter" idx="5"/>
           </p:nvPr>
         </p:nvSpPr>
         <p:spPr/>
@@ -2093,7 +1927,7 @@
 </file>
 
 <file path=ppt/notesSlides/notesSlide7.xml><?xml version="1.0" encoding="utf-8"?>
-<p:notes xmlns:a="http://schemas.openxmlformats.org/drawingml/2006/main" xmlns:p="http://schemas.openxmlformats.org/presentationml/2006/main" xmlns:r="http://schemas.openxmlformats.org/officeDocument/2006/relationships">
+<p:notes xmlns:a="http://schemas.openxmlformats.org/drawingml/2006/main" xmlns:r="http://schemas.openxmlformats.org/officeDocument/2006/relationships" xmlns:p="http://schemas.openxmlformats.org/presentationml/2006/main">
   <p:cSld>
     <p:spTree>
       <p:nvGrpSpPr>
@@ -2113,7 +1947,7 @@
         <p:nvSpPr>
           <p:cNvPr id="2" name="Slide Image Placeholder 1"/>
           <p:cNvSpPr>
-            <a:spLocks noGrp="1"/>
+            <a:spLocks noGrp="1" noRot="1" noChangeAspect="1"/>
           </p:cNvSpPr>
           <p:nvPr>
             <p:ph type="sldImg" idx="2"/>
@@ -2128,7 +1962,7 @@
             <a:spLocks noGrp="1"/>
           </p:cNvSpPr>
           <p:nvPr>
-            <p:ph type="body" idx="3" sz="quarter"/>
+            <p:ph type="body" sz="quarter" idx="3"/>
           </p:nvPr>
         </p:nvSpPr>
         <p:spPr/>
@@ -2149,7 +1983,7 @@
             <a:spLocks noGrp="1"/>
           </p:cNvSpPr>
           <p:nvPr>
-            <p:ph type="sldNum" idx="5" sz="quarter"/>
+            <p:ph type="sldNum" sz="quarter" idx="5"/>
           </p:nvPr>
         </p:nvSpPr>
         <p:spPr/>
@@ -2163,7 +1997,7 @@
 </file>
 
 <file path=ppt/notesSlides/notesSlide8.xml><?xml version="1.0" encoding="utf-8"?>
-<p:notes xmlns:a="http://schemas.openxmlformats.org/drawingml/2006/main" xmlns:p="http://schemas.openxmlformats.org/presentationml/2006/main" xmlns:r="http://schemas.openxmlformats.org/officeDocument/2006/relationships">
+<p:notes xmlns:a="http://schemas.openxmlformats.org/drawingml/2006/main" xmlns:r="http://schemas.openxmlformats.org/officeDocument/2006/relationships" xmlns:p="http://schemas.openxmlformats.org/presentationml/2006/main">
   <p:cSld>
     <p:spTree>
       <p:nvGrpSpPr>
@@ -2183,7 +2017,7 @@
         <p:nvSpPr>
           <p:cNvPr id="2" name="Slide Image Placeholder 1"/>
           <p:cNvSpPr>
-            <a:spLocks noGrp="1"/>
+            <a:spLocks noGrp="1" noRot="1" noChangeAspect="1"/>
           </p:cNvSpPr>
           <p:nvPr>
             <p:ph type="sldImg" idx="2"/>
@@ -2198,7 +2032,7 @@
             <a:spLocks noGrp="1"/>
           </p:cNvSpPr>
           <p:nvPr>
-            <p:ph type="body" idx="3" sz="quarter"/>
+            <p:ph type="body" sz="quarter" idx="3"/>
           </p:nvPr>
         </p:nvSpPr>
         <p:spPr/>
@@ -2219,7 +2053,7 @@
             <a:spLocks noGrp="1"/>
           </p:cNvSpPr>
           <p:nvPr>
-            <p:ph type="sldNum" idx="5" sz="quarter"/>
+            <p:ph type="sldNum" sz="quarter" idx="5"/>
           </p:nvPr>
         </p:nvSpPr>
         <p:spPr/>
@@ -2233,7 +2067,7 @@
 </file>
 
 <file path=ppt/notesSlides/notesSlide9.xml><?xml version="1.0" encoding="utf-8"?>
-<p:notes xmlns:a="http://schemas.openxmlformats.org/drawingml/2006/main" xmlns:p="http://schemas.openxmlformats.org/presentationml/2006/main" xmlns:r="http://schemas.openxmlformats.org/officeDocument/2006/relationships">
+<p:notes xmlns:a="http://schemas.openxmlformats.org/drawingml/2006/main" xmlns:r="http://schemas.openxmlformats.org/officeDocument/2006/relationships" xmlns:p="http://schemas.openxmlformats.org/presentationml/2006/main">
   <p:cSld>
     <p:spTree>
       <p:nvGrpSpPr>
@@ -2253,7 +2087,7 @@
         <p:nvSpPr>
           <p:cNvPr id="2" name="Slide Image Placeholder 1"/>
           <p:cNvSpPr>
-            <a:spLocks noGrp="1"/>
+            <a:spLocks noGrp="1" noRot="1" noChangeAspect="1"/>
           </p:cNvSpPr>
           <p:nvPr>
             <p:ph type="sldImg" idx="2"/>
@@ -2268,7 +2102,7 @@
             <a:spLocks noGrp="1"/>
           </p:cNvSpPr>
           <p:nvPr>
-            <p:ph type="body" idx="3" sz="quarter"/>
+            <p:ph type="body" sz="quarter" idx="3"/>
           </p:nvPr>
         </p:nvSpPr>
         <p:spPr/>
@@ -2289,7 +2123,7 @@
             <a:spLocks noGrp="1"/>
           </p:cNvSpPr>
           <p:nvPr>
-            <p:ph type="sldNum" idx="5" sz="quarter"/>
+            <p:ph type="sldNum" sz="quarter" idx="5"/>
           </p:nvPr>
         </p:nvSpPr>
         <p:spPr/>
@@ -2340,10 +2174,9 @@
           <a:lstStyle/>
           <a:p>
             <a:r>
-              <a:rPr lang="en-US" smtClean="0"/>
+              <a:rPr lang="en-US"/>
               <a:t>Click to edit Master title style</a:t>
             </a:r>
-            <a:endParaRPr lang="en-US"/>
           </a:p>
         </p:txBody>
       </p:sp>
@@ -2459,10 +2292,9 @@
           </a:lstStyle>
           <a:p>
             <a:r>
-              <a:rPr lang="en-US" smtClean="0"/>
+              <a:rPr lang="en-US"/>
               <a:t>Click to edit Master subtitle style</a:t>
             </a:r>
-            <a:endParaRPr lang="en-US"/>
           </a:p>
         </p:txBody>
       </p:sp>
@@ -2483,7 +2315,7 @@
           <a:p>
             <a:fld id="{5BCAD085-E8A6-8845-BD4E-CB4CCA059FC4}" type="datetimeFigureOut">
               <a:rPr lang="en-US" smtClean="0"/>
-              <a:t>1/27/13</a:t>
+              <a:t>10/4/26</a:t>
             </a:fld>
             <a:endParaRPr lang="en-US"/>
           </a:p>
@@ -2525,7 +2357,7 @@
           <a:p>
             <a:fld id="{C1FF6DA9-008F-8B48-92A6-B652298478BF}" type="slidenum">
               <a:rPr lang="en-US" smtClean="0"/>
-              <a:t>‹#›</a:t>
+              <a:t>‹N°›</a:t>
             </a:fld>
             <a:endParaRPr lang="en-US"/>
           </a:p>
@@ -2577,10 +2409,9 @@
           <a:lstStyle/>
           <a:p>
             <a:r>
-              <a:rPr lang="en-US" smtClean="0"/>
+              <a:rPr lang="en-US"/>
               <a:t>Click to edit Master title style</a:t>
             </a:r>
-            <a:endParaRPr lang="en-US"/>
           </a:p>
         </p:txBody>
       </p:sp>
@@ -2601,38 +2432,37 @@
           <a:p>
             <a:pPr lvl="0"/>
             <a:r>
-              <a:rPr lang="en-US" smtClean="0"/>
+              <a:rPr lang="en-US"/>
               <a:t>Click to edit Master text styles</a:t>
             </a:r>
           </a:p>
           <a:p>
             <a:pPr lvl="1"/>
             <a:r>
-              <a:rPr lang="en-US" smtClean="0"/>
+              <a:rPr lang="en-US"/>
               <a:t>Second level</a:t>
             </a:r>
           </a:p>
           <a:p>
             <a:pPr lvl="2"/>
             <a:r>
-              <a:rPr lang="en-US" smtClean="0"/>
+              <a:rPr lang="en-US"/>
               <a:t>Third level</a:t>
             </a:r>
           </a:p>
           <a:p>
             <a:pPr lvl="3"/>
             <a:r>
-              <a:rPr lang="en-US" smtClean="0"/>
+              <a:rPr lang="en-US"/>
               <a:t>Fourth level</a:t>
             </a:r>
           </a:p>
           <a:p>
             <a:pPr lvl="4"/>
             <a:r>
-              <a:rPr lang="en-US" smtClean="0"/>
+              <a:rPr lang="en-US"/>
               <a:t>Fifth level</a:t>
             </a:r>
-            <a:endParaRPr lang="en-US"/>
           </a:p>
         </p:txBody>
       </p:sp>
@@ -2653,7 +2483,7 @@
           <a:p>
             <a:fld id="{5BCAD085-E8A6-8845-BD4E-CB4CCA059FC4}" type="datetimeFigureOut">
               <a:rPr lang="en-US" smtClean="0"/>
-              <a:t>1/27/13</a:t>
+              <a:t>10/4/26</a:t>
             </a:fld>
             <a:endParaRPr lang="en-US"/>
           </a:p>
@@ -2695,7 +2525,7 @@
           <a:p>
             <a:fld id="{C1FF6DA9-008F-8B48-92A6-B652298478BF}" type="slidenum">
               <a:rPr lang="en-US" smtClean="0"/>
-              <a:t>‹#›</a:t>
+              <a:t>‹N°›</a:t>
             </a:fld>
             <a:endParaRPr lang="en-US"/>
           </a:p>
@@ -2752,10 +2582,9 @@
           <a:lstStyle/>
           <a:p>
             <a:r>
-              <a:rPr lang="en-US" smtClean="0"/>
+              <a:rPr lang="en-US"/>
               <a:t>Click to edit Master title style</a:t>
             </a:r>
-            <a:endParaRPr lang="en-US"/>
           </a:p>
         </p:txBody>
       </p:sp>
@@ -2781,38 +2610,37 @@
           <a:p>
             <a:pPr lvl="0"/>
             <a:r>
-              <a:rPr lang="en-US" smtClean="0"/>
+              <a:rPr lang="en-US"/>
               <a:t>Click to edit Master text styles</a:t>
             </a:r>
           </a:p>
           <a:p>
             <a:pPr lvl="1"/>
             <a:r>
-              <a:rPr lang="en-US" smtClean="0"/>
+              <a:rPr lang="en-US"/>
               <a:t>Second level</a:t>
             </a:r>
           </a:p>
           <a:p>
             <a:pPr lvl="2"/>
             <a:r>
-              <a:rPr lang="en-US" smtClean="0"/>
+              <a:rPr lang="en-US"/>
               <a:t>Third level</a:t>
             </a:r>
           </a:p>
           <a:p>
             <a:pPr lvl="3"/>
             <a:r>
-              <a:rPr lang="en-US" smtClean="0"/>
+              <a:rPr lang="en-US"/>
               <a:t>Fourth level</a:t>
             </a:r>
           </a:p>
           <a:p>
             <a:pPr lvl="4"/>
             <a:r>
-              <a:rPr lang="en-US" smtClean="0"/>
+              <a:rPr lang="en-US"/>
               <a:t>Fifth level</a:t>
             </a:r>
-            <a:endParaRPr lang="en-US"/>
           </a:p>
         </p:txBody>
       </p:sp>
@@ -2833,7 +2661,7 @@
           <a:p>
             <a:fld id="{5BCAD085-E8A6-8845-BD4E-CB4CCA059FC4}" type="datetimeFigureOut">
               <a:rPr lang="en-US" smtClean="0"/>
-              <a:t>1/27/13</a:t>
+              <a:t>10/4/26</a:t>
             </a:fld>
             <a:endParaRPr lang="en-US"/>
           </a:p>
@@ -2875,7 +2703,7 @@
           <a:p>
             <a:fld id="{C1FF6DA9-008F-8B48-92A6-B652298478BF}" type="slidenum">
               <a:rPr lang="en-US" smtClean="0"/>
-              <a:t>‹#›</a:t>
+              <a:t>‹N°›</a:t>
             </a:fld>
             <a:endParaRPr lang="en-US"/>
           </a:p>
@@ -2927,10 +2755,9 @@
           <a:lstStyle/>
           <a:p>
             <a:r>
-              <a:rPr lang="en-US" smtClean="0"/>
+              <a:rPr lang="en-US"/>
               <a:t>Click to edit Master title style</a:t>
             </a:r>
-            <a:endParaRPr lang="en-US"/>
           </a:p>
         </p:txBody>
       </p:sp>
@@ -2951,38 +2778,37 @@
           <a:p>
             <a:pPr lvl="0"/>
             <a:r>
-              <a:rPr lang="en-US" smtClean="0"/>
+              <a:rPr lang="en-US"/>
               <a:t>Click to edit Master text styles</a:t>
             </a:r>
           </a:p>
           <a:p>
             <a:pPr lvl="1"/>
             <a:r>
-              <a:rPr lang="en-US" smtClean="0"/>
+              <a:rPr lang="en-US"/>
               <a:t>Second level</a:t>
             </a:r>
           </a:p>
           <a:p>
             <a:pPr lvl="2"/>
             <a:r>
-              <a:rPr lang="en-US" smtClean="0"/>
+              <a:rPr lang="en-US"/>
               <a:t>Third level</a:t>
             </a:r>
           </a:p>
           <a:p>
             <a:pPr lvl="3"/>
             <a:r>
-              <a:rPr lang="en-US" smtClean="0"/>
+              <a:rPr lang="en-US"/>
               <a:t>Fourth level</a:t>
             </a:r>
           </a:p>
           <a:p>
             <a:pPr lvl="4"/>
             <a:r>
-              <a:rPr lang="en-US" smtClean="0"/>
+              <a:rPr lang="en-US"/>
               <a:t>Fifth level</a:t>
             </a:r>
-            <a:endParaRPr lang="en-US"/>
           </a:p>
         </p:txBody>
       </p:sp>
@@ -3003,7 +2829,7 @@
           <a:p>
             <a:fld id="{5BCAD085-E8A6-8845-BD4E-CB4CCA059FC4}" type="datetimeFigureOut">
               <a:rPr lang="en-US" smtClean="0"/>
-              <a:t>1/27/13</a:t>
+              <a:t>10/4/26</a:t>
             </a:fld>
             <a:endParaRPr lang="en-US"/>
           </a:p>
@@ -3045,7 +2871,7 @@
           <a:p>
             <a:fld id="{C1FF6DA9-008F-8B48-92A6-B652298478BF}" type="slidenum">
               <a:rPr lang="en-US" smtClean="0"/>
-              <a:t>‹#›</a:t>
+              <a:t>‹N°›</a:t>
             </a:fld>
             <a:endParaRPr lang="en-US"/>
           </a:p>
@@ -3106,10 +2932,9 @@
           </a:lstStyle>
           <a:p>
             <a:r>
-              <a:rPr lang="en-US" smtClean="0"/>
+              <a:rPr lang="en-US"/>
               <a:t>Click to edit Master title style</a:t>
             </a:r>
-            <a:endParaRPr lang="en-US"/>
           </a:p>
         </p:txBody>
       </p:sp>
@@ -3226,7 +3051,7 @@
           <a:p>
             <a:pPr lvl="0"/>
             <a:r>
-              <a:rPr lang="en-US" smtClean="0"/>
+              <a:rPr lang="en-US"/>
               <a:t>Click to edit Master text styles</a:t>
             </a:r>
           </a:p>
@@ -3249,7 +3074,7 @@
           <a:p>
             <a:fld id="{5BCAD085-E8A6-8845-BD4E-CB4CCA059FC4}" type="datetimeFigureOut">
               <a:rPr lang="en-US" smtClean="0"/>
-              <a:t>1/27/13</a:t>
+              <a:t>10/4/26</a:t>
             </a:fld>
             <a:endParaRPr lang="en-US"/>
           </a:p>
@@ -3291,7 +3116,7 @@
           <a:p>
             <a:fld id="{C1FF6DA9-008F-8B48-92A6-B652298478BF}" type="slidenum">
               <a:rPr lang="en-US" smtClean="0"/>
-              <a:t>‹#›</a:t>
+              <a:t>‹N°›</a:t>
             </a:fld>
             <a:endParaRPr lang="en-US"/>
           </a:p>
@@ -3343,10 +3168,9 @@
           <a:lstStyle/>
           <a:p>
             <a:r>
-              <a:rPr lang="en-US" smtClean="0"/>
+              <a:rPr lang="en-US"/>
               <a:t>Click to edit Master title style</a:t>
             </a:r>
-            <a:endParaRPr lang="en-US"/>
           </a:p>
         </p:txBody>
       </p:sp>
@@ -3400,38 +3224,37 @@
           <a:p>
             <a:pPr lvl="0"/>
             <a:r>
-              <a:rPr lang="en-US" smtClean="0"/>
+              <a:rPr lang="en-US"/>
               <a:t>Click to edit Master text styles</a:t>
             </a:r>
           </a:p>
           <a:p>
             <a:pPr lvl="1"/>
             <a:r>
-              <a:rPr lang="en-US" smtClean="0"/>
+              <a:rPr lang="en-US"/>
               <a:t>Second level</a:t>
             </a:r>
           </a:p>
           <a:p>
             <a:pPr lvl="2"/>
             <a:r>
-              <a:rPr lang="en-US" smtClean="0"/>
+              <a:rPr lang="en-US"/>
               <a:t>Third level</a:t>
             </a:r>
           </a:p>
           <a:p>
             <a:pPr lvl="3"/>
             <a:r>
-              <a:rPr lang="en-US" smtClean="0"/>
+              <a:rPr lang="en-US"/>
               <a:t>Fourth level</a:t>
             </a:r>
           </a:p>
           <a:p>
             <a:pPr lvl="4"/>
             <a:r>
-              <a:rPr lang="en-US" smtClean="0"/>
+              <a:rPr lang="en-US"/>
               <a:t>Fifth level</a:t>
             </a:r>
-            <a:endParaRPr lang="en-US"/>
           </a:p>
         </p:txBody>
       </p:sp>
@@ -3485,38 +3308,37 @@
           <a:p>
             <a:pPr lvl="0"/>
             <a:r>
-              <a:rPr lang="en-US" smtClean="0"/>
+              <a:rPr lang="en-US"/>
               <a:t>Click to edit Master text styles</a:t>
             </a:r>
           </a:p>
           <a:p>
             <a:pPr lvl="1"/>
             <a:r>
-              <a:rPr lang="en-US" smtClean="0"/>
+              <a:rPr lang="en-US"/>
               <a:t>Second level</a:t>
             </a:r>
           </a:p>
           <a:p>
             <a:pPr lvl="2"/>
             <a:r>
-              <a:rPr lang="en-US" smtClean="0"/>
+              <a:rPr lang="en-US"/>
               <a:t>Third level</a:t>
             </a:r>
           </a:p>
           <a:p>
             <a:pPr lvl="3"/>
             <a:r>
-              <a:rPr lang="en-US" smtClean="0"/>
+              <a:rPr lang="en-US"/>
               <a:t>Fourth level</a:t>
             </a:r>
           </a:p>
           <a:p>
             <a:pPr lvl="4"/>
             <a:r>
-              <a:rPr lang="en-US" smtClean="0"/>
+              <a:rPr lang="en-US"/>
               <a:t>Fifth level</a:t>
             </a:r>
-            <a:endParaRPr lang="en-US"/>
           </a:p>
         </p:txBody>
       </p:sp>
@@ -3537,7 +3359,7 @@
           <a:p>
             <a:fld id="{5BCAD085-E8A6-8845-BD4E-CB4CCA059FC4}" type="datetimeFigureOut">
               <a:rPr lang="en-US" smtClean="0"/>
-              <a:t>1/27/13</a:t>
+              <a:t>10/4/26</a:t>
             </a:fld>
             <a:endParaRPr lang="en-US"/>
           </a:p>
@@ -3579,7 +3401,7 @@
           <a:p>
             <a:fld id="{C1FF6DA9-008F-8B48-92A6-B652298478BF}" type="slidenum">
               <a:rPr lang="en-US" smtClean="0"/>
-              <a:t>‹#›</a:t>
+              <a:t>‹N°›</a:t>
             </a:fld>
             <a:endParaRPr lang="en-US"/>
           </a:p>
@@ -3635,10 +3457,9 @@
           </a:lstStyle>
           <a:p>
             <a:r>
-              <a:rPr lang="en-US" smtClean="0"/>
+              <a:rPr lang="en-US"/>
               <a:t>Click to edit Master title style</a:t>
             </a:r>
-            <a:endParaRPr lang="en-US"/>
           </a:p>
         </p:txBody>
       </p:sp>
@@ -3701,7 +3522,7 @@
           <a:p>
             <a:pPr lvl="0"/>
             <a:r>
-              <a:rPr lang="en-US" smtClean="0"/>
+              <a:rPr lang="en-US"/>
               <a:t>Click to edit Master text styles</a:t>
             </a:r>
           </a:p>
@@ -3757,38 +3578,37 @@
           <a:p>
             <a:pPr lvl="0"/>
             <a:r>
-              <a:rPr lang="en-US" smtClean="0"/>
+              <a:rPr lang="en-US"/>
               <a:t>Click to edit Master text styles</a:t>
             </a:r>
           </a:p>
           <a:p>
             <a:pPr lvl="1"/>
             <a:r>
-              <a:rPr lang="en-US" smtClean="0"/>
+              <a:rPr lang="en-US"/>
               <a:t>Second level</a:t>
             </a:r>
           </a:p>
           <a:p>
             <a:pPr lvl="2"/>
             <a:r>
-              <a:rPr lang="en-US" smtClean="0"/>
+              <a:rPr lang="en-US"/>
               <a:t>Third level</a:t>
             </a:r>
           </a:p>
           <a:p>
             <a:pPr lvl="3"/>
             <a:r>
-              <a:rPr lang="en-US" smtClean="0"/>
+              <a:rPr lang="en-US"/>
               <a:t>Fourth level</a:t>
             </a:r>
           </a:p>
           <a:p>
             <a:pPr lvl="4"/>
             <a:r>
-              <a:rPr lang="en-US" smtClean="0"/>
+              <a:rPr lang="en-US"/>
               <a:t>Fifth level</a:t>
             </a:r>
-            <a:endParaRPr lang="en-US"/>
           </a:p>
         </p:txBody>
       </p:sp>
@@ -3851,7 +3671,7 @@
           <a:p>
             <a:pPr lvl="0"/>
             <a:r>
-              <a:rPr lang="en-US" smtClean="0"/>
+              <a:rPr lang="en-US"/>
               <a:t>Click to edit Master text styles</a:t>
             </a:r>
           </a:p>
@@ -3907,38 +3727,37 @@
           <a:p>
             <a:pPr lvl="0"/>
             <a:r>
-              <a:rPr lang="en-US" smtClean="0"/>
+              <a:rPr lang="en-US"/>
               <a:t>Click to edit Master text styles</a:t>
             </a:r>
           </a:p>
           <a:p>
             <a:pPr lvl="1"/>
             <a:r>
-              <a:rPr lang="en-US" smtClean="0"/>
+              <a:rPr lang="en-US"/>
               <a:t>Second level</a:t>
             </a:r>
           </a:p>
           <a:p>
             <a:pPr lvl="2"/>
             <a:r>
-              <a:rPr lang="en-US" smtClean="0"/>
+              <a:rPr lang="en-US"/>
               <a:t>Third level</a:t>
             </a:r>
           </a:p>
           <a:p>
             <a:pPr lvl="3"/>
             <a:r>
-              <a:rPr lang="en-US" smtClean="0"/>
+              <a:rPr lang="en-US"/>
               <a:t>Fourth level</a:t>
             </a:r>
           </a:p>
           <a:p>
             <a:pPr lvl="4"/>
             <a:r>
-              <a:rPr lang="en-US" smtClean="0"/>
+              <a:rPr lang="en-US"/>
               <a:t>Fifth level</a:t>
             </a:r>
-            <a:endParaRPr lang="en-US"/>
           </a:p>
         </p:txBody>
       </p:sp>
@@ -3959,7 +3778,7 @@
           <a:p>
             <a:fld id="{5BCAD085-E8A6-8845-BD4E-CB4CCA059FC4}" type="datetimeFigureOut">
               <a:rPr lang="en-US" smtClean="0"/>
-              <a:t>1/27/13</a:t>
+              <a:t>10/4/26</a:t>
             </a:fld>
             <a:endParaRPr lang="en-US"/>
           </a:p>
@@ -4001,7 +3820,7 @@
           <a:p>
             <a:fld id="{C1FF6DA9-008F-8B48-92A6-B652298478BF}" type="slidenum">
               <a:rPr lang="en-US" smtClean="0"/>
-              <a:t>‹#›</a:t>
+              <a:t>‹N°›</a:t>
             </a:fld>
             <a:endParaRPr lang="en-US"/>
           </a:p>
@@ -4053,10 +3872,9 @@
           <a:lstStyle/>
           <a:p>
             <a:r>
-              <a:rPr lang="en-US" smtClean="0"/>
+              <a:rPr lang="en-US"/>
               <a:t>Click to edit Master title style</a:t>
             </a:r>
-            <a:endParaRPr lang="en-US"/>
           </a:p>
         </p:txBody>
       </p:sp>
@@ -4077,7 +3895,7 @@
           <a:p>
             <a:fld id="{5BCAD085-E8A6-8845-BD4E-CB4CCA059FC4}" type="datetimeFigureOut">
               <a:rPr lang="en-US" smtClean="0"/>
-              <a:t>1/27/13</a:t>
+              <a:t>10/4/26</a:t>
             </a:fld>
             <a:endParaRPr lang="en-US"/>
           </a:p>
@@ -4119,7 +3937,7 @@
           <a:p>
             <a:fld id="{C1FF6DA9-008F-8B48-92A6-B652298478BF}" type="slidenum">
               <a:rPr lang="en-US" smtClean="0"/>
-              <a:t>‹#›</a:t>
+              <a:t>‹N°›</a:t>
             </a:fld>
             <a:endParaRPr lang="en-US"/>
           </a:p>
@@ -4172,7 +3990,7 @@
           <a:p>
             <a:fld id="{5BCAD085-E8A6-8845-BD4E-CB4CCA059FC4}" type="datetimeFigureOut">
               <a:rPr lang="en-US" smtClean="0"/>
-              <a:t>1/27/13</a:t>
+              <a:t>10/4/26</a:t>
             </a:fld>
             <a:endParaRPr lang="en-US"/>
           </a:p>
@@ -4214,7 +4032,7 @@
           <a:p>
             <a:fld id="{C1FF6DA9-008F-8B48-92A6-B652298478BF}" type="slidenum">
               <a:rPr lang="en-US" smtClean="0"/>
-              <a:t>‹#›</a:t>
+              <a:t>‹N°›</a:t>
             </a:fld>
             <a:endParaRPr lang="en-US"/>
           </a:p>
@@ -4275,10 +4093,9 @@
           </a:lstStyle>
           <a:p>
             <a:r>
-              <a:rPr lang="en-US" smtClean="0"/>
+              <a:rPr lang="en-US"/>
               <a:t>Click to edit Master title style</a:t>
             </a:r>
-            <a:endParaRPr lang="en-US"/>
           </a:p>
         </p:txBody>
       </p:sp>
@@ -4332,38 +4149,37 @@
           <a:p>
             <a:pPr lvl="0"/>
             <a:r>
-              <a:rPr lang="en-US" smtClean="0"/>
+              <a:rPr lang="en-US"/>
               <a:t>Click to edit Master text styles</a:t>
             </a:r>
           </a:p>
           <a:p>
             <a:pPr lvl="1"/>
             <a:r>
-              <a:rPr lang="en-US" smtClean="0"/>
+              <a:rPr lang="en-US"/>
               <a:t>Second level</a:t>
             </a:r>
           </a:p>
           <a:p>
             <a:pPr lvl="2"/>
             <a:r>
-              <a:rPr lang="en-US" smtClean="0"/>
+              <a:rPr lang="en-US"/>
               <a:t>Third level</a:t>
             </a:r>
           </a:p>
           <a:p>
             <a:pPr lvl="3"/>
             <a:r>
-              <a:rPr lang="en-US" smtClean="0"/>
+              <a:rPr lang="en-US"/>
               <a:t>Fourth level</a:t>
             </a:r>
           </a:p>
           <a:p>
             <a:pPr lvl="4"/>
             <a:r>
-              <a:rPr lang="en-US" smtClean="0"/>
+              <a:rPr lang="en-US"/>
               <a:t>Fifth level</a:t>
             </a:r>
-            <a:endParaRPr lang="en-US"/>
           </a:p>
         </p:txBody>
       </p:sp>
@@ -4426,7 +4242,7 @@
           <a:p>
             <a:pPr lvl="0"/>
             <a:r>
-              <a:rPr lang="en-US" smtClean="0"/>
+              <a:rPr lang="en-US"/>
               <a:t>Click to edit Master text styles</a:t>
             </a:r>
           </a:p>
@@ -4449,7 +4265,7 @@
           <a:p>
             <a:fld id="{5BCAD085-E8A6-8845-BD4E-CB4CCA059FC4}" type="datetimeFigureOut">
               <a:rPr lang="en-US" smtClean="0"/>
-              <a:t>1/27/13</a:t>
+              <a:t>10/4/26</a:t>
             </a:fld>
             <a:endParaRPr lang="en-US"/>
           </a:p>
@@ -4491,7 +4307,7 @@
           <a:p>
             <a:fld id="{C1FF6DA9-008F-8B48-92A6-B652298478BF}" type="slidenum">
               <a:rPr lang="en-US" smtClean="0"/>
-              <a:t>‹#›</a:t>
+              <a:t>‹N°›</a:t>
             </a:fld>
             <a:endParaRPr lang="en-US"/>
           </a:p>
@@ -4552,10 +4368,9 @@
           </a:lstStyle>
           <a:p>
             <a:r>
-              <a:rPr lang="en-US" smtClean="0"/>
+              <a:rPr lang="en-US"/>
               <a:t>Click to edit Master title style</a:t>
             </a:r>
-            <a:endParaRPr lang="en-US"/>
           </a:p>
         </p:txBody>
       </p:sp>
@@ -4679,7 +4494,7 @@
           <a:p>
             <a:pPr lvl="0"/>
             <a:r>
-              <a:rPr lang="en-US" smtClean="0"/>
+              <a:rPr lang="en-US"/>
               <a:t>Click to edit Master text styles</a:t>
             </a:r>
           </a:p>
@@ -4702,7 +4517,7 @@
           <a:p>
             <a:fld id="{5BCAD085-E8A6-8845-BD4E-CB4CCA059FC4}" type="datetimeFigureOut">
               <a:rPr lang="en-US" smtClean="0"/>
-              <a:t>1/27/13</a:t>
+              <a:t>10/4/26</a:t>
             </a:fld>
             <a:endParaRPr lang="en-US"/>
           </a:p>
@@ -4744,7 +4559,7 @@
           <a:p>
             <a:fld id="{C1FF6DA9-008F-8B48-92A6-B652298478BF}" type="slidenum">
               <a:rPr lang="en-US" smtClean="0"/>
-              <a:t>‹#›</a:t>
+              <a:t>‹N°›</a:t>
             </a:fld>
             <a:endParaRPr lang="en-US"/>
           </a:p>
@@ -4811,10 +4626,9 @@
           <a:lstStyle/>
           <a:p>
             <a:r>
-              <a:rPr lang="en-US" smtClean="0"/>
+              <a:rPr lang="en-US"/>
               <a:t>Click to edit Master title style</a:t>
             </a:r>
-            <a:endParaRPr lang="en-US"/>
           </a:p>
         </p:txBody>
       </p:sp>
@@ -4845,38 +4659,37 @@
           <a:p>
             <a:pPr lvl="0"/>
             <a:r>
-              <a:rPr lang="en-US" smtClean="0"/>
+              <a:rPr lang="en-US"/>
               <a:t>Click to edit Master text styles</a:t>
             </a:r>
           </a:p>
           <a:p>
             <a:pPr lvl="1"/>
             <a:r>
-              <a:rPr lang="en-US" smtClean="0"/>
+              <a:rPr lang="en-US"/>
               <a:t>Second level</a:t>
             </a:r>
           </a:p>
           <a:p>
             <a:pPr lvl="2"/>
             <a:r>
-              <a:rPr lang="en-US" smtClean="0"/>
+              <a:rPr lang="en-US"/>
               <a:t>Third level</a:t>
             </a:r>
           </a:p>
           <a:p>
             <a:pPr lvl="3"/>
             <a:r>
-              <a:rPr lang="en-US" smtClean="0"/>
+              <a:rPr lang="en-US"/>
               <a:t>Fourth level</a:t>
             </a:r>
           </a:p>
           <a:p>
             <a:pPr lvl="4"/>
             <a:r>
-              <a:rPr lang="en-US" smtClean="0"/>
+              <a:rPr lang="en-US"/>
               <a:t>Fifth level</a:t>
             </a:r>
-            <a:endParaRPr lang="en-US"/>
           </a:p>
         </p:txBody>
       </p:sp>
@@ -4915,7 +4728,7 @@
           <a:p>
             <a:fld id="{5BCAD085-E8A6-8845-BD4E-CB4CCA059FC4}" type="datetimeFigureOut">
               <a:rPr lang="en-US" smtClean="0"/>
-              <a:t>1/27/13</a:t>
+              <a:t>10/4/26</a:t>
             </a:fld>
             <a:endParaRPr lang="en-US"/>
           </a:p>
@@ -4993,7 +4806,7 @@
           <a:p>
             <a:fld id="{C1FF6DA9-008F-8B48-92A6-B652298478BF}" type="slidenum">
               <a:rPr lang="en-US" smtClean="0"/>
-              <a:t>‹#›</a:t>
+              <a:t>‹N°›</a:t>
             </a:fld>
             <a:endParaRPr lang="en-US"/>
           </a:p>
@@ -5274,7 +5087,7 @@
 </file>
 
 <file path=ppt/slides/slide1.xml><?xml version="1.0" encoding="utf-8"?>
-<p:sld xmlns:a="http://schemas.openxmlformats.org/drawingml/2006/main" xmlns:p="http://schemas.openxmlformats.org/presentationml/2006/main" xmlns:r="http://schemas.openxmlformats.org/officeDocument/2006/relationships">
+<p:sld xmlns:a="http://schemas.openxmlformats.org/drawingml/2006/main" xmlns:r="http://schemas.openxmlformats.org/officeDocument/2006/relationships" xmlns:p="http://schemas.openxmlformats.org/presentationml/2006/main">
   <p:cSld>
     <p:spTree>
       <p:nvGrpSpPr>
@@ -5282,7 +5095,14 @@
         <p:cNvGrpSpPr/>
         <p:nvPr/>
       </p:nvGrpSpPr>
-      <p:grpSpPr/>
+      <p:grpSpPr>
+        <a:xfrm>
+          <a:off x="0" y="0"/>
+          <a:ext cx="0" cy="0"/>
+          <a:chOff x="0" y="0"/>
+          <a:chExt cx="0" cy="0"/>
+        </a:xfrm>
+      </p:grpSpPr>
       <p:pic>
         <p:nvPicPr>
           <p:cNvPr id="2" name="Picture 1" descr="slide-01.png"/>
@@ -5292,7 +5112,7 @@
           <p:nvPr/>
         </p:nvPicPr>
         <p:blipFill>
-          <a:blip r:embed="rId2"/>
+          <a:blip r:embed="rId3"/>
           <a:stretch>
             <a:fillRect/>
           </a:stretch>
@@ -5312,12 +5132,12 @@
   <p:clrMapOvr>
     <a:masterClrMapping/>
   </p:clrMapOvr>
-  <p:transition advClick="1"/>
+  <p:transition/>
 </p:sld>
 </file>
 
 <file path=ppt/slides/slide10.xml><?xml version="1.0" encoding="utf-8"?>
-<p:sld xmlns:a="http://schemas.openxmlformats.org/drawingml/2006/main" xmlns:p="http://schemas.openxmlformats.org/presentationml/2006/main" xmlns:r="http://schemas.openxmlformats.org/officeDocument/2006/relationships">
+<p:sld xmlns:a="http://schemas.openxmlformats.org/drawingml/2006/main" xmlns:r="http://schemas.openxmlformats.org/officeDocument/2006/relationships" xmlns:p="http://schemas.openxmlformats.org/presentationml/2006/main">
   <p:cSld>
     <p:spTree>
       <p:nvGrpSpPr>
@@ -5325,7 +5145,14 @@
         <p:cNvGrpSpPr/>
         <p:nvPr/>
       </p:nvGrpSpPr>
-      <p:grpSpPr/>
+      <p:grpSpPr>
+        <a:xfrm>
+          <a:off x="0" y="0"/>
+          <a:ext cx="0" cy="0"/>
+          <a:chOff x="0" y="0"/>
+          <a:chExt cx="0" cy="0"/>
+        </a:xfrm>
+      </p:grpSpPr>
       <p:pic>
         <p:nvPicPr>
           <p:cNvPr id="2" name="Picture 1" descr="slide-10.png"/>
@@ -5335,7 +5162,7 @@
           <p:nvPr/>
         </p:nvPicPr>
         <p:blipFill>
-          <a:blip r:embed="rId2"/>
+          <a:blip r:embed="rId3"/>
           <a:stretch>
             <a:fillRect/>
           </a:stretch>
@@ -5355,12 +5182,12 @@
   <p:clrMapOvr>
     <a:masterClrMapping/>
   </p:clrMapOvr>
-  <p:transition advClick="1"/>
+  <p:transition/>
 </p:sld>
 </file>
 
 <file path=ppt/slides/slide11.xml><?xml version="1.0" encoding="utf-8"?>
-<p:sld xmlns:a="http://schemas.openxmlformats.org/drawingml/2006/main" xmlns:p="http://schemas.openxmlformats.org/presentationml/2006/main" xmlns:r="http://schemas.openxmlformats.org/officeDocument/2006/relationships">
+<p:sld xmlns:a="http://schemas.openxmlformats.org/drawingml/2006/main" xmlns:r="http://schemas.openxmlformats.org/officeDocument/2006/relationships" xmlns:p="http://schemas.openxmlformats.org/presentationml/2006/main">
   <p:cSld>
     <p:spTree>
       <p:nvGrpSpPr>
@@ -5368,7 +5195,14 @@
         <p:cNvGrpSpPr/>
         <p:nvPr/>
       </p:nvGrpSpPr>
-      <p:grpSpPr/>
+      <p:grpSpPr>
+        <a:xfrm>
+          <a:off x="0" y="0"/>
+          <a:ext cx="0" cy="0"/>
+          <a:chOff x="0" y="0"/>
+          <a:chExt cx="0" cy="0"/>
+        </a:xfrm>
+      </p:grpSpPr>
       <p:pic>
         <p:nvPicPr>
           <p:cNvPr id="2" name="Picture 1" descr="slide-11.png"/>
@@ -5378,7 +5212,7 @@
           <p:nvPr/>
         </p:nvPicPr>
         <p:blipFill>
-          <a:blip r:embed="rId2"/>
+          <a:blip r:embed="rId3"/>
           <a:stretch>
             <a:fillRect/>
           </a:stretch>
@@ -5398,12 +5232,12 @@
   <p:clrMapOvr>
     <a:masterClrMapping/>
   </p:clrMapOvr>
-  <p:transition advClick="1"/>
+  <p:transition/>
 </p:sld>
 </file>
 
 <file path=ppt/slides/slide12.xml><?xml version="1.0" encoding="utf-8"?>
-<p:sld xmlns:a="http://schemas.openxmlformats.org/drawingml/2006/main" xmlns:p="http://schemas.openxmlformats.org/presentationml/2006/main" xmlns:r="http://schemas.openxmlformats.org/officeDocument/2006/relationships">
+<p:sld xmlns:a="http://schemas.openxmlformats.org/drawingml/2006/main" xmlns:r="http://schemas.openxmlformats.org/officeDocument/2006/relationships" xmlns:p="http://schemas.openxmlformats.org/presentationml/2006/main">
   <p:cSld>
     <p:spTree>
       <p:nvGrpSpPr>
@@ -5411,7 +5245,14 @@
         <p:cNvGrpSpPr/>
         <p:nvPr/>
       </p:nvGrpSpPr>
-      <p:grpSpPr/>
+      <p:grpSpPr>
+        <a:xfrm>
+          <a:off x="0" y="0"/>
+          <a:ext cx="0" cy="0"/>
+          <a:chOff x="0" y="0"/>
+          <a:chExt cx="0" cy="0"/>
+        </a:xfrm>
+      </p:grpSpPr>
       <p:pic>
         <p:nvPicPr>
           <p:cNvPr id="2" name="Picture 1" descr="slide-12.png"/>
@@ -5421,7 +5262,7 @@
           <p:nvPr/>
         </p:nvPicPr>
         <p:blipFill>
-          <a:blip r:embed="rId2"/>
+          <a:blip r:embed="rId3"/>
           <a:stretch>
             <a:fillRect/>
           </a:stretch>
@@ -5441,12 +5282,12 @@
   <p:clrMapOvr>
     <a:masterClrMapping/>
   </p:clrMapOvr>
-  <p:transition advClick="1"/>
+  <p:transition/>
 </p:sld>
 </file>
 
 <file path=ppt/slides/slide13.xml><?xml version="1.0" encoding="utf-8"?>
-<p:sld xmlns:a="http://schemas.openxmlformats.org/drawingml/2006/main" xmlns:p="http://schemas.openxmlformats.org/presentationml/2006/main" xmlns:r="http://schemas.openxmlformats.org/officeDocument/2006/relationships">
+<p:sld xmlns:a="http://schemas.openxmlformats.org/drawingml/2006/main" xmlns:r="http://schemas.openxmlformats.org/officeDocument/2006/relationships" xmlns:p="http://schemas.openxmlformats.org/presentationml/2006/main">
   <p:cSld>
     <p:spTree>
       <p:nvGrpSpPr>
@@ -5454,7 +5295,14 @@
         <p:cNvGrpSpPr/>
         <p:nvPr/>
       </p:nvGrpSpPr>
-      <p:grpSpPr/>
+      <p:grpSpPr>
+        <a:xfrm>
+          <a:off x="0" y="0"/>
+          <a:ext cx="0" cy="0"/>
+          <a:chOff x="0" y="0"/>
+          <a:chExt cx="0" cy="0"/>
+        </a:xfrm>
+      </p:grpSpPr>
       <p:pic>
         <p:nvPicPr>
           <p:cNvPr id="2" name="Picture 1" descr="slide-13.png"/>
@@ -5464,7 +5312,7 @@
           <p:nvPr/>
         </p:nvPicPr>
         <p:blipFill>
-          <a:blip r:embed="rId2"/>
+          <a:blip r:embed="rId3"/>
           <a:stretch>
             <a:fillRect/>
           </a:stretch>
@@ -5484,12 +5332,12 @@
   <p:clrMapOvr>
     <a:masterClrMapping/>
   </p:clrMapOvr>
-  <p:transition advClick="1"/>
+  <p:transition/>
 </p:sld>
 </file>
 
 <file path=ppt/slides/slide14.xml><?xml version="1.0" encoding="utf-8"?>
-<p:sld xmlns:a="http://schemas.openxmlformats.org/drawingml/2006/main" xmlns:p="http://schemas.openxmlformats.org/presentationml/2006/main" xmlns:r="http://schemas.openxmlformats.org/officeDocument/2006/relationships">
+<p:sld xmlns:a="http://schemas.openxmlformats.org/drawingml/2006/main" xmlns:r="http://schemas.openxmlformats.org/officeDocument/2006/relationships" xmlns:p="http://schemas.openxmlformats.org/presentationml/2006/main">
   <p:cSld>
     <p:spTree>
       <p:nvGrpSpPr>
@@ -5497,7 +5345,14 @@
         <p:cNvGrpSpPr/>
         <p:nvPr/>
       </p:nvGrpSpPr>
-      <p:grpSpPr/>
+      <p:grpSpPr>
+        <a:xfrm>
+          <a:off x="0" y="0"/>
+          <a:ext cx="0" cy="0"/>
+          <a:chOff x="0" y="0"/>
+          <a:chExt cx="0" cy="0"/>
+        </a:xfrm>
+      </p:grpSpPr>
       <p:pic>
         <p:nvPicPr>
           <p:cNvPr id="2" name="Picture 1" descr="slide-14.png"/>
@@ -5507,7 +5362,7 @@
           <p:nvPr/>
         </p:nvPicPr>
         <p:blipFill>
-          <a:blip r:embed="rId2"/>
+          <a:blip r:embed="rId3"/>
           <a:stretch>
             <a:fillRect/>
           </a:stretch>
@@ -5527,12 +5382,12 @@
   <p:clrMapOvr>
     <a:masterClrMapping/>
   </p:clrMapOvr>
-  <p:transition advClick="1"/>
+  <p:transition/>
 </p:sld>
 </file>
 
 <file path=ppt/slides/slide15.xml><?xml version="1.0" encoding="utf-8"?>
-<p:sld xmlns:a="http://schemas.openxmlformats.org/drawingml/2006/main" xmlns:p="http://schemas.openxmlformats.org/presentationml/2006/main" xmlns:r="http://schemas.openxmlformats.org/officeDocument/2006/relationships">
+<p:sld xmlns:a="http://schemas.openxmlformats.org/drawingml/2006/main" xmlns:r="http://schemas.openxmlformats.org/officeDocument/2006/relationships" xmlns:p="http://schemas.openxmlformats.org/presentationml/2006/main">
   <p:cSld>
     <p:spTree>
       <p:nvGrpSpPr>
@@ -5540,7 +5395,14 @@
         <p:cNvGrpSpPr/>
         <p:nvPr/>
       </p:nvGrpSpPr>
-      <p:grpSpPr/>
+      <p:grpSpPr>
+        <a:xfrm>
+          <a:off x="0" y="0"/>
+          <a:ext cx="0" cy="0"/>
+          <a:chOff x="0" y="0"/>
+          <a:chExt cx="0" cy="0"/>
+        </a:xfrm>
+      </p:grpSpPr>
       <p:pic>
         <p:nvPicPr>
           <p:cNvPr id="2" name="Picture 1" descr="slide-15.png"/>
@@ -5550,7 +5412,7 @@
           <p:nvPr/>
         </p:nvPicPr>
         <p:blipFill>
-          <a:blip r:embed="rId2"/>
+          <a:blip r:embed="rId3"/>
           <a:stretch>
             <a:fillRect/>
           </a:stretch>
@@ -5570,12 +5432,12 @@
   <p:clrMapOvr>
     <a:masterClrMapping/>
   </p:clrMapOvr>
-  <p:transition advClick="1"/>
+  <p:transition/>
 </p:sld>
 </file>
 
 <file path=ppt/slides/slide16.xml><?xml version="1.0" encoding="utf-8"?>
-<p:sld xmlns:a="http://schemas.openxmlformats.org/drawingml/2006/main" xmlns:p="http://schemas.openxmlformats.org/presentationml/2006/main" xmlns:r="http://schemas.openxmlformats.org/officeDocument/2006/relationships">
+<p:sld xmlns:a="http://schemas.openxmlformats.org/drawingml/2006/main" xmlns:r="http://schemas.openxmlformats.org/officeDocument/2006/relationships" xmlns:p="http://schemas.openxmlformats.org/presentationml/2006/main">
   <p:cSld>
     <p:spTree>
       <p:nvGrpSpPr>
@@ -5583,7 +5445,14 @@
         <p:cNvGrpSpPr/>
         <p:nvPr/>
       </p:nvGrpSpPr>
-      <p:grpSpPr/>
+      <p:grpSpPr>
+        <a:xfrm>
+          <a:off x="0" y="0"/>
+          <a:ext cx="0" cy="0"/>
+          <a:chOff x="0" y="0"/>
+          <a:chExt cx="0" cy="0"/>
+        </a:xfrm>
+      </p:grpSpPr>
       <p:pic>
         <p:nvPicPr>
           <p:cNvPr id="2" name="Picture 1" descr="slide-16.png"/>
@@ -5593,7 +5462,7 @@
           <p:nvPr/>
         </p:nvPicPr>
         <p:blipFill>
-          <a:blip r:embed="rId2"/>
+          <a:blip r:embed="rId3"/>
           <a:stretch>
             <a:fillRect/>
           </a:stretch>
@@ -5613,12 +5482,12 @@
   <p:clrMapOvr>
     <a:masterClrMapping/>
   </p:clrMapOvr>
-  <p:transition advClick="1"/>
+  <p:transition/>
 </p:sld>
 </file>
 
 <file path=ppt/slides/slide17.xml><?xml version="1.0" encoding="utf-8"?>
-<p:sld xmlns:a="http://schemas.openxmlformats.org/drawingml/2006/main" xmlns:p="http://schemas.openxmlformats.org/presentationml/2006/main" xmlns:r="http://schemas.openxmlformats.org/officeDocument/2006/relationships">
+<p:sld xmlns:a="http://schemas.openxmlformats.org/drawingml/2006/main" xmlns:r="http://schemas.openxmlformats.org/officeDocument/2006/relationships" xmlns:p="http://schemas.openxmlformats.org/presentationml/2006/main">
   <p:cSld>
     <p:spTree>
       <p:nvGrpSpPr>
@@ -5626,7 +5495,14 @@
         <p:cNvGrpSpPr/>
         <p:nvPr/>
       </p:nvGrpSpPr>
-      <p:grpSpPr/>
+      <p:grpSpPr>
+        <a:xfrm>
+          <a:off x="0" y="0"/>
+          <a:ext cx="0" cy="0"/>
+          <a:chOff x="0" y="0"/>
+          <a:chExt cx="0" cy="0"/>
+        </a:xfrm>
+      </p:grpSpPr>
       <p:pic>
         <p:nvPicPr>
           <p:cNvPr id="2" name="Picture 1" descr="slide-17.png"/>
@@ -5636,7 +5512,7 @@
           <p:nvPr/>
         </p:nvPicPr>
         <p:blipFill>
-          <a:blip r:embed="rId2"/>
+          <a:blip r:embed="rId3"/>
           <a:stretch>
             <a:fillRect/>
           </a:stretch>
@@ -5656,12 +5532,12 @@
   <p:clrMapOvr>
     <a:masterClrMapping/>
   </p:clrMapOvr>
-  <p:transition advClick="1"/>
+  <p:transition/>
 </p:sld>
 </file>
 
 <file path=ppt/slides/slide18.xml><?xml version="1.0" encoding="utf-8"?>
-<p:sld xmlns:a="http://schemas.openxmlformats.org/drawingml/2006/main" xmlns:p="http://schemas.openxmlformats.org/presentationml/2006/main" xmlns:r="http://schemas.openxmlformats.org/officeDocument/2006/relationships">
+<p:sld xmlns:a="http://schemas.openxmlformats.org/drawingml/2006/main" xmlns:r="http://schemas.openxmlformats.org/officeDocument/2006/relationships" xmlns:p="http://schemas.openxmlformats.org/presentationml/2006/main">
   <p:cSld>
     <p:spTree>
       <p:nvGrpSpPr>
@@ -5669,7 +5545,14 @@
         <p:cNvGrpSpPr/>
         <p:nvPr/>
       </p:nvGrpSpPr>
-      <p:grpSpPr/>
+      <p:grpSpPr>
+        <a:xfrm>
+          <a:off x="0" y="0"/>
+          <a:ext cx="0" cy="0"/>
+          <a:chOff x="0" y="0"/>
+          <a:chExt cx="0" cy="0"/>
+        </a:xfrm>
+      </p:grpSpPr>
       <p:pic>
         <p:nvPicPr>
           <p:cNvPr id="2" name="Picture 1" descr="slide-18.png"/>
@@ -5679,7 +5562,7 @@
           <p:nvPr/>
         </p:nvPicPr>
         <p:blipFill>
-          <a:blip r:embed="rId2"/>
+          <a:blip r:embed="rId3"/>
           <a:stretch>
             <a:fillRect/>
           </a:stretch>
@@ -5699,12 +5582,12 @@
   <p:clrMapOvr>
     <a:masterClrMapping/>
   </p:clrMapOvr>
-  <p:transition advClick="1"/>
+  <p:transition/>
 </p:sld>
 </file>
 
 <file path=ppt/slides/slide19.xml><?xml version="1.0" encoding="utf-8"?>
-<p:sld xmlns:a="http://schemas.openxmlformats.org/drawingml/2006/main" xmlns:p="http://schemas.openxmlformats.org/presentationml/2006/main" xmlns:r="http://schemas.openxmlformats.org/officeDocument/2006/relationships">
+<p:sld xmlns:a="http://schemas.openxmlformats.org/drawingml/2006/main" xmlns:r="http://schemas.openxmlformats.org/officeDocument/2006/relationships" xmlns:p="http://schemas.openxmlformats.org/presentationml/2006/main">
   <p:cSld>
     <p:spTree>
       <p:nvGrpSpPr>
@@ -5712,7 +5595,14 @@
         <p:cNvGrpSpPr/>
         <p:nvPr/>
       </p:nvGrpSpPr>
-      <p:grpSpPr/>
+      <p:grpSpPr>
+        <a:xfrm>
+          <a:off x="0" y="0"/>
+          <a:ext cx="0" cy="0"/>
+          <a:chOff x="0" y="0"/>
+          <a:chExt cx="0" cy="0"/>
+        </a:xfrm>
+      </p:grpSpPr>
       <p:pic>
         <p:nvPicPr>
           <p:cNvPr id="2" name="Picture 1" descr="slide-19.png"/>
@@ -5722,7 +5612,7 @@
           <p:nvPr/>
         </p:nvPicPr>
         <p:blipFill>
-          <a:blip r:embed="rId2"/>
+          <a:blip r:embed="rId3"/>
           <a:stretch>
             <a:fillRect/>
           </a:stretch>
@@ -5742,12 +5632,12 @@
   <p:clrMapOvr>
     <a:masterClrMapping/>
   </p:clrMapOvr>
-  <p:transition advClick="1"/>
+  <p:transition/>
 </p:sld>
 </file>
 
 <file path=ppt/slides/slide2.xml><?xml version="1.0" encoding="utf-8"?>
-<p:sld xmlns:a="http://schemas.openxmlformats.org/drawingml/2006/main" xmlns:p="http://schemas.openxmlformats.org/presentationml/2006/main" xmlns:r="http://schemas.openxmlformats.org/officeDocument/2006/relationships">
+<p:sld xmlns:a="http://schemas.openxmlformats.org/drawingml/2006/main" xmlns:r="http://schemas.openxmlformats.org/officeDocument/2006/relationships" xmlns:p="http://schemas.openxmlformats.org/presentationml/2006/main">
   <p:cSld>
     <p:spTree>
       <p:nvGrpSpPr>
@@ -5755,7 +5645,14 @@
         <p:cNvGrpSpPr/>
         <p:nvPr/>
       </p:nvGrpSpPr>
-      <p:grpSpPr/>
+      <p:grpSpPr>
+        <a:xfrm>
+          <a:off x="0" y="0"/>
+          <a:ext cx="0" cy="0"/>
+          <a:chOff x="0" y="0"/>
+          <a:chExt cx="0" cy="0"/>
+        </a:xfrm>
+      </p:grpSpPr>
       <p:pic>
         <p:nvPicPr>
           <p:cNvPr id="2" name="Picture 1" descr="slide-02.png"/>
@@ -5765,7 +5662,7 @@
           <p:nvPr/>
         </p:nvPicPr>
         <p:blipFill>
-          <a:blip r:embed="rId2"/>
+          <a:blip r:embed="rId3"/>
           <a:stretch>
             <a:fillRect/>
           </a:stretch>
@@ -5785,12 +5682,12 @@
   <p:clrMapOvr>
     <a:masterClrMapping/>
   </p:clrMapOvr>
-  <p:transition advClick="1"/>
+  <p:transition/>
 </p:sld>
 </file>
 
 <file path=ppt/slides/slide20.xml><?xml version="1.0" encoding="utf-8"?>
-<p:sld xmlns:a="http://schemas.openxmlformats.org/drawingml/2006/main" xmlns:p="http://schemas.openxmlformats.org/presentationml/2006/main" xmlns:r="http://schemas.openxmlformats.org/officeDocument/2006/relationships">
+<p:sld xmlns:a="http://schemas.openxmlformats.org/drawingml/2006/main" xmlns:r="http://schemas.openxmlformats.org/officeDocument/2006/relationships" xmlns:p="http://schemas.openxmlformats.org/presentationml/2006/main">
   <p:cSld>
     <p:spTree>
       <p:nvGrpSpPr>
@@ -5798,7 +5695,14 @@
         <p:cNvGrpSpPr/>
         <p:nvPr/>
       </p:nvGrpSpPr>
-      <p:grpSpPr/>
+      <p:grpSpPr>
+        <a:xfrm>
+          <a:off x="0" y="0"/>
+          <a:ext cx="0" cy="0"/>
+          <a:chOff x="0" y="0"/>
+          <a:chExt cx="0" cy="0"/>
+        </a:xfrm>
+      </p:grpSpPr>
       <p:pic>
         <p:nvPicPr>
           <p:cNvPr id="2" name="Picture 1" descr="slide-20.png"/>
@@ -5808,7 +5712,7 @@
           <p:nvPr/>
         </p:nvPicPr>
         <p:blipFill>
-          <a:blip r:embed="rId2"/>
+          <a:blip r:embed="rId3"/>
           <a:stretch>
             <a:fillRect/>
           </a:stretch>
@@ -5828,12 +5732,12 @@
   <p:clrMapOvr>
     <a:masterClrMapping/>
   </p:clrMapOvr>
-  <p:transition advClick="1"/>
+  <p:transition/>
 </p:sld>
 </file>
 
 <file path=ppt/slides/slide21.xml><?xml version="1.0" encoding="utf-8"?>
-<p:sld xmlns:a="http://schemas.openxmlformats.org/drawingml/2006/main" xmlns:p="http://schemas.openxmlformats.org/presentationml/2006/main" xmlns:r="http://schemas.openxmlformats.org/officeDocument/2006/relationships">
+<p:sld xmlns:a="http://schemas.openxmlformats.org/drawingml/2006/main" xmlns:r="http://schemas.openxmlformats.org/officeDocument/2006/relationships" xmlns:p="http://schemas.openxmlformats.org/presentationml/2006/main">
   <p:cSld>
     <p:spTree>
       <p:nvGrpSpPr>
@@ -5841,7 +5745,14 @@
         <p:cNvGrpSpPr/>
         <p:nvPr/>
       </p:nvGrpSpPr>
-      <p:grpSpPr/>
+      <p:grpSpPr>
+        <a:xfrm>
+          <a:off x="0" y="0"/>
+          <a:ext cx="0" cy="0"/>
+          <a:chOff x="0" y="0"/>
+          <a:chExt cx="0" cy="0"/>
+        </a:xfrm>
+      </p:grpSpPr>
       <p:pic>
         <p:nvPicPr>
           <p:cNvPr id="2" name="Picture 1" descr="slide-21.png"/>
@@ -5851,7 +5762,7 @@
           <p:nvPr/>
         </p:nvPicPr>
         <p:blipFill>
-          <a:blip r:embed="rId2"/>
+          <a:blip r:embed="rId3"/>
           <a:stretch>
             <a:fillRect/>
           </a:stretch>
@@ -5871,12 +5782,12 @@
   <p:clrMapOvr>
     <a:masterClrMapping/>
   </p:clrMapOvr>
-  <p:transition advClick="1"/>
+  <p:transition/>
 </p:sld>
 </file>
 
 <file path=ppt/slides/slide22.xml><?xml version="1.0" encoding="utf-8"?>
-<p:sld xmlns:a="http://schemas.openxmlformats.org/drawingml/2006/main" xmlns:p="http://schemas.openxmlformats.org/presentationml/2006/main" xmlns:r="http://schemas.openxmlformats.org/officeDocument/2006/relationships">
+<p:sld xmlns:a="http://schemas.openxmlformats.org/drawingml/2006/main" xmlns:r="http://schemas.openxmlformats.org/officeDocument/2006/relationships" xmlns:p="http://schemas.openxmlformats.org/presentationml/2006/main">
   <p:cSld>
     <p:spTree>
       <p:nvGrpSpPr>
@@ -5884,7 +5795,14 @@
         <p:cNvGrpSpPr/>
         <p:nvPr/>
       </p:nvGrpSpPr>
-      <p:grpSpPr/>
+      <p:grpSpPr>
+        <a:xfrm>
+          <a:off x="0" y="0"/>
+          <a:ext cx="0" cy="0"/>
+          <a:chOff x="0" y="0"/>
+          <a:chExt cx="0" cy="0"/>
+        </a:xfrm>
+      </p:grpSpPr>
       <p:pic>
         <p:nvPicPr>
           <p:cNvPr id="2" name="Picture 1" descr="slide-22.png"/>
@@ -5894,7 +5812,7 @@
           <p:nvPr/>
         </p:nvPicPr>
         <p:blipFill>
-          <a:blip r:embed="rId2"/>
+          <a:blip r:embed="rId3"/>
           <a:stretch>
             <a:fillRect/>
           </a:stretch>
@@ -5914,12 +5832,12 @@
   <p:clrMapOvr>
     <a:masterClrMapping/>
   </p:clrMapOvr>
-  <p:transition advClick="1"/>
+  <p:transition/>
 </p:sld>
 </file>
 
 <file path=ppt/slides/slide23.xml><?xml version="1.0" encoding="utf-8"?>
-<p:sld xmlns:a="http://schemas.openxmlformats.org/drawingml/2006/main" xmlns:p="http://schemas.openxmlformats.org/presentationml/2006/main" xmlns:r="http://schemas.openxmlformats.org/officeDocument/2006/relationships">
+<p:sld xmlns:a="http://schemas.openxmlformats.org/drawingml/2006/main" xmlns:r="http://schemas.openxmlformats.org/officeDocument/2006/relationships" xmlns:p="http://schemas.openxmlformats.org/presentationml/2006/main">
   <p:cSld>
     <p:spTree>
       <p:nvGrpSpPr>
@@ -5927,7 +5845,14 @@
         <p:cNvGrpSpPr/>
         <p:nvPr/>
       </p:nvGrpSpPr>
-      <p:grpSpPr/>
+      <p:grpSpPr>
+        <a:xfrm>
+          <a:off x="0" y="0"/>
+          <a:ext cx="0" cy="0"/>
+          <a:chOff x="0" y="0"/>
+          <a:chExt cx="0" cy="0"/>
+        </a:xfrm>
+      </p:grpSpPr>
       <p:pic>
         <p:nvPicPr>
           <p:cNvPr id="2" name="Picture 1" descr="slide-23.png"/>
@@ -5937,7 +5862,7 @@
           <p:nvPr/>
         </p:nvPicPr>
         <p:blipFill>
-          <a:blip r:embed="rId2"/>
+          <a:blip r:embed="rId3"/>
           <a:stretch>
             <a:fillRect/>
           </a:stretch>
@@ -5957,12 +5882,12 @@
   <p:clrMapOvr>
     <a:masterClrMapping/>
   </p:clrMapOvr>
-  <p:transition advClick="1"/>
+  <p:transition/>
 </p:sld>
 </file>
 
 <file path=ppt/slides/slide24.xml><?xml version="1.0" encoding="utf-8"?>
-<p:sld xmlns:a="http://schemas.openxmlformats.org/drawingml/2006/main" xmlns:p="http://schemas.openxmlformats.org/presentationml/2006/main" xmlns:r="http://schemas.openxmlformats.org/officeDocument/2006/relationships">
+<p:sld xmlns:a="http://schemas.openxmlformats.org/drawingml/2006/main" xmlns:r="http://schemas.openxmlformats.org/officeDocument/2006/relationships" xmlns:p="http://schemas.openxmlformats.org/presentationml/2006/main">
   <p:cSld>
     <p:spTree>
       <p:nvGrpSpPr>
@@ -5970,7 +5895,14 @@
         <p:cNvGrpSpPr/>
         <p:nvPr/>
       </p:nvGrpSpPr>
-      <p:grpSpPr/>
+      <p:grpSpPr>
+        <a:xfrm>
+          <a:off x="0" y="0"/>
+          <a:ext cx="0" cy="0"/>
+          <a:chOff x="0" y="0"/>
+          <a:chExt cx="0" cy="0"/>
+        </a:xfrm>
+      </p:grpSpPr>
       <p:pic>
         <p:nvPicPr>
           <p:cNvPr id="2" name="Picture 1" descr="slide-24.png"/>
@@ -5980,7 +5912,7 @@
           <p:nvPr/>
         </p:nvPicPr>
         <p:blipFill>
-          <a:blip r:embed="rId2"/>
+          <a:blip r:embed="rId3"/>
           <a:stretch>
             <a:fillRect/>
           </a:stretch>
@@ -6000,12 +5932,12 @@
   <p:clrMapOvr>
     <a:masterClrMapping/>
   </p:clrMapOvr>
-  <p:transition advClick="1"/>
+  <p:transition/>
 </p:sld>
 </file>
 
 <file path=ppt/slides/slide25.xml><?xml version="1.0" encoding="utf-8"?>
-<p:sld xmlns:a="http://schemas.openxmlformats.org/drawingml/2006/main" xmlns:p="http://schemas.openxmlformats.org/presentationml/2006/main" xmlns:r="http://schemas.openxmlformats.org/officeDocument/2006/relationships">
+<p:sld xmlns:a="http://schemas.openxmlformats.org/drawingml/2006/main" xmlns:r="http://schemas.openxmlformats.org/officeDocument/2006/relationships" xmlns:p="http://schemas.openxmlformats.org/presentationml/2006/main">
   <p:cSld>
     <p:spTree>
       <p:nvGrpSpPr>
@@ -6013,7 +5945,14 @@
         <p:cNvGrpSpPr/>
         <p:nvPr/>
       </p:nvGrpSpPr>
-      <p:grpSpPr/>
+      <p:grpSpPr>
+        <a:xfrm>
+          <a:off x="0" y="0"/>
+          <a:ext cx="0" cy="0"/>
+          <a:chOff x="0" y="0"/>
+          <a:chExt cx="0" cy="0"/>
+        </a:xfrm>
+      </p:grpSpPr>
       <p:pic>
         <p:nvPicPr>
           <p:cNvPr id="2" name="Picture 1" descr="slide-25.png"/>
@@ -6023,7 +5962,7 @@
           <p:nvPr/>
         </p:nvPicPr>
         <p:blipFill>
-          <a:blip r:embed="rId2"/>
+          <a:blip r:embed="rId3"/>
           <a:stretch>
             <a:fillRect/>
           </a:stretch>
@@ -6043,12 +5982,12 @@
   <p:clrMapOvr>
     <a:masterClrMapping/>
   </p:clrMapOvr>
-  <p:transition advClick="1"/>
+  <p:transition/>
 </p:sld>
 </file>
 
 <file path=ppt/slides/slide26.xml><?xml version="1.0" encoding="utf-8"?>
-<p:sld xmlns:a="http://schemas.openxmlformats.org/drawingml/2006/main" xmlns:p="http://schemas.openxmlformats.org/presentationml/2006/main" xmlns:r="http://schemas.openxmlformats.org/officeDocument/2006/relationships">
+<p:sld xmlns:a="http://schemas.openxmlformats.org/drawingml/2006/main" xmlns:r="http://schemas.openxmlformats.org/officeDocument/2006/relationships" xmlns:p="http://schemas.openxmlformats.org/presentationml/2006/main">
   <p:cSld>
     <p:spTree>
       <p:nvGrpSpPr>
@@ -6056,7 +5995,14 @@
         <p:cNvGrpSpPr/>
         <p:nvPr/>
       </p:nvGrpSpPr>
-      <p:grpSpPr/>
+      <p:grpSpPr>
+        <a:xfrm>
+          <a:off x="0" y="0"/>
+          <a:ext cx="0" cy="0"/>
+          <a:chOff x="0" y="0"/>
+          <a:chExt cx="0" cy="0"/>
+        </a:xfrm>
+      </p:grpSpPr>
       <p:pic>
         <p:nvPicPr>
           <p:cNvPr id="2" name="Picture 1" descr="slide-26.png"/>
@@ -6066,7 +6012,7 @@
           <p:nvPr/>
         </p:nvPicPr>
         <p:blipFill>
-          <a:blip r:embed="rId2"/>
+          <a:blip r:embed="rId3"/>
           <a:stretch>
             <a:fillRect/>
           </a:stretch>
@@ -6086,12 +6032,12 @@
   <p:clrMapOvr>
     <a:masterClrMapping/>
   </p:clrMapOvr>
-  <p:transition advClick="1"/>
+  <p:transition/>
 </p:sld>
 </file>
 
 <file path=ppt/slides/slide3.xml><?xml version="1.0" encoding="utf-8"?>
-<p:sld xmlns:a="http://schemas.openxmlformats.org/drawingml/2006/main" xmlns:p="http://schemas.openxmlformats.org/presentationml/2006/main" xmlns:r="http://schemas.openxmlformats.org/officeDocument/2006/relationships">
+<p:sld xmlns:a="http://schemas.openxmlformats.org/drawingml/2006/main" xmlns:r="http://schemas.openxmlformats.org/officeDocument/2006/relationships" xmlns:p="http://schemas.openxmlformats.org/presentationml/2006/main">
   <p:cSld>
     <p:spTree>
       <p:nvGrpSpPr>
@@ -6099,7 +6045,14 @@
         <p:cNvGrpSpPr/>
         <p:nvPr/>
       </p:nvGrpSpPr>
-      <p:grpSpPr/>
+      <p:grpSpPr>
+        <a:xfrm>
+          <a:off x="0" y="0"/>
+          <a:ext cx="0" cy="0"/>
+          <a:chOff x="0" y="0"/>
+          <a:chExt cx="0" cy="0"/>
+        </a:xfrm>
+      </p:grpSpPr>
       <p:pic>
         <p:nvPicPr>
           <p:cNvPr id="2" name="Picture 1" descr="slide-03.png"/>
@@ -6109,7 +6062,7 @@
           <p:nvPr/>
         </p:nvPicPr>
         <p:blipFill>
-          <a:blip r:embed="rId2"/>
+          <a:blip r:embed="rId3"/>
           <a:stretch>
             <a:fillRect/>
           </a:stretch>
@@ -6129,12 +6082,12 @@
   <p:clrMapOvr>
     <a:masterClrMapping/>
   </p:clrMapOvr>
-  <p:transition advClick="1"/>
+  <p:transition/>
 </p:sld>
 </file>
 
 <file path=ppt/slides/slide4.xml><?xml version="1.0" encoding="utf-8"?>
-<p:sld xmlns:a="http://schemas.openxmlformats.org/drawingml/2006/main" xmlns:p="http://schemas.openxmlformats.org/presentationml/2006/main" xmlns:r="http://schemas.openxmlformats.org/officeDocument/2006/relationships">
+<p:sld xmlns:a="http://schemas.openxmlformats.org/drawingml/2006/main" xmlns:r="http://schemas.openxmlformats.org/officeDocument/2006/relationships" xmlns:p="http://schemas.openxmlformats.org/presentationml/2006/main">
   <p:cSld>
     <p:spTree>
       <p:nvGrpSpPr>
@@ -6142,7 +6095,14 @@
         <p:cNvGrpSpPr/>
         <p:nvPr/>
       </p:nvGrpSpPr>
-      <p:grpSpPr/>
+      <p:grpSpPr>
+        <a:xfrm>
+          <a:off x="0" y="0"/>
+          <a:ext cx="0" cy="0"/>
+          <a:chOff x="0" y="0"/>
+          <a:chExt cx="0" cy="0"/>
+        </a:xfrm>
+      </p:grpSpPr>
       <p:pic>
         <p:nvPicPr>
           <p:cNvPr id="2" name="Picture 1" descr="slide-04.png"/>
@@ -6152,7 +6112,7 @@
           <p:nvPr/>
         </p:nvPicPr>
         <p:blipFill>
-          <a:blip r:embed="rId2"/>
+          <a:blip r:embed="rId3"/>
           <a:stretch>
             <a:fillRect/>
           </a:stretch>
@@ -6172,12 +6132,12 @@
   <p:clrMapOvr>
     <a:masterClrMapping/>
   </p:clrMapOvr>
-  <p:transition advClick="1"/>
+  <p:transition/>
 </p:sld>
 </file>
 
 <file path=ppt/slides/slide5.xml><?xml version="1.0" encoding="utf-8"?>
-<p:sld xmlns:a="http://schemas.openxmlformats.org/drawingml/2006/main" xmlns:p="http://schemas.openxmlformats.org/presentationml/2006/main" xmlns:r="http://schemas.openxmlformats.org/officeDocument/2006/relationships">
+<p:sld xmlns:a="http://schemas.openxmlformats.org/drawingml/2006/main" xmlns:r="http://schemas.openxmlformats.org/officeDocument/2006/relationships" xmlns:p="http://schemas.openxmlformats.org/presentationml/2006/main">
   <p:cSld>
     <p:spTree>
       <p:nvGrpSpPr>
@@ -6185,7 +6145,14 @@
         <p:cNvGrpSpPr/>
         <p:nvPr/>
       </p:nvGrpSpPr>
-      <p:grpSpPr/>
+      <p:grpSpPr>
+        <a:xfrm>
+          <a:off x="0" y="0"/>
+          <a:ext cx="0" cy="0"/>
+          <a:chOff x="0" y="0"/>
+          <a:chExt cx="0" cy="0"/>
+        </a:xfrm>
+      </p:grpSpPr>
       <p:pic>
         <p:nvPicPr>
           <p:cNvPr id="2" name="Picture 1" descr="slide-05.png"/>
@@ -6195,7 +6162,7 @@
           <p:nvPr/>
         </p:nvPicPr>
         <p:blipFill>
-          <a:blip r:embed="rId2"/>
+          <a:blip r:embed="rId3"/>
           <a:stretch>
             <a:fillRect/>
           </a:stretch>
@@ -6215,12 +6182,12 @@
   <p:clrMapOvr>
     <a:masterClrMapping/>
   </p:clrMapOvr>
-  <p:transition advClick="1"/>
+  <p:transition/>
 </p:sld>
 </file>
 
 <file path=ppt/slides/slide6.xml><?xml version="1.0" encoding="utf-8"?>
-<p:sld xmlns:a="http://schemas.openxmlformats.org/drawingml/2006/main" xmlns:p="http://schemas.openxmlformats.org/presentationml/2006/main" xmlns:r="http://schemas.openxmlformats.org/officeDocument/2006/relationships">
+<p:sld xmlns:a="http://schemas.openxmlformats.org/drawingml/2006/main" xmlns:r="http://schemas.openxmlformats.org/officeDocument/2006/relationships" xmlns:p="http://schemas.openxmlformats.org/presentationml/2006/main">
   <p:cSld>
     <p:spTree>
       <p:nvGrpSpPr>
@@ -6228,7 +6195,14 @@
         <p:cNvGrpSpPr/>
         <p:nvPr/>
       </p:nvGrpSpPr>
-      <p:grpSpPr/>
+      <p:grpSpPr>
+        <a:xfrm>
+          <a:off x="0" y="0"/>
+          <a:ext cx="0" cy="0"/>
+          <a:chOff x="0" y="0"/>
+          <a:chExt cx="0" cy="0"/>
+        </a:xfrm>
+      </p:grpSpPr>
       <p:pic>
         <p:nvPicPr>
           <p:cNvPr id="2" name="Picture 1" descr="slide-06.png"/>
@@ -6238,7 +6212,7 @@
           <p:nvPr/>
         </p:nvPicPr>
         <p:blipFill>
-          <a:blip r:embed="rId2"/>
+          <a:blip r:embed="rId3"/>
           <a:stretch>
             <a:fillRect/>
           </a:stretch>
@@ -6258,12 +6232,12 @@
   <p:clrMapOvr>
     <a:masterClrMapping/>
   </p:clrMapOvr>
-  <p:transition advClick="1"/>
+  <p:transition/>
 </p:sld>
 </file>
 
 <file path=ppt/slides/slide7.xml><?xml version="1.0" encoding="utf-8"?>
-<p:sld xmlns:a="http://schemas.openxmlformats.org/drawingml/2006/main" xmlns:p="http://schemas.openxmlformats.org/presentationml/2006/main" xmlns:r="http://schemas.openxmlformats.org/officeDocument/2006/relationships">
+<p:sld xmlns:a="http://schemas.openxmlformats.org/drawingml/2006/main" xmlns:r="http://schemas.openxmlformats.org/officeDocument/2006/relationships" xmlns:p="http://schemas.openxmlformats.org/presentationml/2006/main">
   <p:cSld>
     <p:spTree>
       <p:nvGrpSpPr>
@@ -6271,7 +6245,14 @@
         <p:cNvGrpSpPr/>
         <p:nvPr/>
       </p:nvGrpSpPr>
-      <p:grpSpPr/>
+      <p:grpSpPr>
+        <a:xfrm>
+          <a:off x="0" y="0"/>
+          <a:ext cx="0" cy="0"/>
+          <a:chOff x="0" y="0"/>
+          <a:chExt cx="0" cy="0"/>
+        </a:xfrm>
+      </p:grpSpPr>
       <p:pic>
         <p:nvPicPr>
           <p:cNvPr id="2" name="Picture 1" descr="slide-07.png"/>
@@ -6281,7 +6262,7 @@
           <p:nvPr/>
         </p:nvPicPr>
         <p:blipFill>
-          <a:blip r:embed="rId2"/>
+          <a:blip r:embed="rId3"/>
           <a:stretch>
             <a:fillRect/>
           </a:stretch>
@@ -6301,12 +6282,12 @@
   <p:clrMapOvr>
     <a:masterClrMapping/>
   </p:clrMapOvr>
-  <p:transition advClick="1"/>
+  <p:transition/>
 </p:sld>
 </file>
 
 <file path=ppt/slides/slide8.xml><?xml version="1.0" encoding="utf-8"?>
-<p:sld xmlns:a="http://schemas.openxmlformats.org/drawingml/2006/main" xmlns:p="http://schemas.openxmlformats.org/presentationml/2006/main" xmlns:r="http://schemas.openxmlformats.org/officeDocument/2006/relationships">
+<p:sld xmlns:a="http://schemas.openxmlformats.org/drawingml/2006/main" xmlns:r="http://schemas.openxmlformats.org/officeDocument/2006/relationships" xmlns:p="http://schemas.openxmlformats.org/presentationml/2006/main">
   <p:cSld>
     <p:spTree>
       <p:nvGrpSpPr>
@@ -6314,7 +6295,14 @@
         <p:cNvGrpSpPr/>
         <p:nvPr/>
       </p:nvGrpSpPr>
-      <p:grpSpPr/>
+      <p:grpSpPr>
+        <a:xfrm>
+          <a:off x="0" y="0"/>
+          <a:ext cx="0" cy="0"/>
+          <a:chOff x="0" y="0"/>
+          <a:chExt cx="0" cy="0"/>
+        </a:xfrm>
+      </p:grpSpPr>
       <p:pic>
         <p:nvPicPr>
           <p:cNvPr id="2" name="Picture 1" descr="slide-08.png"/>
@@ -6324,7 +6312,7 @@
           <p:nvPr/>
         </p:nvPicPr>
         <p:blipFill>
-          <a:blip r:embed="rId2"/>
+          <a:blip r:embed="rId3"/>
           <a:stretch>
             <a:fillRect/>
           </a:stretch>
@@ -6344,12 +6332,12 @@
   <p:clrMapOvr>
     <a:masterClrMapping/>
   </p:clrMapOvr>
-  <p:transition advClick="1"/>
+  <p:transition/>
 </p:sld>
 </file>
 
 <file path=ppt/slides/slide9.xml><?xml version="1.0" encoding="utf-8"?>
-<p:sld xmlns:a="http://schemas.openxmlformats.org/drawingml/2006/main" xmlns:p="http://schemas.openxmlformats.org/presentationml/2006/main" xmlns:r="http://schemas.openxmlformats.org/officeDocument/2006/relationships">
+<p:sld xmlns:a="http://schemas.openxmlformats.org/drawingml/2006/main" xmlns:r="http://schemas.openxmlformats.org/officeDocument/2006/relationships" xmlns:p="http://schemas.openxmlformats.org/presentationml/2006/main">
   <p:cSld>
     <p:spTree>
       <p:nvGrpSpPr>
@@ -6357,7 +6345,14 @@
         <p:cNvGrpSpPr/>
         <p:nvPr/>
       </p:nvGrpSpPr>
-      <p:grpSpPr/>
+      <p:grpSpPr>
+        <a:xfrm>
+          <a:off x="0" y="0"/>
+          <a:ext cx="0" cy="0"/>
+          <a:chOff x="0" y="0"/>
+          <a:chExt cx="0" cy="0"/>
+        </a:xfrm>
+      </p:grpSpPr>
       <p:pic>
         <p:nvPicPr>
           <p:cNvPr id="2" name="Picture 1" descr="slide-09.png"/>
@@ -6367,7 +6362,7 @@
           <p:nvPr/>
         </p:nvPicPr>
         <p:blipFill>
-          <a:blip r:embed="rId2"/>
+          <a:blip r:embed="rId3"/>
           <a:stretch>
             <a:fillRect/>
           </a:stretch>
@@ -6387,7 +6382,7 @@
   <p:clrMapOvr>
     <a:masterClrMapping/>
   </p:clrMapOvr>
-  <p:transition advClick="1"/>
+  <p:transition/>
 </p:sld>
 </file>
 
@@ -6712,7 +6707,7 @@
 </file>
 
 <file path=ppt/theme/theme2.xml><?xml version="1.0" encoding="utf-8"?>
-<a:theme xmlns:a="http://schemas.openxmlformats.org/drawingml/2006/main" name="Office Theme">
+<a:theme xmlns:a="http://schemas.openxmlformats.org/drawingml/2006/main" name="Thème Office">
   <a:themeElements>
     <a:clrScheme name="Office">
       <a:dk1>
@@ -6722,44 +6717,44 @@
         <a:sysClr val="window" lastClr="FFFFFF"/>
       </a:lt1>
       <a:dk2>
-        <a:srgbClr val="1F497D"/>
+        <a:srgbClr val="0E2841"/>
       </a:dk2>
       <a:lt2>
-        <a:srgbClr val="EEECE1"/>
+        <a:srgbClr val="E8E8E8"/>
       </a:lt2>
       <a:accent1>
-        <a:srgbClr val="4F81BD"/>
+        <a:srgbClr val="156082"/>
       </a:accent1>
       <a:accent2>
-        <a:srgbClr val="C0504D"/>
+        <a:srgbClr val="E97132"/>
       </a:accent2>
       <a:accent3>
-        <a:srgbClr val="9BBB59"/>
+        <a:srgbClr val="196B24"/>
       </a:accent3>
       <a:accent4>
-        <a:srgbClr val="8064A2"/>
+        <a:srgbClr val="0F9ED5"/>
       </a:accent4>
       <a:accent5>
-        <a:srgbClr val="4BACC6"/>
+        <a:srgbClr val="A02B93"/>
       </a:accent5>
       <a:accent6>
-        <a:srgbClr val="F79646"/>
+        <a:srgbClr val="4EA72E"/>
       </a:accent6>
       <a:hlink>
-        <a:srgbClr val="0000FF"/>
+        <a:srgbClr val="467886"/>
       </a:hlink>
       <a:folHlink>
-        <a:srgbClr val="800080"/>
+        <a:srgbClr val="96607D"/>
       </a:folHlink>
     </a:clrScheme>
     <a:fontScheme name="Office">
       <a:majorFont>
-        <a:latin typeface="Calibri"/>
+        <a:latin typeface="Aptos Display" panose="02110004020202020204"/>
         <a:ea typeface=""/>
         <a:cs typeface=""/>
-        <a:font script="Jpan" typeface="ＭＳ Ｐゴシック"/>
+        <a:font script="Jpan" typeface="游ゴシック Light"/>
         <a:font script="Hang" typeface="맑은 고딕"/>
-        <a:font script="Hans" typeface="宋体"/>
+        <a:font script="Hans" typeface="等线 Light"/>
         <a:font script="Hant" typeface="新細明體"/>
         <a:font script="Arab" typeface="Times New Roman"/>
         <a:font script="Hebr" typeface="Times New Roman"/>
@@ -6787,14 +6782,31 @@
         <a:font script="Viet" typeface="Times New Roman"/>
         <a:font script="Uigh" typeface="Microsoft Uighur"/>
         <a:font script="Geor" typeface="Sylfaen"/>
+        <a:font script="Armn" typeface="Arial"/>
+        <a:font script="Bugi" typeface="Leelawadee UI"/>
+        <a:font script="Bopo" typeface="Microsoft JhengHei"/>
+        <a:font script="Java" typeface="Javanese Text"/>
+        <a:font script="Lisu" typeface="Segoe UI"/>
+        <a:font script="Mymr" typeface="Myanmar Text"/>
+        <a:font script="Nkoo" typeface="Ebrima"/>
+        <a:font script="Olck" typeface="Nirmala UI"/>
+        <a:font script="Osma" typeface="Ebrima"/>
+        <a:font script="Phag" typeface="Phagspa"/>
+        <a:font script="Syrn" typeface="Estrangelo Edessa"/>
+        <a:font script="Syrj" typeface="Estrangelo Edessa"/>
+        <a:font script="Syre" typeface="Estrangelo Edessa"/>
+        <a:font script="Sora" typeface="Nirmala UI"/>
+        <a:font script="Tale" typeface="Microsoft Tai Le"/>
+        <a:font script="Talu" typeface="Microsoft New Tai Lue"/>
+        <a:font script="Tfng" typeface="Ebrima"/>
       </a:majorFont>
       <a:minorFont>
-        <a:latin typeface="Calibri"/>
+        <a:latin typeface="Aptos" panose="02110004020202020204"/>
         <a:ea typeface=""/>
         <a:cs typeface=""/>
-        <a:font script="Jpan" typeface="ＭＳ Ｐゴシック"/>
+        <a:font script="Jpan" typeface="游ゴシック"/>
         <a:font script="Hang" typeface="맑은 고딕"/>
-        <a:font script="Hans" typeface="宋体"/>
+        <a:font script="Hans" typeface="等线"/>
         <a:font script="Hant" typeface="新細明體"/>
         <a:font script="Arab" typeface="Arial"/>
         <a:font script="Hebr" typeface="Arial"/>
@@ -6822,6 +6834,23 @@
         <a:font script="Viet" typeface="Arial"/>
         <a:font script="Uigh" typeface="Microsoft Uighur"/>
         <a:font script="Geor" typeface="Sylfaen"/>
+        <a:font script="Armn" typeface="Arial"/>
+        <a:font script="Bugi" typeface="Leelawadee UI"/>
+        <a:font script="Bopo" typeface="Microsoft JhengHei"/>
+        <a:font script="Java" typeface="Javanese Text"/>
+        <a:font script="Lisu" typeface="Segoe UI"/>
+        <a:font script="Mymr" typeface="Myanmar Text"/>
+        <a:font script="Nkoo" typeface="Ebrima"/>
+        <a:font script="Olck" typeface="Nirmala UI"/>
+        <a:font script="Osma" typeface="Ebrima"/>
+        <a:font script="Phag" typeface="Phagspa"/>
+        <a:font script="Syrn" typeface="Estrangelo Edessa"/>
+        <a:font script="Syrj" typeface="Estrangelo Edessa"/>
+        <a:font script="Syre" typeface="Estrangelo Edessa"/>
+        <a:font script="Sora" typeface="Nirmala UI"/>
+        <a:font script="Tale" typeface="Microsoft Tai Le"/>
+        <a:font script="Talu" typeface="Microsoft New Tai Lue"/>
+        <a:font script="Tfng" typeface="Ebrima"/>
       </a:minorFont>
     </a:fontScheme>
     <a:fmtScheme name="Office">
@@ -6833,180 +6862,136 @@
           <a:gsLst>
             <a:gs pos="0">
               <a:schemeClr val="phClr">
-                <a:tint val="50000"/>
-                <a:satMod val="300000"/>
+                <a:lumMod val="110000"/>
+                <a:satMod val="105000"/>
+                <a:tint val="67000"/>
               </a:schemeClr>
             </a:gs>
-            <a:gs pos="35000">
+            <a:gs pos="50000">
               <a:schemeClr val="phClr">
-                <a:tint val="37000"/>
-                <a:satMod val="300000"/>
+                <a:lumMod val="105000"/>
+                <a:satMod val="103000"/>
+                <a:tint val="73000"/>
               </a:schemeClr>
             </a:gs>
             <a:gs pos="100000">
               <a:schemeClr val="phClr">
-                <a:tint val="15000"/>
-                <a:satMod val="350000"/>
+                <a:lumMod val="105000"/>
+                <a:satMod val="109000"/>
+                <a:tint val="81000"/>
               </a:schemeClr>
             </a:gs>
           </a:gsLst>
-          <a:lin ang="16200000" scaled="1"/>
+          <a:lin ang="5400000" scaled="0"/>
         </a:gradFill>
         <a:gradFill rotWithShape="1">
           <a:gsLst>
             <a:gs pos="0">
               <a:schemeClr val="phClr">
-                <a:tint val="100000"/>
+                <a:satMod val="103000"/>
+                <a:lumMod val="102000"/>
+                <a:tint val="94000"/>
+              </a:schemeClr>
+            </a:gs>
+            <a:gs pos="50000">
+              <a:schemeClr val="phClr">
+                <a:satMod val="110000"/>
+                <a:lumMod val="100000"/>
                 <a:shade val="100000"/>
-                <a:satMod val="130000"/>
               </a:schemeClr>
             </a:gs>
             <a:gs pos="100000">
               <a:schemeClr val="phClr">
-                <a:tint val="50000"/>
-                <a:shade val="100000"/>
-                <a:satMod val="350000"/>
+                <a:lumMod val="99000"/>
+                <a:satMod val="120000"/>
+                <a:shade val="78000"/>
               </a:schemeClr>
             </a:gs>
           </a:gsLst>
-          <a:lin ang="16200000" scaled="0"/>
+          <a:lin ang="5400000" scaled="0"/>
         </a:gradFill>
       </a:fillStyleLst>
       <a:lnStyleLst>
-        <a:ln w="9525" cap="flat" cmpd="sng" algn="ctr">
+        <a:ln w="12700" cap="flat" cmpd="sng" algn="ctr">
           <a:solidFill>
-            <a:schemeClr val="phClr">
-              <a:shade val="95000"/>
-              <a:satMod val="105000"/>
-            </a:schemeClr>
+            <a:schemeClr val="phClr"/>
           </a:solidFill>
           <a:prstDash val="solid"/>
+          <a:miter lim="800000"/>
+        </a:ln>
+        <a:ln w="19050" cap="flat" cmpd="sng" algn="ctr">
+          <a:solidFill>
+            <a:schemeClr val="phClr"/>
+          </a:solidFill>
+          <a:prstDash val="solid"/>
+          <a:miter lim="800000"/>
         </a:ln>
         <a:ln w="25400" cap="flat" cmpd="sng" algn="ctr">
           <a:solidFill>
             <a:schemeClr val="phClr"/>
           </a:solidFill>
           <a:prstDash val="solid"/>
-        </a:ln>
-        <a:ln w="38100" cap="flat" cmpd="sng" algn="ctr">
-          <a:solidFill>
-            <a:schemeClr val="phClr"/>
-          </a:solidFill>
-          <a:prstDash val="solid"/>
+          <a:miter lim="800000"/>
         </a:ln>
       </a:lnStyleLst>
       <a:effectStyleLst>
         <a:effectStyle>
+          <a:effectLst/>
+        </a:effectStyle>
+        <a:effectStyle>
+          <a:effectLst/>
+        </a:effectStyle>
+        <a:effectStyle>
           <a:effectLst>
-            <a:outerShdw blurRad="40000" dist="20000" dir="5400000" rotWithShape="0">
+            <a:outerShdw blurRad="57150" dist="19050" dir="5400000" algn="ctr" rotWithShape="0">
               <a:srgbClr val="000000">
-                <a:alpha val="38000"/>
+                <a:alpha val="63000"/>
               </a:srgbClr>
             </a:outerShdw>
           </a:effectLst>
-        </a:effectStyle>
-        <a:effectStyle>
-          <a:effectLst>
-            <a:outerShdw blurRad="40000" dist="23000" dir="5400000" rotWithShape="0">
-              <a:srgbClr val="000000">
-                <a:alpha val="35000"/>
-              </a:srgbClr>
-            </a:outerShdw>
-          </a:effectLst>
-        </a:effectStyle>
-        <a:effectStyle>
-          <a:effectLst>
-            <a:outerShdw blurRad="40000" dist="23000" dir="5400000" rotWithShape="0">
-              <a:srgbClr val="000000">
-                <a:alpha val="35000"/>
-              </a:srgbClr>
-            </a:outerShdw>
-          </a:effectLst>
-          <a:scene3d>
-            <a:camera prst="orthographicFront">
-              <a:rot lat="0" lon="0" rev="0"/>
-            </a:camera>
-            <a:lightRig rig="threePt" dir="t">
-              <a:rot lat="0" lon="0" rev="1200000"/>
-            </a:lightRig>
-          </a:scene3d>
-          <a:sp3d>
-            <a:bevelT w="63500" h="25400"/>
-          </a:sp3d>
         </a:effectStyle>
       </a:effectStyleLst>
       <a:bgFillStyleLst>
         <a:solidFill>
           <a:schemeClr val="phClr"/>
         </a:solidFill>
+        <a:solidFill>
+          <a:schemeClr val="phClr">
+            <a:tint val="95000"/>
+            <a:satMod val="170000"/>
+          </a:schemeClr>
+        </a:solidFill>
         <a:gradFill rotWithShape="1">
           <a:gsLst>
             <a:gs pos="0">
               <a:schemeClr val="phClr">
-                <a:tint val="40000"/>
-                <a:satMod val="350000"/>
+                <a:tint val="93000"/>
+                <a:satMod val="150000"/>
+                <a:shade val="98000"/>
+                <a:lumMod val="102000"/>
               </a:schemeClr>
             </a:gs>
-            <a:gs pos="40000">
+            <a:gs pos="50000">
               <a:schemeClr val="phClr">
-                <a:tint val="45000"/>
-                <a:shade val="99000"/>
-                <a:satMod val="350000"/>
+                <a:tint val="98000"/>
+                <a:satMod val="130000"/>
+                <a:shade val="90000"/>
+                <a:lumMod val="103000"/>
               </a:schemeClr>
             </a:gs>
             <a:gs pos="100000">
               <a:schemeClr val="phClr">
-                <a:shade val="20000"/>
-                <a:satMod val="255000"/>
+                <a:shade val="63000"/>
+                <a:satMod val="120000"/>
               </a:schemeClr>
             </a:gs>
           </a:gsLst>
-          <a:path path="circle">
-            <a:fillToRect l="50000" t="-80000" r="50000" b="180000"/>
-          </a:path>
-        </a:gradFill>
-        <a:gradFill rotWithShape="1">
-          <a:gsLst>
-            <a:gs pos="0">
-              <a:schemeClr val="phClr">
-                <a:tint val="80000"/>
-                <a:satMod val="300000"/>
-              </a:schemeClr>
-            </a:gs>
-            <a:gs pos="100000">
-              <a:schemeClr val="phClr">
-                <a:shade val="30000"/>
-                <a:satMod val="200000"/>
-              </a:schemeClr>
-            </a:gs>
-          </a:gsLst>
-          <a:path path="circle">
-            <a:fillToRect l="50000" t="50000" r="50000" b="50000"/>
-          </a:path>
+          <a:lin ang="5400000" scaled="0"/>
         </a:gradFill>
       </a:bgFillStyleLst>
     </a:fmtScheme>
   </a:themeElements>
   <a:objectDefaults>
-    <a:spDef>
-      <a:spPr/>
-      <a:bodyPr/>
-      <a:lstStyle/>
-      <a:style>
-        <a:lnRef idx="1">
-          <a:schemeClr val="accent1"/>
-        </a:lnRef>
-        <a:fillRef idx="3">
-          <a:schemeClr val="accent1"/>
-        </a:fillRef>
-        <a:effectRef idx="2">
-          <a:schemeClr val="accent1"/>
-        </a:effectRef>
-        <a:fontRef idx="minor">
-          <a:schemeClr val="lt1"/>
-        </a:fontRef>
-      </a:style>
-    </a:spDef>
     <a:lnDef>
       <a:spPr/>
       <a:bodyPr/>
@@ -7028,5 +7013,10 @@
     </a:lnDef>
   </a:objectDefaults>
   <a:extraClrSchemeLst/>
+  <a:extLst>
+    <a:ext uri="{05A4C25C-085E-4340-85A3-A5531E510DB2}">
+      <thm15:themeFamily xmlns:thm15="http://schemas.microsoft.com/office/thememl/2012/main" name="Office Theme" id="{2E142A2C-CD16-42D6-873A-C26D2A0506FA}" vid="{1BDDFF52-6CD6-40A5-AB3C-68EB2F1E4D0A}"/>
+    </a:ext>
+  </a:extLst>
 </a:theme>
 </file>
</xml_diff>

<commit_message>
feat(pitch): ajouter la page d’impression des badges QR
</commit_message>
<xml_diff>
--- a/docs/pitch/Club-des-Affaires-pitch.pptx
+++ b/docs/pitch/Club-des-Affaires-pitch.pptx
@@ -25,6 +25,7 @@
     <p:sldId id="270" r:id="rId16"/>
     <p:sldId id="271" r:id="rId17"/>
     <p:sldId id="272" r:id="rId18"/>
+    <p:sldId id="282" r:id="rId33"/>
     <p:sldId id="273" r:id="rId19"/>
     <p:sldId id="274" r:id="rId20"/>
     <p:sldId id="275" r:id="rId21"/>
@@ -746,7 +747,7 @@
           <a:lstStyle/>
           <a:p>
             <a:r>
-              <a:t>(1:26–1:32) L’équipe voit les membres, les rencontres et les personnes isolées.</a:t>
+              <a:t>(1:26–1:31) L’équipe voit les membres, les rencontres et les personnes isolées.</a:t>
             </a:r>
           </a:p>
         </p:txBody>
@@ -816,7 +817,7 @@
           <a:lstStyle/>
           <a:p>
             <a:r>
-              <a:t>(1:32–1:37) Elle prépare les soirées, génère les badges et les tables tournantes.</a:t>
+              <a:t>(1:31–1:35) Elle prépare les soirées et les tables tournantes.</a:t>
             </a:r>
           </a:p>
         </p:txBody>
@@ -886,7 +887,7 @@
           <a:lstStyle/>
           <a:p>
             <a:r>
-              <a:t>(1:37–1:44) Ici, trente-huit invités sont mélangés sur trois services.</a:t>
+              <a:t>(1:35–1:40) Ici, trente-huit invités sont mélangés sur trois services.</a:t>
             </a:r>
           </a:p>
         </p:txBody>
@@ -1602,6 +1603,52 @@
           </p:nvPr>
         </p:nvSpPr>
         <p:spPr/>
+      </p:sp>
+    </p:spTree>
+  </p:cSld>
+  <p:clrMapOvr>
+    <a:masterClrMapping/>
+  </p:clrMapOvr>
+</p:notes>
+</file>
+
+<file path=ppt/notesSlides/notesSlide27.xml><?xml version="1.0" encoding="utf-8"?>
+<p:notes xmlns:a="http://schemas.openxmlformats.org/drawingml/2006/main" xmlns:p="http://schemas.openxmlformats.org/presentationml/2006/main" xmlns:r="http://schemas.openxmlformats.org/officeDocument/2006/relationships">
+  <p:cSld>
+    <p:spTree>
+      <p:nvGrpSpPr>
+        <p:cNvPr id="1" name=""/>
+        <p:cNvGrpSpPr/>
+        <p:nvPr/>
+      </p:nvGrpSpPr>
+      <p:grpSpPr>
+        <a:xfrm>
+          <a:off x="0" y="0"/>
+          <a:ext cx="0" cy="0"/>
+          <a:chOff x="0" y="0"/>
+          <a:chExt cx="0" cy="0"/>
+        </a:xfrm>
+      </p:grpSpPr>
+      <p:sp>
+        <p:nvSpPr>
+          <p:cNvPr id="1" name="Notes Placeholder 2"/>
+          <p:cNvSpPr>
+            <a:spLocks noGrp="1"/>
+          </p:cNvSpPr>
+          <p:nvPr>
+            <p:ph type="body" sz="quarter" idx="3"/>
+          </p:nvPr>
+        </p:nvSpPr>
+        <p:spPr/>
+        <p:txBody>
+          <a:bodyPr/>
+          <a:lstStyle/>
+          <a:p>
+            <a:r>
+              <a:t>(1:40–1:44) Elle imprime les badges QR des inscrits.</a:t>
+            </a:r>
+          </a:p>
+        </p:txBody>
       </p:sp>
     </p:spTree>
   </p:cSld>
@@ -6036,6 +6083,49 @@
 </p:sld>
 </file>
 
+<file path=ppt/slides/slide27.xml><?xml version="1.0" encoding="utf-8"?>
+<p:sld xmlns:a="http://schemas.openxmlformats.org/drawingml/2006/main" xmlns:p="http://schemas.openxmlformats.org/presentationml/2006/main" xmlns:r="http://schemas.openxmlformats.org/officeDocument/2006/relationships">
+  <p:cSld>
+    <p:spTree>
+      <p:nvGrpSpPr>
+        <p:cNvPr id="1" name=""/>
+        <p:cNvGrpSpPr/>
+        <p:nvPr/>
+      </p:nvGrpSpPr>
+      <p:grpSpPr/>
+      <p:pic>
+        <p:nvPicPr>
+          <p:cNvPr id="2" name="Picture 1" descr="slide-18.png"/>
+          <p:cNvPicPr>
+            <a:picLocks noChangeAspect="1"/>
+          </p:cNvPicPr>
+          <p:nvPr/>
+        </p:nvPicPr>
+        <p:blipFill>
+          <a:blip r:embed="rId2"/>
+          <a:stretch>
+            <a:fillRect/>
+          </a:stretch>
+        </p:blipFill>
+        <p:spPr>
+          <a:xfrm>
+            <a:off x="0" y="0"/>
+            <a:ext cx="12192000" cy="6858000"/>
+          </a:xfrm>
+          <a:prstGeom prst="rect">
+            <a:avLst/>
+          </a:prstGeom>
+        </p:spPr>
+      </p:pic>
+    </p:spTree>
+  </p:cSld>
+  <p:clrMapOvr>
+    <a:masterClrMapping/>
+  </p:clrMapOvr>
+  <p:transition advClick="1"/>
+</p:sld>
+</file>
+
 <file path=ppt/slides/slide3.xml><?xml version="1.0" encoding="utf-8"?>
 <p:sld xmlns:a="http://schemas.openxmlformats.org/drawingml/2006/main" xmlns:r="http://schemas.openxmlformats.org/officeDocument/2006/relationships" xmlns:p="http://schemas.openxmlformats.org/presentationml/2006/main">
   <p:cSld>

</xml_diff>